<commit_message>
before reversing the order
</commit_message>
<xml_diff>
--- a/vignettes/figures/decision_tree.pptx
+++ b/vignettes/figures/decision_tree.pptx
@@ -5,16 +5,17 @@
     <p:sldMasterId id="2147483648" r:id="rId1"/>
   </p:sldMasterIdLst>
   <p:notesMasterIdLst>
-    <p:notesMasterId r:id="rId9"/>
+    <p:notesMasterId r:id="rId10"/>
   </p:notesMasterIdLst>
   <p:sldIdLst>
     <p:sldId id="269" r:id="rId2"/>
-    <p:sldId id="268" r:id="rId3"/>
-    <p:sldId id="270" r:id="rId4"/>
-    <p:sldId id="272" r:id="rId5"/>
-    <p:sldId id="271" r:id="rId6"/>
-    <p:sldId id="275" r:id="rId7"/>
-    <p:sldId id="274" r:id="rId8"/>
+    <p:sldId id="276" r:id="rId3"/>
+    <p:sldId id="268" r:id="rId4"/>
+    <p:sldId id="270" r:id="rId5"/>
+    <p:sldId id="272" r:id="rId6"/>
+    <p:sldId id="271" r:id="rId7"/>
+    <p:sldId id="275" r:id="rId8"/>
+    <p:sldId id="274" r:id="rId9"/>
   </p:sldIdLst>
   <p:sldSz cx="12192000" cy="6858000"/>
   <p:notesSz cx="6858000" cy="9144000"/>
@@ -135,7 +136,7 @@
 <file path=ppt/revisionInfo.xml><?xml version="1.0" encoding="utf-8"?>
 <p1510:revInfo xmlns:a="http://schemas.openxmlformats.org/drawingml/2006/main" xmlns:r="http://schemas.openxmlformats.org/officeDocument/2006/relationships" xmlns:p1510="http://schemas.microsoft.com/office/powerpoint/2015/10/main">
   <p1510:revLst>
-    <p1510:client id="{7974B000-A06F-7C40-91DD-D843A6B4800C}" v="124" dt="2026-08-05T15:03:01.512"/>
+    <p1510:client id="{D50A137B-1D76-E140-B528-34AC915B058D}" v="10" dt="2026-09-26T08:32:11.826"/>
   </p1510:revLst>
 </p1510:revInfo>
 </file>
@@ -145,189 +146,80 @@
   <pc:docChgLst>
     <pc:chgData name="Schilling Sabine HSLU W" userId="b0e2af5c-9187-4900-883a-c96514cd8e15" providerId="ADAL" clId="{5E51067F-94D7-505D-9735-0698788361AC}"/>
     <pc:docChg chg="undo custSel addSld delSld modSld sldOrd">
-      <pc:chgData name="Schilling Sabine HSLU W" userId="b0e2af5c-9187-4900-883a-c96514cd8e15" providerId="ADAL" clId="{5E51067F-94D7-505D-9735-0698788361AC}" dt="2026-08-10T21:32:42.712" v="2748" actId="20577"/>
+      <pc:chgData name="Schilling Sabine HSLU W" userId="b0e2af5c-9187-4900-883a-c96514cd8e15" providerId="ADAL" clId="{5E51067F-94D7-505D-9735-0698788361AC}" dt="2026-09-26T08:32:11.825" v="2765" actId="20577"/>
       <pc:docMkLst>
         <pc:docMk/>
       </pc:docMkLst>
-      <pc:sldChg chg="modSp mod ord">
-        <pc:chgData name="Schilling Sabine HSLU W" userId="b0e2af5c-9187-4900-883a-c96514cd8e15" providerId="ADAL" clId="{5E51067F-94D7-505D-9735-0698788361AC}" dt="2026-08-10T21:32:42.712" v="2748" actId="20577"/>
+      <pc:sldChg chg="modSp add mod">
+        <pc:chgData name="Schilling Sabine HSLU W" userId="b0e2af5c-9187-4900-883a-c96514cd8e15" providerId="ADAL" clId="{5E51067F-94D7-505D-9735-0698788361AC}" dt="2026-09-26T08:32:11.825" v="2765" actId="20577"/>
         <pc:sldMkLst>
           <pc:docMk/>
-          <pc:sldMk cId="2240045113" sldId="269"/>
+          <pc:sldMk cId="3004504650" sldId="276"/>
         </pc:sldMkLst>
         <pc:spChg chg="mod">
-          <ac:chgData name="Schilling Sabine HSLU W" userId="b0e2af5c-9187-4900-883a-c96514cd8e15" providerId="ADAL" clId="{5E51067F-94D7-505D-9735-0698788361AC}" dt="2026-08-10T21:32:42.712" v="2748" actId="20577"/>
+          <ac:chgData name="Schilling Sabine HSLU W" userId="b0e2af5c-9187-4900-883a-c96514cd8e15" providerId="ADAL" clId="{5E51067F-94D7-505D-9735-0698788361AC}" dt="2026-09-26T08:30:44.156" v="2752" actId="1076"/>
           <ac:spMkLst>
             <pc:docMk/>
-            <pc:sldMk cId="2240045113" sldId="269"/>
-            <ac:spMk id="94" creationId="{515D54C6-3B03-2E08-4597-56850FBD5013}"/>
-          </ac:spMkLst>
-        </pc:spChg>
-      </pc:sldChg>
-      <pc:sldChg chg="modSp add mod">
-        <pc:chgData name="Schilling Sabine HSLU W" userId="b0e2af5c-9187-4900-883a-c96514cd8e15" providerId="ADAL" clId="{5E51067F-94D7-505D-9735-0698788361AC}" dt="2026-08-02T14:48:45.693" v="2589" actId="20577"/>
-        <pc:sldMkLst>
-          <pc:docMk/>
-          <pc:sldMk cId="743801562" sldId="272"/>
-        </pc:sldMkLst>
-        <pc:spChg chg="mod">
-          <ac:chgData name="Schilling Sabine HSLU W" userId="b0e2af5c-9187-4900-883a-c96514cd8e15" providerId="ADAL" clId="{5E51067F-94D7-505D-9735-0698788361AC}" dt="2026-08-02T14:48:45.693" v="2589" actId="20577"/>
-          <ac:spMkLst>
-            <pc:docMk/>
-            <pc:sldMk cId="743801562" sldId="272"/>
-            <ac:spMk id="15" creationId="{DC387780-E244-9D6C-AFA4-2CE93658C461}"/>
-          </ac:spMkLst>
-        </pc:spChg>
-      </pc:sldChg>
-      <pc:sldChg chg="modSp add mod">
-        <pc:chgData name="Schilling Sabine HSLU W" userId="b0e2af5c-9187-4900-883a-c96514cd8e15" providerId="ADAL" clId="{5E51067F-94D7-505D-9735-0698788361AC}" dt="2026-08-05T15:03:17.474" v="2725" actId="14100"/>
-        <pc:sldMkLst>
-          <pc:docMk/>
-          <pc:sldMk cId="1872816070" sldId="274"/>
-        </pc:sldMkLst>
-        <pc:spChg chg="mod">
-          <ac:chgData name="Schilling Sabine HSLU W" userId="b0e2af5c-9187-4900-883a-c96514cd8e15" providerId="ADAL" clId="{5E51067F-94D7-505D-9735-0698788361AC}" dt="2026-08-05T15:02:13.753" v="2692" actId="108"/>
-          <ac:spMkLst>
-            <pc:docMk/>
-            <pc:sldMk cId="1872816070" sldId="274"/>
-            <ac:spMk id="10" creationId="{B4F88A01-6781-5904-A652-B12091D21F3E}"/>
+            <pc:sldMk cId="3004504650" sldId="276"/>
+            <ac:spMk id="10" creationId="{A4AF0122-CAF7-91B0-4C93-6BA6965E57EF}"/>
           </ac:spMkLst>
         </pc:spChg>
         <pc:spChg chg="mod">
-          <ac:chgData name="Schilling Sabine HSLU W" userId="b0e2af5c-9187-4900-883a-c96514cd8e15" providerId="ADAL" clId="{5E51067F-94D7-505D-9735-0698788361AC}" dt="2026-08-05T15:03:01.511" v="2710" actId="20577"/>
+          <ac:chgData name="Schilling Sabine HSLU W" userId="b0e2af5c-9187-4900-883a-c96514cd8e15" providerId="ADAL" clId="{5E51067F-94D7-505D-9735-0698788361AC}" dt="2026-09-26T08:30:48.890" v="2753" actId="1076"/>
           <ac:spMkLst>
             <pc:docMk/>
-            <pc:sldMk cId="1872816070" sldId="274"/>
-            <ac:spMk id="15" creationId="{D09C337C-5BD6-7695-1124-3B21663DC499}"/>
+            <pc:sldMk cId="3004504650" sldId="276"/>
+            <ac:spMk id="18" creationId="{76ECB997-322E-3DF5-701B-8889425A0492}"/>
           </ac:spMkLst>
         </pc:spChg>
         <pc:spChg chg="mod">
-          <ac:chgData name="Schilling Sabine HSLU W" userId="b0e2af5c-9187-4900-883a-c96514cd8e15" providerId="ADAL" clId="{5E51067F-94D7-505D-9735-0698788361AC}" dt="2026-08-05T14:55:13.535" v="2675" actId="554"/>
+          <ac:chgData name="Schilling Sabine HSLU W" userId="b0e2af5c-9187-4900-883a-c96514cd8e15" providerId="ADAL" clId="{5E51067F-94D7-505D-9735-0698788361AC}" dt="2026-09-26T08:31:55.908" v="2760" actId="20577"/>
           <ac:spMkLst>
             <pc:docMk/>
-            <pc:sldMk cId="1872816070" sldId="274"/>
-            <ac:spMk id="18" creationId="{A15FD95C-AD4A-3122-99F9-2334BE4468F1}"/>
+            <pc:sldMk cId="3004504650" sldId="276"/>
+            <ac:spMk id="82" creationId="{F7475914-D382-6494-980D-A3B982652630}"/>
           </ac:spMkLst>
         </pc:spChg>
         <pc:spChg chg="mod">
-          <ac:chgData name="Schilling Sabine HSLU W" userId="b0e2af5c-9187-4900-883a-c96514cd8e15" providerId="ADAL" clId="{5E51067F-94D7-505D-9735-0698788361AC}" dt="2026-08-05T15:03:01.511" v="2710" actId="20577"/>
+          <ac:chgData name="Schilling Sabine HSLU W" userId="b0e2af5c-9187-4900-883a-c96514cd8e15" providerId="ADAL" clId="{5E51067F-94D7-505D-9735-0698788361AC}" dt="2026-09-26T08:32:11.825" v="2765" actId="20577"/>
           <ac:spMkLst>
             <pc:docMk/>
-            <pc:sldMk cId="1872816070" sldId="274"/>
-            <ac:spMk id="25" creationId="{5CDF2517-3347-9596-58AB-BAEE6A600961}"/>
+            <pc:sldMk cId="3004504650" sldId="276"/>
+            <ac:spMk id="88" creationId="{D07BBD28-7148-001B-3324-F486B4507DBB}"/>
           </ac:spMkLst>
         </pc:spChg>
         <pc:spChg chg="mod">
-          <ac:chgData name="Schilling Sabine HSLU W" userId="b0e2af5c-9187-4900-883a-c96514cd8e15" providerId="ADAL" clId="{5E51067F-94D7-505D-9735-0698788361AC}" dt="2026-08-05T15:03:01.511" v="2710" actId="20577"/>
+          <ac:chgData name="Schilling Sabine HSLU W" userId="b0e2af5c-9187-4900-883a-c96514cd8e15" providerId="ADAL" clId="{5E51067F-94D7-505D-9735-0698788361AC}" dt="2026-09-26T08:31:42.039" v="2754" actId="1076"/>
           <ac:spMkLst>
             <pc:docMk/>
-            <pc:sldMk cId="1872816070" sldId="274"/>
-            <ac:spMk id="32" creationId="{8B02DC27-2AEE-33B8-2594-AC61927D4A00}"/>
+            <pc:sldMk cId="3004504650" sldId="276"/>
+            <ac:spMk id="159" creationId="{AA0A1C3C-4163-E16D-29EE-60474368D8B1}"/>
           </ac:spMkLst>
         </pc:spChg>
         <pc:spChg chg="mod">
-          <ac:chgData name="Schilling Sabine HSLU W" userId="b0e2af5c-9187-4900-883a-c96514cd8e15" providerId="ADAL" clId="{5E51067F-94D7-505D-9735-0698788361AC}" dt="2026-08-05T15:02:56.560" v="2709" actId="1035"/>
+          <ac:chgData name="Schilling Sabine HSLU W" userId="b0e2af5c-9187-4900-883a-c96514cd8e15" providerId="ADAL" clId="{5E51067F-94D7-505D-9735-0698788361AC}" dt="2026-09-26T08:30:38.105" v="2751" actId="1076"/>
           <ac:spMkLst>
             <pc:docMk/>
-            <pc:sldMk cId="1872816070" sldId="274"/>
-            <ac:spMk id="39" creationId="{4819F473-9D5A-BC07-B8A0-D41CA5863BCC}"/>
+            <pc:sldMk cId="3004504650" sldId="276"/>
+            <ac:spMk id="160" creationId="{3A214ACA-F729-3B66-9CB2-136F088EC50B}"/>
           </ac:spMkLst>
         </pc:spChg>
-        <pc:spChg chg="mod">
-          <ac:chgData name="Schilling Sabine HSLU W" userId="b0e2af5c-9187-4900-883a-c96514cd8e15" providerId="ADAL" clId="{5E51067F-94D7-505D-9735-0698788361AC}" dt="2026-08-05T15:03:01.511" v="2710" actId="20577"/>
-          <ac:spMkLst>
+        <pc:grpChg chg="mod">
+          <ac:chgData name="Schilling Sabine HSLU W" userId="b0e2af5c-9187-4900-883a-c96514cd8e15" providerId="ADAL" clId="{5E51067F-94D7-505D-9735-0698788361AC}" dt="2026-09-26T08:32:06.640" v="2762" actId="1076"/>
+          <ac:grpSpMkLst>
             <pc:docMk/>
-            <pc:sldMk cId="1872816070" sldId="274"/>
-            <ac:spMk id="50" creationId="{5845F1B0-FB11-6F50-1444-B7FD9BF745CE}"/>
-          </ac:spMkLst>
-        </pc:spChg>
-        <pc:spChg chg="mod">
-          <ac:chgData name="Schilling Sabine HSLU W" userId="b0e2af5c-9187-4900-883a-c96514cd8e15" providerId="ADAL" clId="{5E51067F-94D7-505D-9735-0698788361AC}" dt="2026-08-05T15:03:01.511" v="2710" actId="20577"/>
-          <ac:spMkLst>
-            <pc:docMk/>
-            <pc:sldMk cId="1872816070" sldId="274"/>
-            <ac:spMk id="88" creationId="{BB800D0D-A714-577C-D8EE-4FF5D816DE30}"/>
-          </ac:spMkLst>
-        </pc:spChg>
-        <pc:spChg chg="mod">
-          <ac:chgData name="Schilling Sabine HSLU W" userId="b0e2af5c-9187-4900-883a-c96514cd8e15" providerId="ADAL" clId="{5E51067F-94D7-505D-9735-0698788361AC}" dt="2026-08-05T15:03:01.511" v="2710" actId="20577"/>
-          <ac:spMkLst>
-            <pc:docMk/>
-            <pc:sldMk cId="1872816070" sldId="274"/>
-            <ac:spMk id="93" creationId="{551573E4-0F06-411F-FDE0-93795FB6E2ED}"/>
-          </ac:spMkLst>
-        </pc:spChg>
-        <pc:spChg chg="mod">
-          <ac:chgData name="Schilling Sabine HSLU W" userId="b0e2af5c-9187-4900-883a-c96514cd8e15" providerId="ADAL" clId="{5E51067F-94D7-505D-9735-0698788361AC}" dt="2026-08-05T15:03:01.511" v="2710" actId="20577"/>
-          <ac:spMkLst>
-            <pc:docMk/>
-            <pc:sldMk cId="1872816070" sldId="274"/>
-            <ac:spMk id="149" creationId="{E83C5C9D-B2D4-D6DE-9EF0-EC4AB483000F}"/>
-          </ac:spMkLst>
-        </pc:spChg>
-        <pc:spChg chg="mod">
-          <ac:chgData name="Schilling Sabine HSLU W" userId="b0e2af5c-9187-4900-883a-c96514cd8e15" providerId="ADAL" clId="{5E51067F-94D7-505D-9735-0698788361AC}" dt="2026-08-05T15:03:01.511" v="2710" actId="20577"/>
-          <ac:spMkLst>
-            <pc:docMk/>
-            <pc:sldMk cId="1872816070" sldId="274"/>
-            <ac:spMk id="159" creationId="{2B7F183B-1A00-439B-7A9F-31657A8190F9}"/>
-          </ac:spMkLst>
-        </pc:spChg>
-        <pc:spChg chg="mod">
-          <ac:chgData name="Schilling Sabine HSLU W" userId="b0e2af5c-9187-4900-883a-c96514cd8e15" providerId="ADAL" clId="{5E51067F-94D7-505D-9735-0698788361AC}" dt="2026-08-05T15:03:01.511" v="2710" actId="20577"/>
-          <ac:spMkLst>
-            <pc:docMk/>
-            <pc:sldMk cId="1872816070" sldId="274"/>
-            <ac:spMk id="160" creationId="{8254D93A-DCA5-6C72-47D6-22D0FB53A888}"/>
-          </ac:spMkLst>
-        </pc:spChg>
-        <pc:spChg chg="mod">
-          <ac:chgData name="Schilling Sabine HSLU W" userId="b0e2af5c-9187-4900-883a-c96514cd8e15" providerId="ADAL" clId="{5E51067F-94D7-505D-9735-0698788361AC}" dt="2026-08-05T15:03:01.511" v="2710" actId="20577"/>
-          <ac:spMkLst>
-            <pc:docMk/>
-            <pc:sldMk cId="1872816070" sldId="274"/>
-            <ac:spMk id="453" creationId="{0386FD2C-0360-5A4A-28D3-FA6CEB0E84F9}"/>
-          </ac:spMkLst>
-        </pc:spChg>
+            <pc:sldMk cId="3004504650" sldId="276"/>
+            <ac:grpSpMk id="5" creationId="{A0037538-D5F3-A17C-580E-0C836302DFF9}"/>
+          </ac:grpSpMkLst>
+        </pc:grpChg>
         <pc:cxnChg chg="mod">
-          <ac:chgData name="Schilling Sabine HSLU W" userId="b0e2af5c-9187-4900-883a-c96514cd8e15" providerId="ADAL" clId="{5E51067F-94D7-505D-9735-0698788361AC}" dt="2026-08-05T15:03:17.474" v="2725" actId="14100"/>
+          <ac:chgData name="Schilling Sabine HSLU W" userId="b0e2af5c-9187-4900-883a-c96514cd8e15" providerId="ADAL" clId="{5E51067F-94D7-505D-9735-0698788361AC}" dt="2026-09-26T08:30:48.890" v="2753" actId="1076"/>
           <ac:cxnSpMkLst>
             <pc:docMk/>
-            <pc:sldMk cId="1872816070" sldId="274"/>
-            <ac:cxnSpMk id="12" creationId="{C24D2140-54A2-5F39-0CD6-BD660F15E5F7}"/>
+            <pc:sldMk cId="3004504650" sldId="276"/>
+            <ac:cxnSpMk id="11" creationId="{3E3D73A8-70F2-3F30-8F8E-59464648DBD0}"/>
           </ac:cxnSpMkLst>
         </pc:cxnChg>
-        <pc:cxnChg chg="mod">
-          <ac:chgData name="Schilling Sabine HSLU W" userId="b0e2af5c-9187-4900-883a-c96514cd8e15" providerId="ADAL" clId="{5E51067F-94D7-505D-9735-0698788361AC}" dt="2026-08-05T15:02:50.862" v="2700" actId="1035"/>
-          <ac:cxnSpMkLst>
-            <pc:docMk/>
-            <pc:sldMk cId="1872816070" sldId="274"/>
-            <ac:cxnSpMk id="492" creationId="{8F1AB3DB-EB4F-135A-D1D0-A13DBF952EB8}"/>
-          </ac:cxnSpMkLst>
-        </pc:cxnChg>
-        <pc:cxnChg chg="mod">
-          <ac:chgData name="Schilling Sabine HSLU W" userId="b0e2af5c-9187-4900-883a-c96514cd8e15" providerId="ADAL" clId="{5E51067F-94D7-505D-9735-0698788361AC}" dt="2026-08-05T15:02:50.862" v="2700" actId="1035"/>
-          <ac:cxnSpMkLst>
-            <pc:docMk/>
-            <pc:sldMk cId="1872816070" sldId="274"/>
-            <ac:cxnSpMk id="493" creationId="{2AF0592A-8DCE-B774-86B0-827650A7C2F6}"/>
-          </ac:cxnSpMkLst>
-        </pc:cxnChg>
-      </pc:sldChg>
-      <pc:sldChg chg="modSp add mod ord">
-        <pc:chgData name="Schilling Sabine HSLU W" userId="b0e2af5c-9187-4900-883a-c96514cd8e15" providerId="ADAL" clId="{5E51067F-94D7-505D-9735-0698788361AC}" dt="2026-08-05T14:55:33.083" v="2676" actId="20578"/>
-        <pc:sldMkLst>
-          <pc:docMk/>
-          <pc:sldMk cId="3999169765" sldId="275"/>
-        </pc:sldMkLst>
-        <pc:spChg chg="mod">
-          <ac:chgData name="Schilling Sabine HSLU W" userId="b0e2af5c-9187-4900-883a-c96514cd8e15" providerId="ADAL" clId="{5E51067F-94D7-505D-9735-0698788361AC}" dt="2026-08-05T14:52:48.404" v="2624" actId="108"/>
-          <ac:spMkLst>
-            <pc:docMk/>
-            <pc:sldMk cId="3999169765" sldId="275"/>
-            <ac:spMk id="10" creationId="{B03173ED-707C-1290-E65D-F23E87BC947C}"/>
-          </ac:spMkLst>
-        </pc:spChg>
       </pc:sldChg>
     </pc:docChg>
   </pc:docChgLst>
@@ -416,7 +308,7 @@
           <a:p>
             <a:fld id="{0AECA108-3915-9043-8428-B4BE4472B821}" type="datetimeFigureOut">
               <a:rPr lang="de-DE" smtClean="0"/>
-              <a:t>10.08.26</a:t>
+              <a:t>26.09.26</a:t>
             </a:fld>
             <a:endParaRPr lang="de-DE"/>
           </a:p>
@@ -799,6 +691,114 @@
         <p:cNvPr id="1" name="">
           <a:extLst>
             <a:ext uri="{FF2B5EF4-FFF2-40B4-BE49-F238E27FC236}">
+              <a16:creationId xmlns:a16="http://schemas.microsoft.com/office/drawing/2014/main" id="{77A72522-CCFE-B282-4C03-F4F1FBAC3F84}"/>
+            </a:ext>
+          </a:extLst>
+        </p:cNvPr>
+        <p:cNvGrpSpPr/>
+        <p:nvPr/>
+      </p:nvGrpSpPr>
+      <p:grpSpPr>
+        <a:xfrm>
+          <a:off x="0" y="0"/>
+          <a:ext cx="0" cy="0"/>
+          <a:chOff x="0" y="0"/>
+          <a:chExt cx="0" cy="0"/>
+        </a:xfrm>
+      </p:grpSpPr>
+      <p:sp>
+        <p:nvSpPr>
+          <p:cNvPr id="2" name="Folienbildplatzhalter 1">
+            <a:extLst>
+              <a:ext uri="{FF2B5EF4-FFF2-40B4-BE49-F238E27FC236}">
+                <a16:creationId xmlns:a16="http://schemas.microsoft.com/office/drawing/2014/main" id="{5EC6C7B2-6190-E9AA-B3E7-763EC2123D4B}"/>
+              </a:ext>
+            </a:extLst>
+          </p:cNvPr>
+          <p:cNvSpPr>
+            <a:spLocks noGrp="1" noRot="1" noChangeAspect="1"/>
+          </p:cNvSpPr>
+          <p:nvPr>
+            <p:ph type="sldImg"/>
+          </p:nvPr>
+        </p:nvSpPr>
+        <p:spPr/>
+      </p:sp>
+      <p:sp>
+        <p:nvSpPr>
+          <p:cNvPr id="3" name="Notizenplatzhalter 2">
+            <a:extLst>
+              <a:ext uri="{FF2B5EF4-FFF2-40B4-BE49-F238E27FC236}">
+                <a16:creationId xmlns:a16="http://schemas.microsoft.com/office/drawing/2014/main" id="{ABDC8DA8-DA14-3AE7-BC44-DAFA28FAE944}"/>
+              </a:ext>
+            </a:extLst>
+          </p:cNvPr>
+          <p:cNvSpPr>
+            <a:spLocks noGrp="1"/>
+          </p:cNvSpPr>
+          <p:nvPr>
+            <p:ph type="body" idx="1"/>
+          </p:nvPr>
+        </p:nvSpPr>
+        <p:spPr/>
+        <p:txBody>
+          <a:bodyPr/>
+          <a:lstStyle/>
+          <a:p>
+            <a:endParaRPr lang="de-DE" dirty="0"/>
+          </a:p>
+        </p:txBody>
+      </p:sp>
+      <p:sp>
+        <p:nvSpPr>
+          <p:cNvPr id="4" name="Foliennummernplatzhalter 3">
+            <a:extLst>
+              <a:ext uri="{FF2B5EF4-FFF2-40B4-BE49-F238E27FC236}">
+                <a16:creationId xmlns:a16="http://schemas.microsoft.com/office/drawing/2014/main" id="{1B094936-CE1E-1912-45EB-E98CA25A451B}"/>
+              </a:ext>
+            </a:extLst>
+          </p:cNvPr>
+          <p:cNvSpPr>
+            <a:spLocks noGrp="1"/>
+          </p:cNvSpPr>
+          <p:nvPr>
+            <p:ph type="sldNum" sz="quarter" idx="5"/>
+          </p:nvPr>
+        </p:nvSpPr>
+        <p:spPr/>
+        <p:txBody>
+          <a:bodyPr/>
+          <a:lstStyle/>
+          <a:p>
+            <a:fld id="{67B21A6D-3249-074E-BBD6-BCFA95367850}" type="slidenum">
+              <a:rPr lang="de-DE" smtClean="0"/>
+              <a:t>2</a:t>
+            </a:fld>
+            <a:endParaRPr lang="de-DE"/>
+          </a:p>
+        </p:txBody>
+      </p:sp>
+    </p:spTree>
+    <p:extLst>
+      <p:ext uri="{BB962C8B-B14F-4D97-AF65-F5344CB8AC3E}">
+        <p14:creationId xmlns:p14="http://schemas.microsoft.com/office/powerpoint/2010/main" val="2854238360"/>
+      </p:ext>
+    </p:extLst>
+  </p:cSld>
+  <p:clrMapOvr>
+    <a:masterClrMapping/>
+  </p:clrMapOvr>
+</p:notes>
+</file>
+
+<file path=ppt/notesSlides/notesSlide3.xml><?xml version="1.0" encoding="utf-8"?>
+<p:notes xmlns:a="http://schemas.openxmlformats.org/drawingml/2006/main" xmlns:r="http://schemas.openxmlformats.org/officeDocument/2006/relationships" xmlns:p="http://schemas.openxmlformats.org/presentationml/2006/main">
+  <p:cSld>
+    <p:spTree>
+      <p:nvGrpSpPr>
+        <p:cNvPr id="1" name="">
+          <a:extLst>
+            <a:ext uri="{FF2B5EF4-FFF2-40B4-BE49-F238E27FC236}">
               <a16:creationId xmlns:a16="http://schemas.microsoft.com/office/drawing/2014/main" id="{FE81184C-C4BD-BB61-D66B-24B916B3F31E}"/>
             </a:ext>
           </a:extLst>
@@ -880,7 +880,7 @@
           <a:p>
             <a:fld id="{67B21A6D-3249-074E-BBD6-BCFA95367850}" type="slidenum">
               <a:rPr lang="de-DE" smtClean="0"/>
-              <a:t>2</a:t>
+              <a:t>3</a:t>
             </a:fld>
             <a:endParaRPr lang="de-DE"/>
           </a:p>
@@ -899,7 +899,7 @@
 </p:notes>
 </file>
 
-<file path=ppt/notesSlides/notesSlide3.xml><?xml version="1.0" encoding="utf-8"?>
+<file path=ppt/notesSlides/notesSlide4.xml><?xml version="1.0" encoding="utf-8"?>
 <p:notes xmlns:a="http://schemas.openxmlformats.org/drawingml/2006/main" xmlns:r="http://schemas.openxmlformats.org/officeDocument/2006/relationships" xmlns:p="http://schemas.openxmlformats.org/presentationml/2006/main">
   <p:cSld>
     <p:spTree>
@@ -988,7 +988,7 @@
           <a:p>
             <a:fld id="{67B21A6D-3249-074E-BBD6-BCFA95367850}" type="slidenum">
               <a:rPr lang="de-DE" smtClean="0"/>
-              <a:t>3</a:t>
+              <a:t>4</a:t>
             </a:fld>
             <a:endParaRPr lang="de-DE"/>
           </a:p>
@@ -1007,7 +1007,7 @@
 </p:notes>
 </file>
 
-<file path=ppt/notesSlides/notesSlide4.xml><?xml version="1.0" encoding="utf-8"?>
+<file path=ppt/notesSlides/notesSlide5.xml><?xml version="1.0" encoding="utf-8"?>
 <p:notes xmlns:a="http://schemas.openxmlformats.org/drawingml/2006/main" xmlns:r="http://schemas.openxmlformats.org/officeDocument/2006/relationships" xmlns:p="http://schemas.openxmlformats.org/presentationml/2006/main">
   <p:cSld>
     <p:spTree>
@@ -1096,7 +1096,7 @@
           <a:p>
             <a:fld id="{67B21A6D-3249-074E-BBD6-BCFA95367850}" type="slidenum">
               <a:rPr lang="de-DE" smtClean="0"/>
-              <a:t>4</a:t>
+              <a:t>5</a:t>
             </a:fld>
             <a:endParaRPr lang="de-DE"/>
           </a:p>
@@ -1115,7 +1115,7 @@
 </p:notes>
 </file>
 
-<file path=ppt/notesSlides/notesSlide5.xml><?xml version="1.0" encoding="utf-8"?>
+<file path=ppt/notesSlides/notesSlide6.xml><?xml version="1.0" encoding="utf-8"?>
 <p:notes xmlns:a="http://schemas.openxmlformats.org/drawingml/2006/main" xmlns:r="http://schemas.openxmlformats.org/officeDocument/2006/relationships" xmlns:p="http://schemas.openxmlformats.org/presentationml/2006/main">
   <p:cSld>
     <p:spTree>
@@ -1204,7 +1204,7 @@
           <a:p>
             <a:fld id="{67B21A6D-3249-074E-BBD6-BCFA95367850}" type="slidenum">
               <a:rPr lang="de-DE" smtClean="0"/>
-              <a:t>5</a:t>
+              <a:t>6</a:t>
             </a:fld>
             <a:endParaRPr lang="de-DE"/>
           </a:p>
@@ -1223,7 +1223,7 @@
 </p:notes>
 </file>
 
-<file path=ppt/notesSlides/notesSlide6.xml><?xml version="1.0" encoding="utf-8"?>
+<file path=ppt/notesSlides/notesSlide7.xml><?xml version="1.0" encoding="utf-8"?>
 <p:notes xmlns:a="http://schemas.openxmlformats.org/drawingml/2006/main" xmlns:r="http://schemas.openxmlformats.org/officeDocument/2006/relationships" xmlns:p="http://schemas.openxmlformats.org/presentationml/2006/main">
   <p:cSld>
     <p:spTree>
@@ -1312,7 +1312,7 @@
           <a:p>
             <a:fld id="{67B21A6D-3249-074E-BBD6-BCFA95367850}" type="slidenum">
               <a:rPr lang="de-DE" smtClean="0"/>
-              <a:t>6</a:t>
+              <a:t>7</a:t>
             </a:fld>
             <a:endParaRPr lang="de-DE"/>
           </a:p>
@@ -1331,7 +1331,7 @@
 </p:notes>
 </file>
 
-<file path=ppt/notesSlides/notesSlide7.xml><?xml version="1.0" encoding="utf-8"?>
+<file path=ppt/notesSlides/notesSlide8.xml><?xml version="1.0" encoding="utf-8"?>
 <p:notes xmlns:a="http://schemas.openxmlformats.org/drawingml/2006/main" xmlns:r="http://schemas.openxmlformats.org/officeDocument/2006/relationships" xmlns:p="http://schemas.openxmlformats.org/presentationml/2006/main">
   <p:cSld>
     <p:spTree>
@@ -1420,7 +1420,7 @@
           <a:p>
             <a:fld id="{67B21A6D-3249-074E-BBD6-BCFA95367850}" type="slidenum">
               <a:rPr lang="de-DE" smtClean="0"/>
-              <a:t>7</a:t>
+              <a:t>8</a:t>
             </a:fld>
             <a:endParaRPr lang="de-DE"/>
           </a:p>
@@ -1586,7 +1586,7 @@
           <a:p>
             <a:fld id="{43497422-92ED-3D47-BF28-17000E80E497}" type="datetimeFigureOut">
               <a:rPr lang="de-DE" smtClean="0"/>
-              <a:t>10.08.26</a:t>
+              <a:t>26.09.26</a:t>
             </a:fld>
             <a:endParaRPr lang="de-DE"/>
           </a:p>
@@ -1784,7 +1784,7 @@
           <a:p>
             <a:fld id="{43497422-92ED-3D47-BF28-17000E80E497}" type="datetimeFigureOut">
               <a:rPr lang="de-DE" smtClean="0"/>
-              <a:t>10.08.26</a:t>
+              <a:t>26.09.26</a:t>
             </a:fld>
             <a:endParaRPr lang="de-DE"/>
           </a:p>
@@ -1992,7 +1992,7 @@
           <a:p>
             <a:fld id="{43497422-92ED-3D47-BF28-17000E80E497}" type="datetimeFigureOut">
               <a:rPr lang="de-DE" smtClean="0"/>
-              <a:t>10.08.26</a:t>
+              <a:t>26.09.26</a:t>
             </a:fld>
             <a:endParaRPr lang="de-DE"/>
           </a:p>
@@ -2190,7 +2190,7 @@
           <a:p>
             <a:fld id="{43497422-92ED-3D47-BF28-17000E80E497}" type="datetimeFigureOut">
               <a:rPr lang="de-DE" smtClean="0"/>
-              <a:t>10.08.26</a:t>
+              <a:t>26.09.26</a:t>
             </a:fld>
             <a:endParaRPr lang="de-DE"/>
           </a:p>
@@ -2465,7 +2465,7 @@
           <a:p>
             <a:fld id="{43497422-92ED-3D47-BF28-17000E80E497}" type="datetimeFigureOut">
               <a:rPr lang="de-DE" smtClean="0"/>
-              <a:t>10.08.26</a:t>
+              <a:t>26.09.26</a:t>
             </a:fld>
             <a:endParaRPr lang="de-DE"/>
           </a:p>
@@ -2730,7 +2730,7 @@
           <a:p>
             <a:fld id="{43497422-92ED-3D47-BF28-17000E80E497}" type="datetimeFigureOut">
               <a:rPr lang="de-DE" smtClean="0"/>
-              <a:t>10.08.26</a:t>
+              <a:t>26.09.26</a:t>
             </a:fld>
             <a:endParaRPr lang="de-DE"/>
           </a:p>
@@ -3142,7 +3142,7 @@
           <a:p>
             <a:fld id="{43497422-92ED-3D47-BF28-17000E80E497}" type="datetimeFigureOut">
               <a:rPr lang="de-DE" smtClean="0"/>
-              <a:t>10.08.26</a:t>
+              <a:t>26.09.26</a:t>
             </a:fld>
             <a:endParaRPr lang="de-DE"/>
           </a:p>
@@ -3283,7 +3283,7 @@
           <a:p>
             <a:fld id="{43497422-92ED-3D47-BF28-17000E80E497}" type="datetimeFigureOut">
               <a:rPr lang="de-DE" smtClean="0"/>
-              <a:t>10.08.26</a:t>
+              <a:t>26.09.26</a:t>
             </a:fld>
             <a:endParaRPr lang="de-DE"/>
           </a:p>
@@ -3396,7 +3396,7 @@
           <a:p>
             <a:fld id="{43497422-92ED-3D47-BF28-17000E80E497}" type="datetimeFigureOut">
               <a:rPr lang="de-DE" smtClean="0"/>
-              <a:t>10.08.26</a:t>
+              <a:t>26.09.26</a:t>
             </a:fld>
             <a:endParaRPr lang="de-DE"/>
           </a:p>
@@ -3707,7 +3707,7 @@
           <a:p>
             <a:fld id="{43497422-92ED-3D47-BF28-17000E80E497}" type="datetimeFigureOut">
               <a:rPr lang="de-DE" smtClean="0"/>
-              <a:t>10.08.26</a:t>
+              <a:t>26.09.26</a:t>
             </a:fld>
             <a:endParaRPr lang="de-DE"/>
           </a:p>
@@ -3995,7 +3995,7 @@
           <a:p>
             <a:fld id="{43497422-92ED-3D47-BF28-17000E80E497}" type="datetimeFigureOut">
               <a:rPr lang="de-DE" smtClean="0"/>
-              <a:t>10.08.26</a:t>
+              <a:t>26.09.26</a:t>
             </a:fld>
             <a:endParaRPr lang="de-DE"/>
           </a:p>
@@ -4236,7 +4236,7 @@
           <a:p>
             <a:fld id="{43497422-92ED-3D47-BF28-17000E80E497}" type="datetimeFigureOut">
               <a:rPr lang="de-DE" smtClean="0"/>
-              <a:t>10.08.26</a:t>
+              <a:t>26.09.26</a:t>
             </a:fld>
             <a:endParaRPr lang="de-DE"/>
           </a:p>
@@ -8468,6 +8468,3837 @@
 </file>
 
 <file path=ppt/slides/slide2.xml><?xml version="1.0" encoding="utf-8"?>
+<p:sld xmlns:a="http://schemas.openxmlformats.org/drawingml/2006/main" xmlns:r="http://schemas.openxmlformats.org/officeDocument/2006/relationships" xmlns:p="http://schemas.openxmlformats.org/presentationml/2006/main">
+  <p:cSld>
+    <p:spTree>
+      <p:nvGrpSpPr>
+        <p:cNvPr id="1" name="">
+          <a:extLst>
+            <a:ext uri="{FF2B5EF4-FFF2-40B4-BE49-F238E27FC236}">
+              <a16:creationId xmlns:a16="http://schemas.microsoft.com/office/drawing/2014/main" id="{DF93A58F-A39D-BC3E-84FD-F2C68E434453}"/>
+            </a:ext>
+          </a:extLst>
+        </p:cNvPr>
+        <p:cNvGrpSpPr/>
+        <p:nvPr/>
+      </p:nvGrpSpPr>
+      <p:grpSpPr>
+        <a:xfrm>
+          <a:off x="0" y="0"/>
+          <a:ext cx="0" cy="0"/>
+          <a:chOff x="0" y="0"/>
+          <a:chExt cx="0" cy="0"/>
+        </a:xfrm>
+      </p:grpSpPr>
+      <p:grpSp>
+        <p:nvGrpSpPr>
+          <p:cNvPr id="5" name="Gruppieren 4">
+            <a:extLst>
+              <a:ext uri="{FF2B5EF4-FFF2-40B4-BE49-F238E27FC236}">
+                <a16:creationId xmlns:a16="http://schemas.microsoft.com/office/drawing/2014/main" id="{A0037538-D5F3-A17C-580E-0C836302DFF9}"/>
+              </a:ext>
+            </a:extLst>
+          </p:cNvPr>
+          <p:cNvGrpSpPr/>
+          <p:nvPr/>
+        </p:nvGrpSpPr>
+        <p:grpSpPr>
+          <a:xfrm>
+            <a:off x="377372" y="1472063"/>
+            <a:ext cx="12251028" cy="4946413"/>
+            <a:chOff x="168318" y="1153689"/>
+            <a:chExt cx="12251028" cy="4871133"/>
+          </a:xfrm>
+        </p:grpSpPr>
+        <p:grpSp>
+          <p:nvGrpSpPr>
+            <p:cNvPr id="9" name="Gruppieren 8">
+              <a:extLst>
+                <a:ext uri="{FF2B5EF4-FFF2-40B4-BE49-F238E27FC236}">
+                  <a16:creationId xmlns:a16="http://schemas.microsoft.com/office/drawing/2014/main" id="{C6BE41B2-E779-D5F1-E165-0FF3E8163AC8}"/>
+                </a:ext>
+              </a:extLst>
+            </p:cNvPr>
+            <p:cNvGrpSpPr/>
+            <p:nvPr/>
+          </p:nvGrpSpPr>
+          <p:grpSpPr>
+            <a:xfrm>
+              <a:off x="168318" y="1153689"/>
+              <a:ext cx="12251028" cy="4871133"/>
+              <a:chOff x="176103" y="1290852"/>
+              <a:chExt cx="12251028" cy="4871133"/>
+            </a:xfrm>
+          </p:grpSpPr>
+          <p:sp>
+            <p:nvSpPr>
+              <p:cNvPr id="18" name="Textfeld 17">
+                <a:extLst>
+                  <a:ext uri="{FF2B5EF4-FFF2-40B4-BE49-F238E27FC236}">
+                    <a16:creationId xmlns:a16="http://schemas.microsoft.com/office/drawing/2014/main" id="{76ECB997-322E-3DF5-701B-8889425A0492}"/>
+                  </a:ext>
+                </a:extLst>
+              </p:cNvPr>
+              <p:cNvSpPr txBox="1"/>
+              <p:nvPr/>
+            </p:nvSpPr>
+            <p:spPr>
+              <a:xfrm>
+                <a:off x="6011890" y="3470175"/>
+                <a:ext cx="2869601" cy="276999"/>
+              </a:xfrm>
+              <a:prstGeom prst="rect">
+                <a:avLst/>
+              </a:prstGeom>
+              <a:solidFill>
+                <a:schemeClr val="accent2">
+                  <a:alpha val="19906"/>
+                </a:schemeClr>
+              </a:solidFill>
+              <a:ln w="12700">
+                <a:solidFill>
+                  <a:schemeClr val="tx1"/>
+                </a:solidFill>
+              </a:ln>
+            </p:spPr>
+            <p:txBody>
+              <a:bodyPr wrap="square">
+                <a:spAutoFit/>
+              </a:bodyPr>
+              <a:lstStyle/>
+              <a:p>
+                <a:pPr algn="ctr"/>
+                <a:r>
+                  <a:rPr lang="en-GB" sz="1200" noProof="0" dirty="0" err="1">
+                    <a:latin typeface="Courier New" panose="02070309020205020404" pitchFamily="49" charset="0"/>
+                    <a:ea typeface="Cambria Math" panose="02040503050406030204" pitchFamily="18" charset="0"/>
+                    <a:cs typeface="Courier New" panose="02070309020205020404" pitchFamily="49" charset="0"/>
+                  </a:rPr>
+                  <a:t>shapiro.test</a:t>
+                </a:r>
+                <a:r>
+                  <a:rPr lang="en-GB" sz="1200" noProof="0" dirty="0">
+                    <a:latin typeface="Courier New" panose="02070309020205020404" pitchFamily="49" charset="0"/>
+                    <a:ea typeface="Cambria Math" panose="02040503050406030204" pitchFamily="18" charset="0"/>
+                    <a:cs typeface="Courier New" panose="02070309020205020404" pitchFamily="49" charset="0"/>
+                  </a:rPr>
+                  <a:t>()</a:t>
+                </a:r>
+                <a:r>
+                  <a:rPr lang="en-GB" sz="1200" noProof="0" dirty="0">
+                    <a:latin typeface="Calibri" panose="020F0502020204030204" pitchFamily="34" charset="0"/>
+                    <a:ea typeface="Cambria Math" panose="02040503050406030204" pitchFamily="18" charset="0"/>
+                    <a:cs typeface="Calibri" panose="020F0502020204030204" pitchFamily="34" charset="0"/>
+                  </a:rPr>
+                  <a:t> </a:t>
+                </a:r>
+                <a:r>
+                  <a:rPr lang="en-GB" sz="1200" dirty="0">
+                    <a:latin typeface="Calibri" panose="020F0502020204030204" pitchFamily="34" charset="0"/>
+                    <a:ea typeface="Cambria Math" panose="02040503050406030204" pitchFamily="18" charset="0"/>
+                    <a:cs typeface="Calibri" panose="020F0502020204030204" pitchFamily="34" charset="0"/>
+                  </a:rPr>
+                  <a:t>of residuals</a:t>
+                </a:r>
+                <a:endParaRPr lang="en-GB" sz="1200" noProof="0" dirty="0">
+                  <a:latin typeface="Calibri" panose="020F0502020204030204" pitchFamily="34" charset="0"/>
+                  <a:ea typeface="Cambria Math" panose="02040503050406030204" pitchFamily="18" charset="0"/>
+                  <a:cs typeface="Calibri" panose="020F0502020204030204" pitchFamily="34" charset="0"/>
+                </a:endParaRPr>
+              </a:p>
+            </p:txBody>
+          </p:sp>
+          <p:sp>
+            <p:nvSpPr>
+              <p:cNvPr id="160" name="Textfeld 159">
+                <a:extLst>
+                  <a:ext uri="{FF2B5EF4-FFF2-40B4-BE49-F238E27FC236}">
+                    <a16:creationId xmlns:a16="http://schemas.microsoft.com/office/drawing/2014/main" id="{3A214ACA-F729-3B66-9CB2-136F088EC50B}"/>
+                  </a:ext>
+                </a:extLst>
+              </p:cNvPr>
+              <p:cNvSpPr txBox="1"/>
+              <p:nvPr/>
+            </p:nvSpPr>
+            <p:spPr>
+              <a:xfrm>
+                <a:off x="10692159" y="3843171"/>
+                <a:ext cx="1734970" cy="276999"/>
+              </a:xfrm>
+              <a:prstGeom prst="rect">
+                <a:avLst/>
+              </a:prstGeom>
+              <a:solidFill>
+                <a:schemeClr val="accent2">
+                  <a:lumMod val="20000"/>
+                  <a:lumOff val="80000"/>
+                </a:schemeClr>
+              </a:solidFill>
+              <a:ln w="12700">
+                <a:solidFill>
+                  <a:schemeClr val="accent1">
+                    <a:lumMod val="20000"/>
+                    <a:lumOff val="80000"/>
+                  </a:schemeClr>
+                </a:solidFill>
+              </a:ln>
+            </p:spPr>
+            <p:txBody>
+              <a:bodyPr wrap="square">
+                <a:spAutoFit/>
+              </a:bodyPr>
+              <a:lstStyle>
+                <a:defPPr>
+                  <a:defRPr lang="de-DE"/>
+                </a:defPPr>
+                <a:lvl1pPr algn="ctr">
+                  <a:defRPr sz="1200"/>
+                </a:lvl1pPr>
+              </a:lstStyle>
+              <a:p>
+                <a:r>
+                  <a:rPr lang="en-GB" noProof="0" dirty="0">
+                    <a:latin typeface="Calibri" panose="020F0502020204030204" pitchFamily="34" charset="0"/>
+                    <a:ea typeface="Cambria Math" panose="02040503050406030204" pitchFamily="18" charset="0"/>
+                    <a:cs typeface="Calibri" panose="020F0502020204030204" pitchFamily="34" charset="0"/>
+                  </a:rPr>
+                  <a:t>Check normality</a:t>
+                </a:r>
+              </a:p>
+            </p:txBody>
+          </p:sp>
+          <mc:AlternateContent xmlns:mc="http://schemas.openxmlformats.org/markup-compatibility/2006" xmlns:a14="http://schemas.microsoft.com/office/drawing/2010/main">
+            <mc:Choice Requires="a14">
+              <p:sp>
+                <p:nvSpPr>
+                  <p:cNvPr id="7" name="Textfeld 6">
+                    <a:extLst>
+                      <a:ext uri="{FF2B5EF4-FFF2-40B4-BE49-F238E27FC236}">
+                        <a16:creationId xmlns:a16="http://schemas.microsoft.com/office/drawing/2014/main" id="{BEB68CDB-9F71-E1D5-3E30-8C249752B64F}"/>
+                      </a:ext>
+                    </a:extLst>
+                  </p:cNvPr>
+                  <p:cNvSpPr txBox="1"/>
+                  <p:nvPr/>
+                </p:nvSpPr>
+                <p:spPr>
+                  <a:xfrm>
+                    <a:off x="3476487" y="1290852"/>
+                    <a:ext cx="5594111" cy="461665"/>
+                  </a:xfrm>
+                  <a:prstGeom prst="rect">
+                    <a:avLst/>
+                  </a:prstGeom>
+                  <a:solidFill>
+                    <a:schemeClr val="bg1">
+                      <a:lumMod val="85000"/>
+                    </a:schemeClr>
+                  </a:solidFill>
+                  <a:ln w="6350">
+                    <a:solidFill>
+                      <a:schemeClr val="bg1">
+                        <a:lumMod val="85000"/>
+                      </a:schemeClr>
+                    </a:solidFill>
+                  </a:ln>
+                </p:spPr>
+                <p:txBody>
+                  <a:bodyPr wrap="square">
+                    <a:spAutoFit/>
+                  </a:bodyPr>
+                  <a:lstStyle/>
+                  <a:p>
+                    <a:pPr marL="174625" indent="-174625">
+                      <a:buFont typeface="Arial" panose="020B0604020202020204" pitchFamily="34" charset="0"/>
+                      <a:buChar char="•"/>
+                    </a:pPr>
+                    <a:r>
+                      <a:rPr lang="en-GB" sz="1200" dirty="0">
+                        <a:latin typeface="Calibri" panose="020F0502020204030204" pitchFamily="34" charset="0"/>
+                        <a:ea typeface="Cambria Math" panose="02040503050406030204" pitchFamily="18" charset="0"/>
+                        <a:cs typeface="Calibri" panose="020F0502020204030204" pitchFamily="34" charset="0"/>
+                      </a:rPr>
+                      <a:t>C</a:t>
+                    </a:r>
+                    <a:r>
+                      <a:rPr lang="en-GB" sz="1200" noProof="0" dirty="0" err="1">
+                        <a:latin typeface="Calibri" panose="020F0502020204030204" pitchFamily="34" charset="0"/>
+                        <a:ea typeface="Cambria Math" panose="02040503050406030204" pitchFamily="18" charset="0"/>
+                        <a:cs typeface="Calibri" panose="020F0502020204030204" pitchFamily="34" charset="0"/>
+                      </a:rPr>
+                      <a:t>ategorical</a:t>
+                    </a:r>
+                    <a:r>
+                      <a:rPr lang="en-GB" sz="1200" noProof="0" dirty="0">
+                        <a:latin typeface="Calibri" panose="020F0502020204030204" pitchFamily="34" charset="0"/>
+                        <a:ea typeface="Cambria Math" panose="02040503050406030204" pitchFamily="18" charset="0"/>
+                        <a:cs typeface="Calibri" panose="020F0502020204030204" pitchFamily="34" charset="0"/>
+                      </a:rPr>
+                      <a:t> predictor of </a:t>
+                    </a:r>
+                    <a:r>
+                      <a:rPr lang="en-GB" sz="1200" noProof="0" dirty="0">
+                        <a:latin typeface="Courier New" panose="02070309020205020404" pitchFamily="49" charset="0"/>
+                        <a:ea typeface="Cambria Math" panose="02040503050406030204" pitchFamily="18" charset="0"/>
+                        <a:cs typeface="Courier New" panose="02070309020205020404" pitchFamily="49" charset="0"/>
+                      </a:rPr>
+                      <a:t>class </a:t>
+                    </a:r>
+                    <a:r>
+                      <a:rPr lang="en-GB" sz="1200" dirty="0">
+                        <a:latin typeface="Calibri" panose="020F0502020204030204" pitchFamily="34" charset="0"/>
+                        <a:ea typeface="Cambria Math" panose="02040503050406030204" pitchFamily="18" charset="0"/>
+                        <a:cs typeface="Calibri" panose="020F0502020204030204" pitchFamily="34" charset="0"/>
+                      </a:rPr>
+                      <a:t>“</a:t>
+                    </a:r>
+                    <a:r>
+                      <a:rPr lang="en-GB" sz="1200" dirty="0">
+                        <a:latin typeface="Courier New" panose="02070309020205020404" pitchFamily="49" charset="0"/>
+                        <a:ea typeface="Cambria Math" panose="02040503050406030204" pitchFamily="18" charset="0"/>
+                        <a:cs typeface="Courier New" panose="02070309020205020404" pitchFamily="49" charset="0"/>
+                      </a:rPr>
+                      <a:t>factor</a:t>
+                    </a:r>
+                    <a:r>
+                      <a:rPr lang="en-GB" sz="1200" noProof="0" dirty="0">
+                        <a:latin typeface="Calibri" panose="020F0502020204030204" pitchFamily="34" charset="0"/>
+                        <a:ea typeface="Cambria Math" panose="02040503050406030204" pitchFamily="18" charset="0"/>
+                        <a:cs typeface="Calibri" panose="020F0502020204030204" pitchFamily="34" charset="0"/>
+                      </a:rPr>
+                      <a:t>“  with </a:t>
+                    </a:r>
+                    <a14:m>
+                      <m:oMath xmlns:m="http://schemas.openxmlformats.org/officeDocument/2006/math">
+                        <m:r>
+                          <a:rPr lang="en-US" sz="1200" b="0" i="1" noProof="0" smtClean="0">
+                            <a:latin typeface="Cambria Math" panose="02040503050406030204" pitchFamily="18" charset="0"/>
+                            <a:ea typeface="Cambria Math" panose="02040503050406030204" pitchFamily="18" charset="0"/>
+                            <a:cs typeface="Calibri" panose="020F0502020204030204" pitchFamily="34" charset="0"/>
+                          </a:rPr>
+                          <m:t>𝑘</m:t>
+                        </m:r>
+                        <m:r>
+                          <a:rPr lang="en-US" sz="1200" b="0" i="1" noProof="0" smtClean="0">
+                            <a:latin typeface="Cambria Math" panose="02040503050406030204" pitchFamily="18" charset="0"/>
+                            <a:ea typeface="Cambria Math" panose="02040503050406030204" pitchFamily="18" charset="0"/>
+                            <a:cs typeface="Calibri" panose="020F0502020204030204" pitchFamily="34" charset="0"/>
+                          </a:rPr>
+                          <m:t> </m:t>
+                        </m:r>
+                      </m:oMath>
+                    </a14:m>
+                    <a:r>
+                      <a:rPr lang="en-GB" sz="1200" noProof="0" dirty="0">
+                        <a:latin typeface="Calibri" panose="020F0502020204030204" pitchFamily="34" charset="0"/>
+                        <a:ea typeface="Cambria Math" panose="02040503050406030204" pitchFamily="18" charset="0"/>
+                        <a:cs typeface="Calibri" panose="020F0502020204030204" pitchFamily="34" charset="0"/>
+                      </a:rPr>
+                      <a:t>levels</a:t>
+                    </a:r>
+                  </a:p>
+                  <a:p>
+                    <a:pPr marL="171450" indent="-171450">
+                      <a:buFont typeface="Arial" panose="020B0604020202020204" pitchFamily="34" charset="0"/>
+                      <a:buChar char="•"/>
+                    </a:pPr>
+                    <a:r>
+                      <a:rPr lang="en-GB" sz="1200" dirty="0">
+                        <a:latin typeface="Calibri" panose="020F0502020204030204" pitchFamily="34" charset="0"/>
+                        <a:ea typeface="Cambria Math" panose="02040503050406030204" pitchFamily="18" charset="0"/>
+                        <a:cs typeface="Calibri" panose="020F0502020204030204" pitchFamily="34" charset="0"/>
+                      </a:rPr>
+                      <a:t>N</a:t>
+                    </a:r>
+                    <a:r>
+                      <a:rPr lang="en-GB" sz="1200" noProof="0" dirty="0">
+                        <a:latin typeface="Calibri" panose="020F0502020204030204" pitchFamily="34" charset="0"/>
+                        <a:ea typeface="Cambria Math" panose="02040503050406030204" pitchFamily="18" charset="0"/>
+                        <a:cs typeface="Calibri" panose="020F0502020204030204" pitchFamily="34" charset="0"/>
+                      </a:rPr>
+                      <a:t>umeric response of </a:t>
+                    </a:r>
+                    <a:r>
+                      <a:rPr lang="en-GB" sz="1200" noProof="0" dirty="0">
+                        <a:latin typeface="Courier New" panose="02070309020205020404" pitchFamily="49" charset="0"/>
+                        <a:ea typeface="Cambria Math" panose="02040503050406030204" pitchFamily="18" charset="0"/>
+                        <a:cs typeface="Courier New" panose="02070309020205020404" pitchFamily="49" charset="0"/>
+                      </a:rPr>
+                      <a:t>class </a:t>
+                    </a:r>
+                    <a:r>
+                      <a:rPr lang="en-GB" sz="1200" dirty="0">
+                        <a:latin typeface="Calibri" panose="020F0502020204030204" pitchFamily="34" charset="0"/>
+                        <a:ea typeface="Cambria Math" panose="02040503050406030204" pitchFamily="18" charset="0"/>
+                        <a:cs typeface="Calibri" panose="020F0502020204030204" pitchFamily="34" charset="0"/>
+                      </a:rPr>
+                      <a:t>“</a:t>
+                    </a:r>
+                    <a:r>
+                      <a:rPr lang="en-GB" sz="1200" noProof="0" dirty="0">
+                        <a:latin typeface="Courier New" panose="02070309020205020404" pitchFamily="49" charset="0"/>
+                        <a:ea typeface="Cambria Math" panose="02040503050406030204" pitchFamily="18" charset="0"/>
+                        <a:cs typeface="Courier New" panose="02070309020205020404" pitchFamily="49" charset="0"/>
+                      </a:rPr>
+                      <a:t>numeric</a:t>
+                    </a:r>
+                    <a:r>
+                      <a:rPr lang="en-GB" sz="1200" dirty="0">
+                        <a:latin typeface="Calibri" panose="020F0502020204030204" pitchFamily="34" charset="0"/>
+                        <a:ea typeface="Cambria Math" panose="02040503050406030204" pitchFamily="18" charset="0"/>
+                        <a:cs typeface="Calibri" panose="020F0502020204030204" pitchFamily="34" charset="0"/>
+                      </a:rPr>
+                      <a:t>”</a:t>
+                    </a:r>
+                    <a:r>
+                      <a:rPr lang="en-GB" sz="1200" dirty="0">
+                        <a:latin typeface="Courier New" panose="02070309020205020404" pitchFamily="49" charset="0"/>
+                        <a:ea typeface="Cambria Math" panose="02040503050406030204" pitchFamily="18" charset="0"/>
+                        <a:cs typeface="Courier New" panose="02070309020205020404" pitchFamily="49" charset="0"/>
+                      </a:rPr>
+                      <a:t> </a:t>
+                    </a:r>
+                    <a:r>
+                      <a:rPr lang="en-GB" sz="1200" noProof="0" dirty="0">
+                        <a:latin typeface="Calibri" panose="020F0502020204030204" pitchFamily="34" charset="0"/>
+                        <a:ea typeface="Cambria Math" panose="02040503050406030204" pitchFamily="18" charset="0"/>
+                        <a:cs typeface="Calibri" panose="020F0502020204030204" pitchFamily="34" charset="0"/>
+                      </a:rPr>
+                      <a:t>or “</a:t>
+                    </a:r>
+                    <a:r>
+                      <a:rPr lang="en-GB" sz="1200" noProof="0" dirty="0">
+                        <a:latin typeface="Courier New" panose="02070309020205020404" pitchFamily="49" charset="0"/>
+                        <a:ea typeface="Cambria Math" panose="02040503050406030204" pitchFamily="18" charset="0"/>
+                        <a:cs typeface="Courier New" panose="02070309020205020404" pitchFamily="49" charset="0"/>
+                      </a:rPr>
+                      <a:t>integer</a:t>
+                    </a:r>
+                    <a:r>
+                      <a:rPr lang="en-GB" sz="1200" dirty="0">
+                        <a:latin typeface="Calibri" panose="020F0502020204030204" pitchFamily="34" charset="0"/>
+                        <a:ea typeface="Cambria Math" panose="02040503050406030204" pitchFamily="18" charset="0"/>
+                        <a:cs typeface="Calibri" panose="020F0502020204030204" pitchFamily="34" charset="0"/>
+                      </a:rPr>
+                      <a:t>”</a:t>
+                    </a:r>
+                    <a:endParaRPr lang="en-GB" sz="1200" noProof="0" dirty="0">
+                      <a:latin typeface="Calibri" panose="020F0502020204030204" pitchFamily="34" charset="0"/>
+                      <a:ea typeface="Cambria Math" panose="02040503050406030204" pitchFamily="18" charset="0"/>
+                      <a:cs typeface="Calibri" panose="020F0502020204030204" pitchFamily="34" charset="0"/>
+                    </a:endParaRPr>
+                  </a:p>
+                </p:txBody>
+              </p:sp>
+            </mc:Choice>
+            <mc:Fallback xmlns="">
+              <p:sp>
+                <p:nvSpPr>
+                  <p:cNvPr id="7" name="Textfeld 6">
+                    <a:extLst>
+                      <a:ext uri="{FF2B5EF4-FFF2-40B4-BE49-F238E27FC236}">
+                        <a16:creationId xmlns:a16="http://schemas.microsoft.com/office/drawing/2014/main" id="{1DDAB994-3452-8483-B270-D28711166710}"/>
+                      </a:ext>
+                    </a:extLst>
+                  </p:cNvPr>
+                  <p:cNvSpPr txBox="1">
+                    <a:spLocks noRot="1" noChangeAspect="1" noMove="1" noResize="1" noEditPoints="1" noAdjustHandles="1" noChangeArrowheads="1" noChangeShapeType="1" noTextEdit="1"/>
+                  </p:cNvSpPr>
+                  <p:nvPr/>
+                </p:nvSpPr>
+                <p:spPr>
+                  <a:xfrm>
+                    <a:off x="3476487" y="1290852"/>
+                    <a:ext cx="5594111" cy="461665"/>
+                  </a:xfrm>
+                  <a:prstGeom prst="rect">
+                    <a:avLst/>
+                  </a:prstGeom>
+                  <a:blipFill>
+                    <a:blip r:embed="rId3"/>
+                    <a:stretch>
+                      <a:fillRect t="-2703" b="-8108"/>
+                    </a:stretch>
+                  </a:blipFill>
+                  <a:ln w="6350">
+                    <a:solidFill>
+                      <a:schemeClr val="bg1">
+                        <a:lumMod val="85000"/>
+                      </a:schemeClr>
+                    </a:solidFill>
+                  </a:ln>
+                </p:spPr>
+                <p:txBody>
+                  <a:bodyPr/>
+                  <a:lstStyle/>
+                  <a:p>
+                    <a:r>
+                      <a:rPr lang="de-DE">
+                        <a:noFill/>
+                      </a:rPr>
+                      <a:t> </a:t>
+                    </a:r>
+                  </a:p>
+                </p:txBody>
+              </p:sp>
+            </mc:Fallback>
+          </mc:AlternateContent>
+          <p:sp>
+            <p:nvSpPr>
+              <p:cNvPr id="23" name="Textfeld 22">
+                <a:extLst>
+                  <a:ext uri="{FF2B5EF4-FFF2-40B4-BE49-F238E27FC236}">
+                    <a16:creationId xmlns:a16="http://schemas.microsoft.com/office/drawing/2014/main" id="{46D9F945-C527-3E04-B6C0-A139015C6D51}"/>
+                  </a:ext>
+                </a:extLst>
+              </p:cNvPr>
+              <p:cNvSpPr txBox="1"/>
+              <p:nvPr/>
+            </p:nvSpPr>
+            <p:spPr>
+              <a:xfrm>
+                <a:off x="306876" y="5348377"/>
+                <a:ext cx="1455624" cy="276999"/>
+              </a:xfrm>
+              <a:prstGeom prst="rect">
+                <a:avLst/>
+              </a:prstGeom>
+              <a:solidFill>
+                <a:schemeClr val="accent1">
+                  <a:lumMod val="40000"/>
+                  <a:lumOff val="60000"/>
+                </a:schemeClr>
+              </a:solidFill>
+              <a:ln w="12700">
+                <a:solidFill>
+                  <a:schemeClr val="tx1"/>
+                </a:solidFill>
+              </a:ln>
+            </p:spPr>
+            <p:txBody>
+              <a:bodyPr wrap="square">
+                <a:spAutoFit/>
+              </a:bodyPr>
+              <a:lstStyle>
+                <a:defPPr>
+                  <a:defRPr lang="de-DE"/>
+                </a:defPPr>
+                <a:lvl1pPr algn="ctr">
+                  <a:defRPr sz="1200"/>
+                </a:lvl1pPr>
+              </a:lstStyle>
+              <a:p>
+                <a:r>
+                  <a:rPr lang="en-GB" noProof="0" dirty="0" err="1">
+                    <a:latin typeface="Courier New" panose="02070309020205020404" pitchFamily="49" charset="0"/>
+                    <a:ea typeface="Cambria Math" panose="02040503050406030204" pitchFamily="18" charset="0"/>
+                    <a:cs typeface="Courier New" panose="02070309020205020404" pitchFamily="49" charset="0"/>
+                  </a:rPr>
+                  <a:t>wilcox.test</a:t>
+                </a:r>
+                <a:r>
+                  <a:rPr lang="en-GB" noProof="0" dirty="0">
+                    <a:latin typeface="Courier New" panose="02070309020205020404" pitchFamily="49" charset="0"/>
+                    <a:ea typeface="Cambria Math" panose="02040503050406030204" pitchFamily="18" charset="0"/>
+                    <a:cs typeface="Courier New" panose="02070309020205020404" pitchFamily="49" charset="0"/>
+                  </a:rPr>
+                  <a:t>()</a:t>
+                </a:r>
+              </a:p>
+            </p:txBody>
+          </p:sp>
+          <p:sp>
+            <p:nvSpPr>
+              <p:cNvPr id="27" name="Textfeld 26">
+                <a:extLst>
+                  <a:ext uri="{FF2B5EF4-FFF2-40B4-BE49-F238E27FC236}">
+                    <a16:creationId xmlns:a16="http://schemas.microsoft.com/office/drawing/2014/main" id="{58DD2482-92EA-84D2-8C27-3EE24782B4DB}"/>
+                  </a:ext>
+                </a:extLst>
+              </p:cNvPr>
+              <p:cNvSpPr txBox="1"/>
+              <p:nvPr/>
+            </p:nvSpPr>
+            <p:spPr>
+              <a:xfrm>
+                <a:off x="1822802" y="5348377"/>
+                <a:ext cx="2352360" cy="276999"/>
+              </a:xfrm>
+              <a:prstGeom prst="rect">
+                <a:avLst/>
+              </a:prstGeom>
+              <a:solidFill>
+                <a:schemeClr val="accent1">
+                  <a:lumMod val="40000"/>
+                  <a:lumOff val="60000"/>
+                </a:schemeClr>
+              </a:solidFill>
+              <a:ln w="12700">
+                <a:solidFill>
+                  <a:schemeClr val="accent1">
+                    <a:lumMod val="40000"/>
+                    <a:lumOff val="60000"/>
+                  </a:schemeClr>
+                </a:solidFill>
+              </a:ln>
+            </p:spPr>
+            <p:txBody>
+              <a:bodyPr wrap="square">
+                <a:spAutoFit/>
+              </a:bodyPr>
+              <a:lstStyle>
+                <a:defPPr>
+                  <a:defRPr lang="de-DE"/>
+                </a:defPPr>
+                <a:lvl1pPr algn="ctr">
+                  <a:defRPr sz="1200"/>
+                </a:lvl1pPr>
+              </a:lstStyle>
+              <a:p>
+                <a:r>
+                  <a:rPr lang="en-GB" noProof="0" dirty="0" err="1">
+                    <a:latin typeface="Courier New" panose="02070309020205020404" pitchFamily="49" charset="0"/>
+                    <a:ea typeface="Cambria Math" panose="02040503050406030204" pitchFamily="18" charset="0"/>
+                    <a:cs typeface="Courier New" panose="02070309020205020404" pitchFamily="49" charset="0"/>
+                  </a:rPr>
+                  <a:t>kruskal.test</a:t>
+                </a:r>
+                <a:r>
+                  <a:rPr lang="en-GB" noProof="0" dirty="0">
+                    <a:latin typeface="Courier New" panose="02070309020205020404" pitchFamily="49" charset="0"/>
+                    <a:ea typeface="Cambria Math" panose="02040503050406030204" pitchFamily="18" charset="0"/>
+                    <a:cs typeface="Courier New" panose="02070309020205020404" pitchFamily="49" charset="0"/>
+                  </a:rPr>
+                  <a:t>()</a:t>
+                </a:r>
+              </a:p>
+            </p:txBody>
+          </p:sp>
+          <mc:AlternateContent xmlns:mc="http://schemas.openxmlformats.org/markup-compatibility/2006" xmlns:a14="http://schemas.microsoft.com/office/drawing/2010/main">
+            <mc:Choice Requires="a14">
+              <p:sp>
+                <p:nvSpPr>
+                  <p:cNvPr id="29" name="Textfeld 28">
+                    <a:extLst>
+                      <a:ext uri="{FF2B5EF4-FFF2-40B4-BE49-F238E27FC236}">
+                        <a16:creationId xmlns:a16="http://schemas.microsoft.com/office/drawing/2014/main" id="{73CDF756-EB46-7364-6230-5D95224216D2}"/>
+                      </a:ext>
+                    </a:extLst>
+                  </p:cNvPr>
+                  <p:cNvSpPr txBox="1"/>
+                  <p:nvPr/>
+                </p:nvSpPr>
+                <p:spPr>
+                  <a:xfrm>
+                    <a:off x="8165541" y="4453323"/>
+                    <a:ext cx="1086431" cy="277200"/>
+                  </a:xfrm>
+                  <a:prstGeom prst="rect">
+                    <a:avLst/>
+                  </a:prstGeom>
+                  <a:noFill/>
+                  <a:ln w="12700">
+                    <a:noFill/>
+                  </a:ln>
+                </p:spPr>
+                <p:txBody>
+                  <a:bodyPr wrap="square">
+                    <a:spAutoFit/>
+                  </a:bodyPr>
+                  <a:lstStyle/>
+                  <a:p>
+                    <a:pPr algn="ctr"/>
+                    <a14:m>
+                      <m:oMath xmlns:m="http://schemas.openxmlformats.org/officeDocument/2006/math">
+                        <m:r>
+                          <a:rPr lang="en-GB" sz="1200" b="0" i="1" noProof="0" smtClean="0">
+                            <a:latin typeface="Cambria Math" panose="02040503050406030204" pitchFamily="18" charset="0"/>
+                            <a:ea typeface="Cambria Math" panose="02040503050406030204" pitchFamily="18" charset="0"/>
+                          </a:rPr>
+                          <m:t>𝑝</m:t>
+                        </m:r>
+                        <m:r>
+                          <a:rPr lang="en-US" sz="1200" b="0" i="1" baseline="-25000" noProof="0" smtClean="0">
+                            <a:latin typeface="Cambria Math" panose="02040503050406030204" pitchFamily="18" charset="0"/>
+                            <a:ea typeface="Cambria Math" panose="02040503050406030204" pitchFamily="18" charset="0"/>
+                          </a:rPr>
+                          <m:t>𝐿</m:t>
+                        </m:r>
+                        <m:r>
+                          <a:rPr lang="en-US" sz="1200" b="0" i="1" smtClean="0">
+                            <a:latin typeface="Cambria Math" panose="02040503050406030204" pitchFamily="18" charset="0"/>
+                            <a:ea typeface="Cambria Math" panose="02040503050406030204" pitchFamily="18" charset="0"/>
+                          </a:rPr>
+                          <m:t>≥</m:t>
+                        </m:r>
+                      </m:oMath>
+                    </a14:m>
+                    <a:r>
+                      <a:rPr lang="en-GB" sz="1200" noProof="0" dirty="0">
+                        <a:latin typeface="Calibri" panose="020F0502020204030204" pitchFamily="34" charset="0"/>
+                        <a:ea typeface="Cambria Math" panose="02040503050406030204" pitchFamily="18" charset="0"/>
+                        <a:cs typeface="Calibri" panose="020F0502020204030204" pitchFamily="34" charset="0"/>
+                      </a:rPr>
+                      <a:t> </a:t>
+                    </a:r>
+                    <a14:m>
+                      <m:oMath xmlns:m="http://schemas.openxmlformats.org/officeDocument/2006/math">
+                        <m:r>
+                          <a:rPr lang="en-GB" sz="1200" i="1">
+                            <a:latin typeface="Cambria Math" panose="02040503050406030204" pitchFamily="18" charset="0"/>
+                            <a:ea typeface="Cambria Math" panose="02040503050406030204" pitchFamily="18" charset="0"/>
+                          </a:rPr>
+                          <m:t>𝛼</m:t>
+                        </m:r>
+                      </m:oMath>
+                    </a14:m>
+                    <a:endParaRPr lang="en-GB" sz="1200" noProof="0" dirty="0">
+                      <a:latin typeface="Calibri" panose="020F0502020204030204" pitchFamily="34" charset="0"/>
+                      <a:ea typeface="Cambria Math" panose="02040503050406030204" pitchFamily="18" charset="0"/>
+                      <a:cs typeface="Calibri" panose="020F0502020204030204" pitchFamily="34" charset="0"/>
+                    </a:endParaRPr>
+                  </a:p>
+                </p:txBody>
+              </p:sp>
+            </mc:Choice>
+            <mc:Fallback xmlns="">
+              <p:sp>
+                <p:nvSpPr>
+                  <p:cNvPr id="29" name="Textfeld 28">
+                    <a:extLst>
+                      <a:ext uri="{FF2B5EF4-FFF2-40B4-BE49-F238E27FC236}">
+                        <a16:creationId xmlns:a16="http://schemas.microsoft.com/office/drawing/2014/main" id="{38C66D2F-9E14-7C8B-5D2A-1F7912FEFB00}"/>
+                      </a:ext>
+                    </a:extLst>
+                  </p:cNvPr>
+                  <p:cNvSpPr txBox="1">
+                    <a:spLocks noRot="1" noChangeAspect="1" noMove="1" noResize="1" noEditPoints="1" noAdjustHandles="1" noChangeArrowheads="1" noChangeShapeType="1" noTextEdit="1"/>
+                  </p:cNvSpPr>
+                  <p:nvPr/>
+                </p:nvSpPr>
+                <p:spPr>
+                  <a:xfrm>
+                    <a:off x="8165541" y="4453323"/>
+                    <a:ext cx="1086431" cy="277200"/>
+                  </a:xfrm>
+                  <a:prstGeom prst="rect">
+                    <a:avLst/>
+                  </a:prstGeom>
+                  <a:blipFill>
+                    <a:blip r:embed="rId5"/>
+                    <a:stretch>
+                      <a:fillRect b="-4348"/>
+                    </a:stretch>
+                  </a:blipFill>
+                  <a:ln w="12700">
+                    <a:noFill/>
+                  </a:ln>
+                </p:spPr>
+                <p:txBody>
+                  <a:bodyPr/>
+                  <a:lstStyle/>
+                  <a:p>
+                    <a:r>
+                      <a:rPr lang="de-DE">
+                        <a:noFill/>
+                      </a:rPr>
+                      <a:t> </a:t>
+                    </a:r>
+                  </a:p>
+                </p:txBody>
+              </p:sp>
+            </mc:Fallback>
+          </mc:AlternateContent>
+          <mc:AlternateContent xmlns:mc="http://schemas.openxmlformats.org/markup-compatibility/2006" xmlns:a14="http://schemas.microsoft.com/office/drawing/2010/main">
+            <mc:Choice Requires="a14">
+              <p:sp>
+                <p:nvSpPr>
+                  <p:cNvPr id="30" name="Textfeld 29">
+                    <a:extLst>
+                      <a:ext uri="{FF2B5EF4-FFF2-40B4-BE49-F238E27FC236}">
+                        <a16:creationId xmlns:a16="http://schemas.microsoft.com/office/drawing/2014/main" id="{78BBD69E-9B30-6847-5A3F-E523CB71199C}"/>
+                      </a:ext>
+                    </a:extLst>
+                  </p:cNvPr>
+                  <p:cNvSpPr txBox="1"/>
+                  <p:nvPr/>
+                </p:nvSpPr>
+                <p:spPr>
+                  <a:xfrm>
+                    <a:off x="4843821" y="4484616"/>
+                    <a:ext cx="1086431" cy="461665"/>
+                  </a:xfrm>
+                  <a:prstGeom prst="rect">
+                    <a:avLst/>
+                  </a:prstGeom>
+                  <a:noFill/>
+                  <a:ln w="12700">
+                    <a:noFill/>
+                  </a:ln>
+                </p:spPr>
+                <p:txBody>
+                  <a:bodyPr wrap="square">
+                    <a:spAutoFit/>
+                  </a:bodyPr>
+                  <a:lstStyle/>
+                  <a:p>
+                    <a:pPr algn="ctr"/>
+                    <a14:m>
+                      <m:oMathPara xmlns:m="http://schemas.openxmlformats.org/officeDocument/2006/math">
+                        <m:oMath>
+                          <m:r>
+                            <a:rPr lang="en-GB" sz="1200" b="0" i="1" noProof="0" smtClean="0">
+                              <a:latin typeface="Cambria Math" panose="02040503050406030204" pitchFamily="18" charset="0"/>
+                              <a:ea typeface="Cambria Math" panose="02040503050406030204" pitchFamily="18" charset="0"/>
+                            </a:rPr>
+                            <m:t>𝑝</m:t>
+                          </m:r>
+                          <m:r>
+                            <a:rPr lang="en-US" sz="1200" b="0" i="1" baseline="-25000" noProof="0" smtClean="0">
+                              <a:latin typeface="Cambria Math" panose="02040503050406030204" pitchFamily="18" charset="0"/>
+                              <a:ea typeface="Cambria Math" panose="02040503050406030204" pitchFamily="18" charset="0"/>
+                            </a:rPr>
+                            <m:t>𝐿</m:t>
+                          </m:r>
+                          <m:r>
+                            <m:rPr>
+                              <m:nor/>
+                            </m:rPr>
+                            <a:rPr lang="en-GB" sz="1200" i="0" dirty="0">
+                              <a:latin typeface="Calibri" panose="020F0502020204030204" pitchFamily="34" charset="0"/>
+                              <a:ea typeface="Cambria Math" panose="02040503050406030204" pitchFamily="18" charset="0"/>
+                              <a:cs typeface="Calibri" panose="020F0502020204030204" pitchFamily="34" charset="0"/>
+                            </a:rPr>
+                            <m:t> </m:t>
+                          </m:r>
+                          <m:r>
+                            <m:rPr>
+                              <m:nor/>
+                            </m:rPr>
+                            <a:rPr lang="en-US" sz="1200" b="0" i="0" dirty="0" smtClean="0">
+                              <a:latin typeface="Calibri" panose="020F0502020204030204" pitchFamily="34" charset="0"/>
+                              <a:ea typeface="Cambria Math" panose="02040503050406030204" pitchFamily="18" charset="0"/>
+                              <a:cs typeface="Calibri" panose="020F0502020204030204" pitchFamily="34" charset="0"/>
+                            </a:rPr>
+                            <m:t>&lt;</m:t>
+                          </m:r>
+                          <m:r>
+                            <a:rPr lang="en-US" sz="1200" b="0" i="1" dirty="0" smtClean="0">
+                              <a:latin typeface="Cambria Math" panose="02040503050406030204" pitchFamily="18" charset="0"/>
+                              <a:ea typeface="Cambria Math" panose="02040503050406030204" pitchFamily="18" charset="0"/>
+                              <a:cs typeface="Calibri" panose="020F0502020204030204" pitchFamily="34" charset="0"/>
+                            </a:rPr>
+                            <m:t> </m:t>
+                          </m:r>
+                          <m:r>
+                            <a:rPr lang="en-GB" sz="1200" i="1">
+                              <a:latin typeface="Cambria Math" panose="02040503050406030204" pitchFamily="18" charset="0"/>
+                              <a:ea typeface="Cambria Math" panose="02040503050406030204" pitchFamily="18" charset="0"/>
+                            </a:rPr>
+                            <m:t>𝛼</m:t>
+                          </m:r>
+                        </m:oMath>
+                      </m:oMathPara>
+                    </a14:m>
+                    <a:endParaRPr lang="en-GB" sz="1200" dirty="0">
+                      <a:latin typeface="Calibri" panose="020F0502020204030204" pitchFamily="34" charset="0"/>
+                      <a:ea typeface="Cambria Math" panose="02040503050406030204" pitchFamily="18" charset="0"/>
+                      <a:cs typeface="Calibri" panose="020F0502020204030204" pitchFamily="34" charset="0"/>
+                    </a:endParaRPr>
+                  </a:p>
+                  <a:p>
+                    <a:pPr algn="ctr"/>
+                    <a:endParaRPr lang="en-GB" sz="1200" dirty="0">
+                      <a:latin typeface="Calibri" panose="020F0502020204030204" pitchFamily="34" charset="0"/>
+                      <a:ea typeface="Cambria Math" panose="02040503050406030204" pitchFamily="18" charset="0"/>
+                      <a:cs typeface="Calibri" panose="020F0502020204030204" pitchFamily="34" charset="0"/>
+                    </a:endParaRPr>
+                  </a:p>
+                </p:txBody>
+              </p:sp>
+            </mc:Choice>
+            <mc:Fallback xmlns="">
+              <p:sp>
+                <p:nvSpPr>
+                  <p:cNvPr id="30" name="Textfeld 29">
+                    <a:extLst>
+                      <a:ext uri="{FF2B5EF4-FFF2-40B4-BE49-F238E27FC236}">
+                        <a16:creationId xmlns:a16="http://schemas.microsoft.com/office/drawing/2014/main" id="{CA4581C7-C3B0-54FA-EF00-228EC57A3E10}"/>
+                      </a:ext>
+                    </a:extLst>
+                  </p:cNvPr>
+                  <p:cNvSpPr txBox="1">
+                    <a:spLocks noRot="1" noChangeAspect="1" noMove="1" noResize="1" noEditPoints="1" noAdjustHandles="1" noChangeArrowheads="1" noChangeShapeType="1" noTextEdit="1"/>
+                  </p:cNvSpPr>
+                  <p:nvPr/>
+                </p:nvSpPr>
+                <p:spPr>
+                  <a:xfrm>
+                    <a:off x="4843821" y="4484616"/>
+                    <a:ext cx="1086431" cy="461665"/>
+                  </a:xfrm>
+                  <a:prstGeom prst="rect">
+                    <a:avLst/>
+                  </a:prstGeom>
+                  <a:blipFill>
+                    <a:blip r:embed="rId6"/>
+                    <a:stretch>
+                      <a:fillRect b="-10811"/>
+                    </a:stretch>
+                  </a:blipFill>
+                  <a:ln w="12700">
+                    <a:noFill/>
+                  </a:ln>
+                </p:spPr>
+                <p:txBody>
+                  <a:bodyPr/>
+                  <a:lstStyle/>
+                  <a:p>
+                    <a:r>
+                      <a:rPr lang="de-DE">
+                        <a:noFill/>
+                      </a:rPr>
+                      <a:t> </a:t>
+                    </a:r>
+                  </a:p>
+                </p:txBody>
+              </p:sp>
+            </mc:Fallback>
+          </mc:AlternateContent>
+          <p:sp>
+            <p:nvSpPr>
+              <p:cNvPr id="31" name="Textfeld 30">
+                <a:extLst>
+                  <a:ext uri="{FF2B5EF4-FFF2-40B4-BE49-F238E27FC236}">
+                    <a16:creationId xmlns:a16="http://schemas.microsoft.com/office/drawing/2014/main" id="{8F307937-1410-AAF2-1889-6D2AAE7FF568}"/>
+                  </a:ext>
+                </a:extLst>
+              </p:cNvPr>
+              <p:cNvSpPr txBox="1"/>
+              <p:nvPr/>
+            </p:nvSpPr>
+            <p:spPr>
+              <a:xfrm>
+                <a:off x="5270268" y="5367256"/>
+                <a:ext cx="1555285" cy="276999"/>
+              </a:xfrm>
+              <a:prstGeom prst="rect">
+                <a:avLst/>
+              </a:prstGeom>
+              <a:solidFill>
+                <a:schemeClr val="accent4">
+                  <a:alpha val="19758"/>
+                </a:schemeClr>
+              </a:solidFill>
+              <a:ln w="12700">
+                <a:solidFill>
+                  <a:schemeClr val="accent1">
+                    <a:lumMod val="40000"/>
+                    <a:lumOff val="60000"/>
+                  </a:schemeClr>
+                </a:solidFill>
+              </a:ln>
+            </p:spPr>
+            <p:txBody>
+              <a:bodyPr wrap="square">
+                <a:spAutoFit/>
+              </a:bodyPr>
+              <a:lstStyle>
+                <a:defPPr>
+                  <a:defRPr lang="de-DE"/>
+                </a:defPPr>
+                <a:lvl1pPr algn="ctr">
+                  <a:defRPr sz="1200"/>
+                </a:lvl1pPr>
+              </a:lstStyle>
+              <a:p>
+                <a:r>
+                  <a:rPr lang="en-GB" noProof="0" dirty="0" err="1">
+                    <a:latin typeface="Courier New" panose="02070309020205020404" pitchFamily="49" charset="0"/>
+                    <a:ea typeface="Cambria Math" panose="02040503050406030204" pitchFamily="18" charset="0"/>
+                    <a:cs typeface="Courier New" panose="02070309020205020404" pitchFamily="49" charset="0"/>
+                  </a:rPr>
+                  <a:t>oneway.test</a:t>
+                </a:r>
+                <a:r>
+                  <a:rPr lang="en-GB" noProof="0" dirty="0">
+                    <a:latin typeface="Courier New" panose="02070309020205020404" pitchFamily="49" charset="0"/>
+                    <a:ea typeface="Cambria Math" panose="02040503050406030204" pitchFamily="18" charset="0"/>
+                    <a:cs typeface="Courier New" panose="02070309020205020404" pitchFamily="49" charset="0"/>
+                  </a:rPr>
+                  <a:t>()</a:t>
+                </a:r>
+              </a:p>
+            </p:txBody>
+          </p:sp>
+          <p:sp>
+            <p:nvSpPr>
+              <p:cNvPr id="32" name="Textfeld 31">
+                <a:extLst>
+                  <a:ext uri="{FF2B5EF4-FFF2-40B4-BE49-F238E27FC236}">
+                    <a16:creationId xmlns:a16="http://schemas.microsoft.com/office/drawing/2014/main" id="{03740E4E-D243-93E1-4DC1-8516183A2C9E}"/>
+                  </a:ext>
+                </a:extLst>
+              </p:cNvPr>
+              <p:cNvSpPr txBox="1"/>
+              <p:nvPr/>
+            </p:nvSpPr>
+            <p:spPr>
+              <a:xfrm>
+                <a:off x="9492978" y="5376299"/>
+                <a:ext cx="1053655" cy="276999"/>
+              </a:xfrm>
+              <a:prstGeom prst="rect">
+                <a:avLst/>
+              </a:prstGeom>
+              <a:solidFill>
+                <a:schemeClr val="accent4">
+                  <a:alpha val="19758"/>
+                </a:schemeClr>
+              </a:solidFill>
+              <a:ln w="12700">
+                <a:solidFill>
+                  <a:schemeClr val="accent1">
+                    <a:lumMod val="40000"/>
+                    <a:lumOff val="60000"/>
+                  </a:schemeClr>
+                </a:solidFill>
+              </a:ln>
+            </p:spPr>
+            <p:txBody>
+              <a:bodyPr wrap="square">
+                <a:spAutoFit/>
+              </a:bodyPr>
+              <a:lstStyle/>
+              <a:p>
+                <a:pPr algn="ctr"/>
+                <a:r>
+                  <a:rPr lang="en-GB" sz="1200" noProof="0" dirty="0" err="1">
+                    <a:latin typeface="Courier New" panose="02070309020205020404" pitchFamily="49" charset="0"/>
+                    <a:ea typeface="Cambria Math" panose="02040503050406030204" pitchFamily="18" charset="0"/>
+                    <a:cs typeface="Courier New" panose="02070309020205020404" pitchFamily="49" charset="0"/>
+                  </a:rPr>
+                  <a:t>aov</a:t>
+                </a:r>
+                <a:r>
+                  <a:rPr lang="en-GB" sz="1200" noProof="0" dirty="0">
+                    <a:latin typeface="Courier New" panose="02070309020205020404" pitchFamily="49" charset="0"/>
+                    <a:ea typeface="Cambria Math" panose="02040503050406030204" pitchFamily="18" charset="0"/>
+                    <a:cs typeface="Courier New" panose="02070309020205020404" pitchFamily="49" charset="0"/>
+                  </a:rPr>
+                  <a:t>()</a:t>
+                </a:r>
+              </a:p>
+            </p:txBody>
+          </p:sp>
+          <p:grpSp>
+            <p:nvGrpSpPr>
+              <p:cNvPr id="427" name="Gruppieren 426">
+                <a:extLst>
+                  <a:ext uri="{FF2B5EF4-FFF2-40B4-BE49-F238E27FC236}">
+                    <a16:creationId xmlns:a16="http://schemas.microsoft.com/office/drawing/2014/main" id="{781CA729-4D65-24D9-F4CD-703F9EFDF2AA}"/>
+                  </a:ext>
+                </a:extLst>
+              </p:cNvPr>
+              <p:cNvGrpSpPr/>
+              <p:nvPr/>
+            </p:nvGrpSpPr>
+            <p:grpSpPr>
+              <a:xfrm>
+                <a:off x="5783635" y="4151670"/>
+                <a:ext cx="2856320" cy="305400"/>
+                <a:chOff x="8002301" y="4581613"/>
+                <a:chExt cx="1289076" cy="305400"/>
+              </a:xfrm>
+            </p:grpSpPr>
+            <p:cxnSp>
+              <p:nvCxnSpPr>
+                <p:cNvPr id="85" name="Gerade Verbindung mit Pfeil 84">
+                  <a:extLst>
+                    <a:ext uri="{FF2B5EF4-FFF2-40B4-BE49-F238E27FC236}">
+                      <a16:creationId xmlns:a16="http://schemas.microsoft.com/office/drawing/2014/main" id="{89839F7B-2490-6C8D-6F80-F68F14CEEC97}"/>
+                    </a:ext>
+                  </a:extLst>
+                </p:cNvPr>
+                <p:cNvCxnSpPr>
+                  <a:cxnSpLocks/>
+                </p:cNvCxnSpPr>
+                <p:nvPr/>
+              </p:nvCxnSpPr>
+              <p:spPr>
+                <a:xfrm flipH="1">
+                  <a:off x="8002301" y="4581613"/>
+                  <a:ext cx="639486" cy="305400"/>
+                </a:xfrm>
+                <a:prstGeom prst="straightConnector1">
+                  <a:avLst/>
+                </a:prstGeom>
+                <a:ln>
+                  <a:tailEnd type="triangle"/>
+                </a:ln>
+              </p:spPr>
+              <p:style>
+                <a:lnRef idx="1">
+                  <a:schemeClr val="accent1"/>
+                </a:lnRef>
+                <a:fillRef idx="0">
+                  <a:schemeClr val="accent1"/>
+                </a:fillRef>
+                <a:effectRef idx="0">
+                  <a:schemeClr val="accent1"/>
+                </a:effectRef>
+                <a:fontRef idx="minor">
+                  <a:schemeClr val="tx1"/>
+                </a:fontRef>
+              </p:style>
+            </p:cxnSp>
+            <p:cxnSp>
+              <p:nvCxnSpPr>
+                <p:cNvPr id="86" name="Gerade Verbindung mit Pfeil 85">
+                  <a:extLst>
+                    <a:ext uri="{FF2B5EF4-FFF2-40B4-BE49-F238E27FC236}">
+                      <a16:creationId xmlns:a16="http://schemas.microsoft.com/office/drawing/2014/main" id="{BDA52DBB-13B8-E867-E5C5-41894CCE3BF1}"/>
+                    </a:ext>
+                  </a:extLst>
+                </p:cNvPr>
+                <p:cNvCxnSpPr>
+                  <a:cxnSpLocks/>
+                </p:cNvCxnSpPr>
+                <p:nvPr/>
+              </p:nvCxnSpPr>
+              <p:spPr>
+                <a:xfrm>
+                  <a:off x="8641787" y="4581613"/>
+                  <a:ext cx="649590" cy="305400"/>
+                </a:xfrm>
+                <a:prstGeom prst="straightConnector1">
+                  <a:avLst/>
+                </a:prstGeom>
+                <a:ln>
+                  <a:tailEnd type="triangle"/>
+                </a:ln>
+              </p:spPr>
+              <p:style>
+                <a:lnRef idx="1">
+                  <a:schemeClr val="accent1"/>
+                </a:lnRef>
+                <a:fillRef idx="0">
+                  <a:schemeClr val="accent1"/>
+                </a:fillRef>
+                <a:effectRef idx="0">
+                  <a:schemeClr val="accent1"/>
+                </a:effectRef>
+                <a:fontRef idx="minor">
+                  <a:schemeClr val="tx1"/>
+                </a:fontRef>
+              </p:style>
+            </p:cxnSp>
+          </p:grpSp>
+          <p:sp>
+            <p:nvSpPr>
+              <p:cNvPr id="93" name="Textfeld 92">
+                <a:extLst>
+                  <a:ext uri="{FF2B5EF4-FFF2-40B4-BE49-F238E27FC236}">
+                    <a16:creationId xmlns:a16="http://schemas.microsoft.com/office/drawing/2014/main" id="{9B965BEC-F5D2-8608-51F1-E1D18607D2A8}"/>
+                  </a:ext>
+                </a:extLst>
+              </p:cNvPr>
+              <p:cNvSpPr txBox="1"/>
+              <p:nvPr/>
+            </p:nvSpPr>
+            <p:spPr>
+              <a:xfrm>
+                <a:off x="9492977" y="5884785"/>
+                <a:ext cx="1124403" cy="276999"/>
+              </a:xfrm>
+              <a:prstGeom prst="rect">
+                <a:avLst/>
+              </a:prstGeom>
+              <a:solidFill>
+                <a:schemeClr val="bg2">
+                  <a:lumMod val="90000"/>
+                </a:schemeClr>
+              </a:solidFill>
+              <a:ln w="12700">
+                <a:solidFill>
+                  <a:schemeClr val="accent1">
+                    <a:lumMod val="40000"/>
+                    <a:lumOff val="60000"/>
+                  </a:schemeClr>
+                </a:solidFill>
+              </a:ln>
+            </p:spPr>
+            <p:txBody>
+              <a:bodyPr wrap="square">
+                <a:spAutoFit/>
+              </a:bodyPr>
+              <a:lstStyle>
+                <a:defPPr>
+                  <a:defRPr lang="de-DE"/>
+                </a:defPPr>
+                <a:lvl1pPr algn="ctr">
+                  <a:defRPr sz="1200"/>
+                </a:lvl1pPr>
+              </a:lstStyle>
+              <a:p>
+                <a:r>
+                  <a:rPr lang="en-GB" noProof="0" dirty="0" err="1">
+                    <a:latin typeface="Courier New" panose="02070309020205020404" pitchFamily="49" charset="0"/>
+                    <a:ea typeface="Cambria Math" panose="02040503050406030204" pitchFamily="18" charset="0"/>
+                    <a:cs typeface="Courier New" panose="02070309020205020404" pitchFamily="49" charset="0"/>
+                  </a:rPr>
+                  <a:t>TukeyHSD</a:t>
+                </a:r>
+                <a:r>
+                  <a:rPr lang="en-GB" noProof="0" dirty="0">
+                    <a:latin typeface="Courier New" panose="02070309020205020404" pitchFamily="49" charset="0"/>
+                    <a:ea typeface="Cambria Math" panose="02040503050406030204" pitchFamily="18" charset="0"/>
+                    <a:cs typeface="Courier New" panose="02070309020205020404" pitchFamily="49" charset="0"/>
+                  </a:rPr>
+                  <a:t>()</a:t>
+                </a:r>
+              </a:p>
+            </p:txBody>
+          </p:sp>
+          <p:sp>
+            <p:nvSpPr>
+              <p:cNvPr id="94" name="Textfeld 93">
+                <a:extLst>
+                  <a:ext uri="{FF2B5EF4-FFF2-40B4-BE49-F238E27FC236}">
+                    <a16:creationId xmlns:a16="http://schemas.microsoft.com/office/drawing/2014/main" id="{87158079-A2B8-E8EB-B278-CC21E38DEA1F}"/>
+                  </a:ext>
+                </a:extLst>
+              </p:cNvPr>
+              <p:cNvSpPr txBox="1"/>
+              <p:nvPr/>
+            </p:nvSpPr>
+            <p:spPr>
+              <a:xfrm>
+                <a:off x="1802317" y="5884785"/>
+                <a:ext cx="2355146" cy="276999"/>
+              </a:xfrm>
+              <a:prstGeom prst="rect">
+                <a:avLst/>
+              </a:prstGeom>
+              <a:solidFill>
+                <a:schemeClr val="bg2">
+                  <a:lumMod val="90000"/>
+                </a:schemeClr>
+              </a:solidFill>
+              <a:ln w="12700">
+                <a:solidFill>
+                  <a:schemeClr val="accent1">
+                    <a:lumMod val="40000"/>
+                    <a:lumOff val="60000"/>
+                  </a:schemeClr>
+                </a:solidFill>
+              </a:ln>
+            </p:spPr>
+            <p:txBody>
+              <a:bodyPr wrap="square">
+                <a:spAutoFit/>
+              </a:bodyPr>
+              <a:lstStyle/>
+              <a:p>
+                <a:pPr algn="ctr"/>
+                <a:r>
+                  <a:rPr lang="en-GB" sz="1200" dirty="0" err="1">
+                    <a:latin typeface="Courier New" panose="02070309020205020404" pitchFamily="49" charset="0"/>
+                    <a:ea typeface="Cambria Math" panose="02040503050406030204" pitchFamily="18" charset="0"/>
+                    <a:cs typeface="Courier New" panose="02070309020205020404" pitchFamily="49" charset="0"/>
+                  </a:rPr>
+                  <a:t>dunn</a:t>
+                </a:r>
+                <a:r>
+                  <a:rPr lang="en-GB" sz="1200" err="1">
+                    <a:latin typeface="Courier New" panose="02070309020205020404" pitchFamily="49" charset="0"/>
+                    <a:ea typeface="Cambria Math" panose="02040503050406030204" pitchFamily="18" charset="0"/>
+                    <a:cs typeface="Courier New" panose="02070309020205020404" pitchFamily="49" charset="0"/>
+                  </a:rPr>
+                  <a:t>.</a:t>
+                </a:r>
+                <a:r>
+                  <a:rPr lang="en-GB" sz="1200">
+                    <a:latin typeface="Courier New" panose="02070309020205020404" pitchFamily="49" charset="0"/>
+                    <a:ea typeface="Cambria Math" panose="02040503050406030204" pitchFamily="18" charset="0"/>
+                    <a:cs typeface="Courier New" panose="02070309020205020404" pitchFamily="49" charset="0"/>
+                  </a:rPr>
+                  <a:t>test</a:t>
+                </a:r>
+                <a:r>
+                  <a:rPr lang="en-GB" sz="1200" noProof="0">
+                    <a:latin typeface="Courier New" panose="02070309020205020404" pitchFamily="49" charset="0"/>
+                    <a:ea typeface="Cambria Math" panose="02040503050406030204" pitchFamily="18" charset="0"/>
+                    <a:cs typeface="Courier New" panose="02070309020205020404" pitchFamily="49" charset="0"/>
+                  </a:rPr>
+                  <a:t>()</a:t>
+                </a:r>
+                <a:endParaRPr lang="en-GB" sz="1200" noProof="0" dirty="0">
+                  <a:latin typeface="Courier New" panose="02070309020205020404" pitchFamily="49" charset="0"/>
+                  <a:ea typeface="Cambria Math" panose="02040503050406030204" pitchFamily="18" charset="0"/>
+                  <a:cs typeface="Courier New" panose="02070309020205020404" pitchFamily="49" charset="0"/>
+                </a:endParaRPr>
+              </a:p>
+            </p:txBody>
+          </p:sp>
+          <p:sp>
+            <p:nvSpPr>
+              <p:cNvPr id="50" name="Textfeld 49">
+                <a:extLst>
+                  <a:ext uri="{FF2B5EF4-FFF2-40B4-BE49-F238E27FC236}">
+                    <a16:creationId xmlns:a16="http://schemas.microsoft.com/office/drawing/2014/main" id="{8FA089FA-66C3-FDEA-DA02-66B4A4849D2C}"/>
+                  </a:ext>
+                </a:extLst>
+              </p:cNvPr>
+              <p:cNvSpPr txBox="1"/>
+              <p:nvPr/>
+            </p:nvSpPr>
+            <p:spPr>
+              <a:xfrm>
+                <a:off x="6896818" y="5376365"/>
+                <a:ext cx="2527130" cy="276999"/>
+              </a:xfrm>
+              <a:prstGeom prst="rect">
+                <a:avLst/>
+              </a:prstGeom>
+              <a:solidFill>
+                <a:schemeClr val="accent4">
+                  <a:alpha val="19758"/>
+                </a:schemeClr>
+              </a:solidFill>
+              <a:ln w="12700">
+                <a:solidFill>
+                  <a:schemeClr val="tx1"/>
+                </a:solidFill>
+              </a:ln>
+            </p:spPr>
+            <p:txBody>
+              <a:bodyPr wrap="square">
+                <a:spAutoFit/>
+              </a:bodyPr>
+              <a:lstStyle/>
+              <a:p>
+                <a:r>
+                  <a:rPr lang="en-GB" sz="1200" noProof="0" dirty="0" err="1">
+                    <a:latin typeface="Courier New" panose="02070309020205020404" pitchFamily="49" charset="0"/>
+                    <a:ea typeface="Cambria Math" panose="02040503050406030204" pitchFamily="18" charset="0"/>
+                    <a:cs typeface="Courier New" panose="02070309020205020404" pitchFamily="49" charset="0"/>
+                  </a:rPr>
+                  <a:t>t.test</a:t>
+                </a:r>
+                <a:r>
+                  <a:rPr lang="en-GB" sz="1200" noProof="0" dirty="0">
+                    <a:latin typeface="Courier New" panose="02070309020205020404" pitchFamily="49" charset="0"/>
+                    <a:ea typeface="Cambria Math" panose="02040503050406030204" pitchFamily="18" charset="0"/>
+                    <a:cs typeface="Courier New" panose="02070309020205020404" pitchFamily="49" charset="0"/>
+                  </a:rPr>
+                  <a:t>(…,</a:t>
+                </a:r>
+                <a:r>
+                  <a:rPr lang="en-GB" sz="1200" noProof="0" dirty="0" err="1">
+                    <a:latin typeface="Courier New" panose="02070309020205020404" pitchFamily="49" charset="0"/>
+                    <a:ea typeface="Cambria Math" panose="02040503050406030204" pitchFamily="18" charset="0"/>
+                    <a:cs typeface="Courier New" panose="02070309020205020404" pitchFamily="49" charset="0"/>
+                  </a:rPr>
+                  <a:t>var.equal</a:t>
+                </a:r>
+                <a:r>
+                  <a:rPr lang="en-GB" sz="1200" noProof="0" dirty="0">
+                    <a:latin typeface="Courier New" panose="02070309020205020404" pitchFamily="49" charset="0"/>
+                    <a:ea typeface="Cambria Math" panose="02040503050406030204" pitchFamily="18" charset="0"/>
+                    <a:cs typeface="Courier New" panose="02070309020205020404" pitchFamily="49" charset="0"/>
+                  </a:rPr>
+                  <a:t>=TRUE)</a:t>
+                </a:r>
+              </a:p>
+            </p:txBody>
+          </p:sp>
+          <mc:AlternateContent xmlns:mc="http://schemas.openxmlformats.org/markup-compatibility/2006">
+            <mc:Choice xmlns:a14="http://schemas.microsoft.com/office/drawing/2010/main" Requires="a14">
+              <p:sp>
+                <p:nvSpPr>
+                  <p:cNvPr id="82" name="Textfeld 81">
+                    <a:extLst>
+                      <a:ext uri="{FF2B5EF4-FFF2-40B4-BE49-F238E27FC236}">
+                        <a16:creationId xmlns:a16="http://schemas.microsoft.com/office/drawing/2014/main" id="{F7475914-D382-6494-980D-A3B982652630}"/>
+                      </a:ext>
+                    </a:extLst>
+                  </p:cNvPr>
+                  <p:cNvSpPr txBox="1"/>
+                  <p:nvPr/>
+                </p:nvSpPr>
+                <p:spPr>
+                  <a:xfrm>
+                    <a:off x="929604" y="3022468"/>
+                    <a:ext cx="2062342" cy="276999"/>
+                  </a:xfrm>
+                  <a:prstGeom prst="rect">
+                    <a:avLst/>
+                  </a:prstGeom>
+                  <a:noFill/>
+                  <a:ln w="12700">
+                    <a:noFill/>
+                  </a:ln>
+                </p:spPr>
+                <p:txBody>
+                  <a:bodyPr wrap="square">
+                    <a:spAutoFit/>
+                  </a:bodyPr>
+                  <a:lstStyle/>
+                  <a:p>
+                    <a:pPr algn="ctr"/>
+                    <a14:m>
+                      <m:oMathPara xmlns:m="http://schemas.openxmlformats.org/officeDocument/2006/math">
+                        <m:oMath>
+                          <m:r>
+                            <a:rPr lang="en-GB" sz="1200" i="1" smtClean="0">
+                              <a:latin typeface="Cambria Math" panose="02040503050406030204" pitchFamily="18" charset="0"/>
+                              <a:ea typeface="Cambria Math" panose="02040503050406030204" pitchFamily="18" charset="0"/>
+                            </a:rPr>
+                            <m:t>𝑝</m:t>
+                          </m:r>
+                          <m:r>
+                            <a:rPr lang="en-US" sz="1200" b="0" i="1" smtClean="0">
+                              <a:latin typeface="Cambria Math" panose="02040503050406030204" pitchFamily="18" charset="0"/>
+                              <a:ea typeface="Cambria Math" panose="02040503050406030204" pitchFamily="18" charset="0"/>
+                            </a:rPr>
+                            <m:t>𝐿</m:t>
+                          </m:r>
+                          <m:r>
+                            <a:rPr lang="en-US" sz="1200" b="0" i="1" smtClean="0">
+                              <a:latin typeface="Cambria Math" panose="02040503050406030204" pitchFamily="18" charset="0"/>
+                              <a:ea typeface="Cambria Math" panose="02040503050406030204" pitchFamily="18" charset="0"/>
+                            </a:rPr>
+                            <m:t>&lt;</m:t>
+                          </m:r>
+                          <m:r>
+                            <a:rPr lang="en-GB" sz="1200" i="1">
+                              <a:latin typeface="Cambria Math" panose="02040503050406030204" pitchFamily="18" charset="0"/>
+                              <a:ea typeface="Cambria Math" panose="02040503050406030204" pitchFamily="18" charset="0"/>
+                            </a:rPr>
+                            <m:t>𝛼</m:t>
+                          </m:r>
+                        </m:oMath>
+                      </m:oMathPara>
+                    </a14:m>
+                    <a:endParaRPr lang="en-GB" sz="1200" noProof="0" dirty="0">
+                      <a:latin typeface="Calibri" panose="020F0502020204030204" pitchFamily="34" charset="0"/>
+                      <a:ea typeface="Cambria Math" panose="02040503050406030204" pitchFamily="18" charset="0"/>
+                      <a:cs typeface="Calibri" panose="020F0502020204030204" pitchFamily="34" charset="0"/>
+                    </a:endParaRPr>
+                  </a:p>
+                </p:txBody>
+              </p:sp>
+            </mc:Choice>
+            <mc:Fallback>
+              <p:sp>
+                <p:nvSpPr>
+                  <p:cNvPr id="82" name="Textfeld 81">
+                    <a:extLst>
+                      <a:ext uri="{FF2B5EF4-FFF2-40B4-BE49-F238E27FC236}">
+                        <a16:creationId xmlns:a16="http://schemas.microsoft.com/office/drawing/2014/main" id="{F7475914-D382-6494-980D-A3B982652630}"/>
+                      </a:ext>
+                    </a:extLst>
+                  </p:cNvPr>
+                  <p:cNvSpPr txBox="1">
+                    <a:spLocks noRot="1" noChangeAspect="1" noMove="1" noResize="1" noEditPoints="1" noAdjustHandles="1" noChangeArrowheads="1" noChangeShapeType="1" noTextEdit="1"/>
+                  </p:cNvSpPr>
+                  <p:nvPr/>
+                </p:nvSpPr>
+                <p:spPr>
+                  <a:xfrm>
+                    <a:off x="929604" y="3022468"/>
+                    <a:ext cx="2062342" cy="276999"/>
+                  </a:xfrm>
+                  <a:prstGeom prst="rect">
+                    <a:avLst/>
+                  </a:prstGeom>
+                  <a:blipFill>
+                    <a:blip r:embed="rId7"/>
+                    <a:stretch>
+                      <a:fillRect/>
+                    </a:stretch>
+                  </a:blipFill>
+                  <a:ln w="12700">
+                    <a:noFill/>
+                  </a:ln>
+                </p:spPr>
+                <p:txBody>
+                  <a:bodyPr/>
+                  <a:lstStyle/>
+                  <a:p>
+                    <a:r>
+                      <a:rPr lang="de-DE">
+                        <a:noFill/>
+                      </a:rPr>
+                      <a:t> </a:t>
+                    </a:r>
+                  </a:p>
+                </p:txBody>
+              </p:sp>
+            </mc:Fallback>
+          </mc:AlternateContent>
+          <mc:AlternateContent xmlns:mc="http://schemas.openxmlformats.org/markup-compatibility/2006">
+            <mc:Choice xmlns:a14="http://schemas.microsoft.com/office/drawing/2010/main" Requires="a14">
+              <p:sp>
+                <p:nvSpPr>
+                  <p:cNvPr id="88" name="Textfeld 87">
+                    <a:extLst>
+                      <a:ext uri="{FF2B5EF4-FFF2-40B4-BE49-F238E27FC236}">
+                        <a16:creationId xmlns:a16="http://schemas.microsoft.com/office/drawing/2014/main" id="{D07BBD28-7148-001B-3324-F486B4507DBB}"/>
+                      </a:ext>
+                    </a:extLst>
+                  </p:cNvPr>
+                  <p:cNvSpPr txBox="1"/>
+                  <p:nvPr/>
+                </p:nvSpPr>
+                <p:spPr>
+                  <a:xfrm>
+                    <a:off x="6543875" y="3055480"/>
+                    <a:ext cx="1805631" cy="276999"/>
+                  </a:xfrm>
+                  <a:prstGeom prst="rect">
+                    <a:avLst/>
+                  </a:prstGeom>
+                  <a:noFill/>
+                  <a:ln w="12700">
+                    <a:noFill/>
+                  </a:ln>
+                </p:spPr>
+                <p:txBody>
+                  <a:bodyPr wrap="square">
+                    <a:spAutoFit/>
+                  </a:bodyPr>
+                  <a:lstStyle/>
+                  <a:p>
+                    <a:pPr algn="ctr"/>
+                    <a14:m>
+                      <m:oMathPara xmlns:m="http://schemas.openxmlformats.org/officeDocument/2006/math">
+                        <m:oMath>
+                          <m:r>
+                            <a:rPr lang="en-GB" sz="1200" b="0" i="1" noProof="0" smtClean="0">
+                              <a:latin typeface="Cambria Math" panose="02040503050406030204" pitchFamily="18" charset="0"/>
+                              <a:ea typeface="Cambria Math" panose="02040503050406030204" pitchFamily="18" charset="0"/>
+                            </a:rPr>
+                            <m:t>𝑝</m:t>
+                          </m:r>
+                          <m:r>
+                            <a:rPr lang="en-US" sz="1200" b="0" i="1" noProof="0" smtClean="0">
+                              <a:latin typeface="Cambria Math" panose="02040503050406030204" pitchFamily="18" charset="0"/>
+                              <a:ea typeface="Cambria Math" panose="02040503050406030204" pitchFamily="18" charset="0"/>
+                            </a:rPr>
+                            <m:t>𝐿</m:t>
+                          </m:r>
+                          <m:r>
+                            <a:rPr lang="en-US" sz="1200" b="0" i="1" baseline="-25000" smtClean="0">
+                              <a:latin typeface="Cambria Math" panose="02040503050406030204" pitchFamily="18" charset="0"/>
+                              <a:ea typeface="Cambria Math" panose="02040503050406030204" pitchFamily="18" charset="0"/>
+                            </a:rPr>
+                            <m:t> </m:t>
+                          </m:r>
+                          <m:r>
+                            <a:rPr lang="en-GB" sz="1200" b="0" i="1" noProof="0" smtClean="0">
+                              <a:latin typeface="Cambria Math" panose="02040503050406030204" pitchFamily="18" charset="0"/>
+                              <a:ea typeface="Cambria Math" panose="02040503050406030204" pitchFamily="18" charset="0"/>
+                            </a:rPr>
+                            <m:t>≥</m:t>
+                          </m:r>
+                          <m:r>
+                            <a:rPr lang="en-US" sz="1200" b="0" i="1" noProof="0" smtClean="0">
+                              <a:latin typeface="Cambria Math" panose="02040503050406030204" pitchFamily="18" charset="0"/>
+                              <a:ea typeface="Cambria Math" panose="02040503050406030204" pitchFamily="18" charset="0"/>
+                            </a:rPr>
+                            <m:t> </m:t>
+                          </m:r>
+                          <m:r>
+                            <a:rPr lang="en-GB" sz="1200" b="0" i="1" noProof="0" smtClean="0">
+                              <a:latin typeface="Cambria Math" panose="02040503050406030204" pitchFamily="18" charset="0"/>
+                              <a:ea typeface="Cambria Math" panose="02040503050406030204" pitchFamily="18" charset="0"/>
+                            </a:rPr>
+                            <m:t>𝛼</m:t>
+                          </m:r>
+                        </m:oMath>
+                      </m:oMathPara>
+                    </a14:m>
+                    <a:endParaRPr lang="en-GB" sz="1200" noProof="0" dirty="0">
+                      <a:latin typeface="Calibri" panose="020F0502020204030204" pitchFamily="34" charset="0"/>
+                      <a:ea typeface="Cambria Math" panose="02040503050406030204" pitchFamily="18" charset="0"/>
+                      <a:cs typeface="Calibri" panose="020F0502020204030204" pitchFamily="34" charset="0"/>
+                    </a:endParaRPr>
+                  </a:p>
+                </p:txBody>
+              </p:sp>
+            </mc:Choice>
+            <mc:Fallback>
+              <p:sp>
+                <p:nvSpPr>
+                  <p:cNvPr id="88" name="Textfeld 87">
+                    <a:extLst>
+                      <a:ext uri="{FF2B5EF4-FFF2-40B4-BE49-F238E27FC236}">
+                        <a16:creationId xmlns:a16="http://schemas.microsoft.com/office/drawing/2014/main" id="{D07BBD28-7148-001B-3324-F486B4507DBB}"/>
+                      </a:ext>
+                    </a:extLst>
+                  </p:cNvPr>
+                  <p:cNvSpPr txBox="1">
+                    <a:spLocks noRot="1" noChangeAspect="1" noMove="1" noResize="1" noEditPoints="1" noAdjustHandles="1" noChangeArrowheads="1" noChangeShapeType="1" noTextEdit="1"/>
+                  </p:cNvSpPr>
+                  <p:nvPr/>
+                </p:nvSpPr>
+                <p:spPr>
+                  <a:xfrm>
+                    <a:off x="6543875" y="3055480"/>
+                    <a:ext cx="1805631" cy="276999"/>
+                  </a:xfrm>
+                  <a:prstGeom prst="rect">
+                    <a:avLst/>
+                  </a:prstGeom>
+                  <a:blipFill>
+                    <a:blip r:embed="rId8"/>
+                    <a:stretch>
+                      <a:fillRect b="-8333"/>
+                    </a:stretch>
+                  </a:blipFill>
+                  <a:ln w="12700">
+                    <a:noFill/>
+                  </a:ln>
+                </p:spPr>
+                <p:txBody>
+                  <a:bodyPr/>
+                  <a:lstStyle/>
+                  <a:p>
+                    <a:r>
+                      <a:rPr lang="de-DE">
+                        <a:noFill/>
+                      </a:rPr>
+                      <a:t> </a:t>
+                    </a:r>
+                  </a:p>
+                </p:txBody>
+              </p:sp>
+            </mc:Fallback>
+          </mc:AlternateContent>
+          <p:sp>
+            <p:nvSpPr>
+              <p:cNvPr id="4" name="Textfeld 3">
+                <a:extLst>
+                  <a:ext uri="{FF2B5EF4-FFF2-40B4-BE49-F238E27FC236}">
+                    <a16:creationId xmlns:a16="http://schemas.microsoft.com/office/drawing/2014/main" id="{28344E6A-FDB3-B4B2-F0A9-9569FF10C64F}"/>
+                  </a:ext>
+                </a:extLst>
+              </p:cNvPr>
+              <p:cNvSpPr txBox="1"/>
+              <p:nvPr/>
+            </p:nvSpPr>
+            <p:spPr>
+              <a:xfrm>
+                <a:off x="10687408" y="5884785"/>
+                <a:ext cx="1739721" cy="277200"/>
+              </a:xfrm>
+              <a:prstGeom prst="rect">
+                <a:avLst/>
+              </a:prstGeom>
+              <a:solidFill>
+                <a:schemeClr val="bg2">
+                  <a:lumMod val="90000"/>
+                </a:schemeClr>
+              </a:solidFill>
+              <a:ln w="12700">
+                <a:solidFill>
+                  <a:schemeClr val="bg2">
+                    <a:lumMod val="90000"/>
+                  </a:schemeClr>
+                </a:solidFill>
+              </a:ln>
+            </p:spPr>
+            <p:txBody>
+              <a:bodyPr wrap="square">
+                <a:spAutoFit/>
+              </a:bodyPr>
+              <a:lstStyle>
+                <a:defPPr>
+                  <a:defRPr lang="de-DE"/>
+                </a:defPPr>
+                <a:lvl1pPr algn="ctr">
+                  <a:defRPr sz="1200"/>
+                </a:lvl1pPr>
+              </a:lstStyle>
+              <a:p>
+                <a:r>
+                  <a:rPr lang="en-GB" noProof="0" dirty="0">
+                    <a:latin typeface="Calibri" panose="020F0502020204030204" pitchFamily="34" charset="0"/>
+                    <a:ea typeface="Cambria Math" panose="02040503050406030204" pitchFamily="18" charset="0"/>
+                    <a:cs typeface="Calibri" panose="020F0502020204030204" pitchFamily="34" charset="0"/>
+                  </a:rPr>
+                  <a:t>Post-hoc test </a:t>
+                </a:r>
+              </a:p>
+            </p:txBody>
+          </p:sp>
+          <p:sp>
+            <p:nvSpPr>
+              <p:cNvPr id="149" name="Textfeld 148">
+                <a:extLst>
+                  <a:ext uri="{FF2B5EF4-FFF2-40B4-BE49-F238E27FC236}">
+                    <a16:creationId xmlns:a16="http://schemas.microsoft.com/office/drawing/2014/main" id="{77EF0683-1D41-733E-FD17-EC5A580822FC}"/>
+                  </a:ext>
+                </a:extLst>
+              </p:cNvPr>
+              <p:cNvSpPr txBox="1"/>
+              <p:nvPr/>
+            </p:nvSpPr>
+            <p:spPr>
+              <a:xfrm>
+                <a:off x="10687409" y="5413543"/>
+                <a:ext cx="1739722" cy="276999"/>
+              </a:xfrm>
+              <a:prstGeom prst="rect">
+                <a:avLst/>
+              </a:prstGeom>
+              <a:noFill/>
+              <a:ln w="12700">
+                <a:solidFill>
+                  <a:schemeClr val="bg2">
+                    <a:lumMod val="90000"/>
+                  </a:schemeClr>
+                </a:solidFill>
+              </a:ln>
+            </p:spPr>
+            <p:txBody>
+              <a:bodyPr wrap="square">
+                <a:spAutoFit/>
+              </a:bodyPr>
+              <a:lstStyle>
+                <a:defPPr>
+                  <a:defRPr lang="de-DE"/>
+                </a:defPPr>
+                <a:lvl1pPr algn="ctr">
+                  <a:defRPr sz="1200"/>
+                </a:lvl1pPr>
+              </a:lstStyle>
+              <a:p>
+                <a:r>
+                  <a:rPr lang="en-GB" noProof="0" dirty="0">
+                    <a:latin typeface="Calibri" panose="020F0502020204030204" pitchFamily="34" charset="0"/>
+                    <a:ea typeface="Cambria Math" panose="02040503050406030204" pitchFamily="18" charset="0"/>
+                    <a:cs typeface="Calibri" panose="020F0502020204030204" pitchFamily="34" charset="0"/>
+                  </a:rPr>
+                  <a:t>Final test selected </a:t>
+                </a:r>
+              </a:p>
+            </p:txBody>
+          </p:sp>
+          <p:sp>
+            <p:nvSpPr>
+              <p:cNvPr id="159" name="Textfeld 158">
+                <a:extLst>
+                  <a:ext uri="{FF2B5EF4-FFF2-40B4-BE49-F238E27FC236}">
+                    <a16:creationId xmlns:a16="http://schemas.microsoft.com/office/drawing/2014/main" id="{AA0A1C3C-4163-E16D-29EE-60474368D8B1}"/>
+                  </a:ext>
+                </a:extLst>
+              </p:cNvPr>
+              <p:cNvSpPr txBox="1"/>
+              <p:nvPr/>
+            </p:nvSpPr>
+            <p:spPr>
+              <a:xfrm>
+                <a:off x="10633133" y="2222764"/>
+                <a:ext cx="1734970" cy="277200"/>
+              </a:xfrm>
+              <a:prstGeom prst="rect">
+                <a:avLst/>
+              </a:prstGeom>
+              <a:solidFill>
+                <a:schemeClr val="accent6">
+                  <a:lumMod val="20000"/>
+                  <a:lumOff val="80000"/>
+                </a:schemeClr>
+              </a:solidFill>
+              <a:ln w="12700">
+                <a:solidFill>
+                  <a:schemeClr val="accent1">
+                    <a:lumMod val="20000"/>
+                    <a:lumOff val="80000"/>
+                  </a:schemeClr>
+                </a:solidFill>
+              </a:ln>
+            </p:spPr>
+            <p:txBody>
+              <a:bodyPr wrap="square">
+                <a:spAutoFit/>
+              </a:bodyPr>
+              <a:lstStyle>
+                <a:defPPr>
+                  <a:defRPr lang="de-DE"/>
+                </a:defPPr>
+                <a:lvl1pPr algn="ctr">
+                  <a:defRPr sz="1200"/>
+                </a:lvl1pPr>
+              </a:lstStyle>
+              <a:p>
+                <a:r>
+                  <a:rPr lang="en-GB" dirty="0">
+                    <a:latin typeface="Calibri" panose="020F0502020204030204" pitchFamily="34" charset="0"/>
+                    <a:ea typeface="Cambria Math" panose="02040503050406030204" pitchFamily="18" charset="0"/>
+                    <a:cs typeface="Calibri" panose="020F0502020204030204" pitchFamily="34" charset="0"/>
+                  </a:rPr>
+                  <a:t>C</a:t>
+                </a:r>
+                <a:r>
+                  <a:rPr lang="en-GB" noProof="0" dirty="0">
+                    <a:latin typeface="Calibri" panose="020F0502020204030204" pitchFamily="34" charset="0"/>
+                    <a:ea typeface="Cambria Math" panose="02040503050406030204" pitchFamily="18" charset="0"/>
+                    <a:cs typeface="Calibri" panose="020F0502020204030204" pitchFamily="34" charset="0"/>
+                  </a:rPr>
+                  <a:t>heck </a:t>
+                </a:r>
+                <a:r>
+                  <a:rPr lang="de-CH" noProof="0" dirty="0">
+                    <a:latin typeface="Calibri" panose="020F0502020204030204" pitchFamily="34" charset="0"/>
+                    <a:ea typeface="Cambria Math" panose="02040503050406030204" pitchFamily="18" charset="0"/>
+                    <a:cs typeface="Calibri" panose="020F0502020204030204" pitchFamily="34" charset="0"/>
+                  </a:rPr>
+                  <a:t>h</a:t>
+                </a:r>
+                <a:r>
+                  <a:rPr lang="de-CH" dirty="0" err="1"/>
+                  <a:t>omoscedasticity</a:t>
+                </a:r>
+                <a:endParaRPr lang="en-GB" noProof="0" dirty="0">
+                  <a:latin typeface="Calibri" panose="020F0502020204030204" pitchFamily="34" charset="0"/>
+                  <a:ea typeface="Cambria Math" panose="02040503050406030204" pitchFamily="18" charset="0"/>
+                  <a:cs typeface="Calibri" panose="020F0502020204030204" pitchFamily="34" charset="0"/>
+                </a:endParaRPr>
+              </a:p>
+            </p:txBody>
+          </p:sp>
+          <p:cxnSp>
+            <p:nvCxnSpPr>
+              <p:cNvPr id="469" name="Gerade Verbindung mit Pfeil 468">
+                <a:extLst>
+                  <a:ext uri="{FF2B5EF4-FFF2-40B4-BE49-F238E27FC236}">
+                    <a16:creationId xmlns:a16="http://schemas.microsoft.com/office/drawing/2014/main" id="{7A8AE287-5639-E40F-C5AB-F93CD5DBB234}"/>
+                  </a:ext>
+                </a:extLst>
+              </p:cNvPr>
+              <p:cNvCxnSpPr>
+                <a:cxnSpLocks/>
+              </p:cNvCxnSpPr>
+              <p:nvPr/>
+            </p:nvCxnSpPr>
+            <p:spPr>
+              <a:xfrm>
+                <a:off x="10055726" y="5667436"/>
+                <a:ext cx="0" cy="188882"/>
+              </a:xfrm>
+              <a:prstGeom prst="straightConnector1">
+                <a:avLst/>
+              </a:prstGeom>
+              <a:ln>
+                <a:solidFill>
+                  <a:schemeClr val="accent1"/>
+                </a:solidFill>
+                <a:tailEnd type="triangle"/>
+              </a:ln>
+            </p:spPr>
+            <p:style>
+              <a:lnRef idx="1">
+                <a:schemeClr val="accent1"/>
+              </a:lnRef>
+              <a:fillRef idx="0">
+                <a:schemeClr val="accent1"/>
+              </a:fillRef>
+              <a:effectRef idx="0">
+                <a:schemeClr val="accent1"/>
+              </a:effectRef>
+              <a:fontRef idx="minor">
+                <a:schemeClr val="tx1"/>
+              </a:fontRef>
+            </p:style>
+          </p:cxnSp>
+          <p:cxnSp>
+            <p:nvCxnSpPr>
+              <p:cNvPr id="470" name="Gerade Verbindung mit Pfeil 469">
+                <a:extLst>
+                  <a:ext uri="{FF2B5EF4-FFF2-40B4-BE49-F238E27FC236}">
+                    <a16:creationId xmlns:a16="http://schemas.microsoft.com/office/drawing/2014/main" id="{CD0303DF-1DCC-BC06-8D22-CEEFEB16794F}"/>
+                  </a:ext>
+                </a:extLst>
+              </p:cNvPr>
+              <p:cNvCxnSpPr>
+                <a:cxnSpLocks/>
+              </p:cNvCxnSpPr>
+              <p:nvPr/>
+            </p:nvCxnSpPr>
+            <p:spPr>
+              <a:xfrm>
+                <a:off x="2989436" y="5667436"/>
+                <a:ext cx="0" cy="188882"/>
+              </a:xfrm>
+              <a:prstGeom prst="straightConnector1">
+                <a:avLst/>
+              </a:prstGeom>
+              <a:ln>
+                <a:solidFill>
+                  <a:schemeClr val="accent1"/>
+                </a:solidFill>
+                <a:tailEnd type="triangle"/>
+              </a:ln>
+            </p:spPr>
+            <p:style>
+              <a:lnRef idx="1">
+                <a:schemeClr val="accent1"/>
+              </a:lnRef>
+              <a:fillRef idx="0">
+                <a:schemeClr val="accent1"/>
+              </a:fillRef>
+              <a:effectRef idx="0">
+                <a:schemeClr val="accent1"/>
+              </a:effectRef>
+              <a:fontRef idx="minor">
+                <a:schemeClr val="tx1"/>
+              </a:fontRef>
+            </p:style>
+          </p:cxnSp>
+          <p:sp>
+            <p:nvSpPr>
+              <p:cNvPr id="3" name="Textfeld 2">
+                <a:extLst>
+                  <a:ext uri="{FF2B5EF4-FFF2-40B4-BE49-F238E27FC236}">
+                    <a16:creationId xmlns:a16="http://schemas.microsoft.com/office/drawing/2014/main" id="{5A54FDF3-A012-00E6-70B5-DE8984AE613B}"/>
+                  </a:ext>
+                </a:extLst>
+              </p:cNvPr>
+              <p:cNvSpPr txBox="1"/>
+              <p:nvPr/>
+            </p:nvSpPr>
+            <p:spPr>
+              <a:xfrm>
+                <a:off x="5286613" y="5884785"/>
+                <a:ext cx="1555286" cy="276999"/>
+              </a:xfrm>
+              <a:prstGeom prst="rect">
+                <a:avLst/>
+              </a:prstGeom>
+              <a:solidFill>
+                <a:schemeClr val="bg2">
+                  <a:lumMod val="90000"/>
+                </a:schemeClr>
+              </a:solidFill>
+              <a:ln w="12700">
+                <a:solidFill>
+                  <a:schemeClr val="accent1">
+                    <a:lumMod val="40000"/>
+                    <a:lumOff val="60000"/>
+                  </a:schemeClr>
+                </a:solidFill>
+              </a:ln>
+            </p:spPr>
+            <p:txBody>
+              <a:bodyPr wrap="square">
+                <a:spAutoFit/>
+              </a:bodyPr>
+              <a:lstStyle>
+                <a:defPPr>
+                  <a:defRPr lang="de-DE"/>
+                </a:defPPr>
+                <a:lvl1pPr algn="ctr">
+                  <a:defRPr sz="1200"/>
+                </a:lvl1pPr>
+              </a:lstStyle>
+              <a:p>
+                <a:r>
+                  <a:rPr lang="en-GB" dirty="0" err="1">
+                    <a:latin typeface="Courier New" panose="02070309020205020404" pitchFamily="49" charset="0"/>
+                    <a:ea typeface="Cambria Math" panose="02040503050406030204" pitchFamily="18" charset="0"/>
+                    <a:cs typeface="Courier New" panose="02070309020205020404" pitchFamily="49" charset="0"/>
+                  </a:rPr>
+                  <a:t>games.howell</a:t>
+                </a:r>
+                <a:r>
+                  <a:rPr lang="en-GB" noProof="0" dirty="0">
+                    <a:latin typeface="Courier New" panose="02070309020205020404" pitchFamily="49" charset="0"/>
+                    <a:ea typeface="Cambria Math" panose="02040503050406030204" pitchFamily="18" charset="0"/>
+                    <a:cs typeface="Courier New" panose="02070309020205020404" pitchFamily="49" charset="0"/>
+                  </a:rPr>
+                  <a:t>()</a:t>
+                </a:r>
+              </a:p>
+            </p:txBody>
+          </p:sp>
+          <p:sp>
+            <p:nvSpPr>
+              <p:cNvPr id="10" name="Textfeld 9">
+                <a:extLst>
+                  <a:ext uri="{FF2B5EF4-FFF2-40B4-BE49-F238E27FC236}">
+                    <a16:creationId xmlns:a16="http://schemas.microsoft.com/office/drawing/2014/main" id="{A4AF0122-CAF7-91B0-4C93-6BA6965E57EF}"/>
+                  </a:ext>
+                </a:extLst>
+              </p:cNvPr>
+              <p:cNvSpPr txBox="1"/>
+              <p:nvPr/>
+            </p:nvSpPr>
+            <p:spPr>
+              <a:xfrm>
+                <a:off x="3917677" y="2201353"/>
+                <a:ext cx="6199886" cy="280863"/>
+              </a:xfrm>
+              <a:prstGeom prst="rect">
+                <a:avLst/>
+              </a:prstGeom>
+              <a:solidFill>
+                <a:schemeClr val="accent6">
+                  <a:lumMod val="20000"/>
+                  <a:lumOff val="80000"/>
+                </a:schemeClr>
+              </a:solidFill>
+              <a:ln w="12700">
+                <a:solidFill>
+                  <a:schemeClr val="accent1">
+                    <a:lumMod val="40000"/>
+                    <a:lumOff val="60000"/>
+                  </a:schemeClr>
+                </a:solidFill>
+              </a:ln>
+            </p:spPr>
+            <p:txBody>
+              <a:bodyPr wrap="square">
+                <a:spAutoFit/>
+              </a:bodyPr>
+              <a:lstStyle/>
+              <a:p>
+                <a:pPr algn="ctr"/>
+                <a:r>
+                  <a:rPr lang="en-GB" sz="1200" dirty="0" err="1">
+                    <a:latin typeface="Courier New" panose="02070309020205020404" pitchFamily="49" charset="0"/>
+                    <a:ea typeface="Cambria Math" panose="02040503050406030204" pitchFamily="18" charset="0"/>
+                    <a:cs typeface="Courier New" panose="02070309020205020404" pitchFamily="49" charset="0"/>
+                  </a:rPr>
+                  <a:t>levene</a:t>
+                </a:r>
+                <a:r>
+                  <a:rPr lang="en-GB" sz="1200" noProof="0" dirty="0">
+                    <a:latin typeface="Courier New" panose="02070309020205020404" pitchFamily="49" charset="0"/>
+                    <a:ea typeface="Cambria Math" panose="02040503050406030204" pitchFamily="18" charset="0"/>
+                    <a:cs typeface="Courier New" panose="02070309020205020404" pitchFamily="49" charset="0"/>
+                  </a:rPr>
+                  <a:t>.test() </a:t>
+                </a:r>
+              </a:p>
+            </p:txBody>
+          </p:sp>
+          <p:cxnSp>
+            <p:nvCxnSpPr>
+              <p:cNvPr id="12" name="Gerade Verbindung mit Pfeil 11">
+                <a:extLst>
+                  <a:ext uri="{FF2B5EF4-FFF2-40B4-BE49-F238E27FC236}">
+                    <a16:creationId xmlns:a16="http://schemas.microsoft.com/office/drawing/2014/main" id="{C982492E-9004-3525-59EB-AC688E5FF045}"/>
+                  </a:ext>
+                </a:extLst>
+              </p:cNvPr>
+              <p:cNvCxnSpPr>
+                <a:cxnSpLocks/>
+                <a:stCxn id="7" idx="2"/>
+              </p:cNvCxnSpPr>
+              <p:nvPr/>
+            </p:nvCxnSpPr>
+            <p:spPr>
+              <a:xfrm>
+                <a:off x="6273543" y="1752517"/>
+                <a:ext cx="0" cy="580488"/>
+              </a:xfrm>
+              <a:prstGeom prst="straightConnector1">
+                <a:avLst/>
+              </a:prstGeom>
+              <a:ln>
+                <a:tailEnd type="triangle"/>
+              </a:ln>
+            </p:spPr>
+            <p:style>
+              <a:lnRef idx="1">
+                <a:schemeClr val="accent1"/>
+              </a:lnRef>
+              <a:fillRef idx="0">
+                <a:schemeClr val="accent1"/>
+              </a:fillRef>
+              <a:effectRef idx="0">
+                <a:schemeClr val="accent1"/>
+              </a:effectRef>
+              <a:fontRef idx="minor">
+                <a:schemeClr val="tx1"/>
+              </a:fontRef>
+            </p:style>
+          </p:cxnSp>
+          <mc:AlternateContent xmlns:mc="http://schemas.openxmlformats.org/markup-compatibility/2006" xmlns:a14="http://schemas.microsoft.com/office/drawing/2010/main">
+            <mc:Choice Requires="a14">
+              <p:sp>
+                <p:nvSpPr>
+                  <p:cNvPr id="24" name="Textfeld 23">
+                    <a:extLst>
+                      <a:ext uri="{FF2B5EF4-FFF2-40B4-BE49-F238E27FC236}">
+                        <a16:creationId xmlns:a16="http://schemas.microsoft.com/office/drawing/2014/main" id="{AC91F27F-B36D-75A0-4A2F-E146CDF71017}"/>
+                      </a:ext>
+                    </a:extLst>
+                  </p:cNvPr>
+                  <p:cNvSpPr txBox="1"/>
+                  <p:nvPr/>
+                </p:nvSpPr>
+                <p:spPr>
+                  <a:xfrm>
+                    <a:off x="176103" y="5018698"/>
+                    <a:ext cx="1455623" cy="276999"/>
+                  </a:xfrm>
+                  <a:prstGeom prst="rect">
+                    <a:avLst/>
+                  </a:prstGeom>
+                  <a:noFill/>
+                  <a:ln w="12700">
+                    <a:noFill/>
+                  </a:ln>
+                </p:spPr>
+                <p:txBody>
+                  <a:bodyPr wrap="square">
+                    <a:spAutoFit/>
+                  </a:bodyPr>
+                  <a:lstStyle/>
+                  <a:p>
+                    <a:pPr algn="ctr"/>
+                    <a14:m>
+                      <m:oMathPara xmlns:m="http://schemas.openxmlformats.org/officeDocument/2006/math">
+                        <m:oMath>
+                          <m:r>
+                            <a:rPr lang="en-US" sz="1200" b="0" i="1" smtClean="0">
+                              <a:latin typeface="Cambria Math" panose="02040503050406030204" pitchFamily="18" charset="0"/>
+                              <a:ea typeface="Cambria Math" panose="02040503050406030204" pitchFamily="18" charset="0"/>
+                            </a:rPr>
+                            <m:t>𝑘</m:t>
+                          </m:r>
+                          <m:r>
+                            <a:rPr lang="en-US" sz="1200" b="0" i="1" smtClean="0">
+                              <a:latin typeface="Cambria Math" panose="02040503050406030204" pitchFamily="18" charset="0"/>
+                              <a:ea typeface="Cambria Math" panose="02040503050406030204" pitchFamily="18" charset="0"/>
+                            </a:rPr>
+                            <m:t>=2</m:t>
+                          </m:r>
+                        </m:oMath>
+                      </m:oMathPara>
+                    </a14:m>
+                    <a:endParaRPr lang="en-GB" sz="1200" noProof="0" dirty="0">
+                      <a:latin typeface="Calibri" panose="020F0502020204030204" pitchFamily="34" charset="0"/>
+                      <a:ea typeface="Cambria Math" panose="02040503050406030204" pitchFamily="18" charset="0"/>
+                      <a:cs typeface="Calibri" panose="020F0502020204030204" pitchFamily="34" charset="0"/>
+                    </a:endParaRPr>
+                  </a:p>
+                </p:txBody>
+              </p:sp>
+            </mc:Choice>
+            <mc:Fallback xmlns="">
+              <p:sp>
+                <p:nvSpPr>
+                  <p:cNvPr id="24" name="Textfeld 23">
+                    <a:extLst>
+                      <a:ext uri="{FF2B5EF4-FFF2-40B4-BE49-F238E27FC236}">
+                        <a16:creationId xmlns:a16="http://schemas.microsoft.com/office/drawing/2014/main" id="{9DDF4002-DC12-E055-D57B-9A420412E12D}"/>
+                      </a:ext>
+                    </a:extLst>
+                  </p:cNvPr>
+                  <p:cNvSpPr txBox="1">
+                    <a:spLocks noRot="1" noChangeAspect="1" noMove="1" noResize="1" noEditPoints="1" noAdjustHandles="1" noChangeArrowheads="1" noChangeShapeType="1" noTextEdit="1"/>
+                  </p:cNvSpPr>
+                  <p:nvPr/>
+                </p:nvSpPr>
+                <p:spPr>
+                  <a:xfrm>
+                    <a:off x="176103" y="5018698"/>
+                    <a:ext cx="1455623" cy="276999"/>
+                  </a:xfrm>
+                  <a:prstGeom prst="rect">
+                    <a:avLst/>
+                  </a:prstGeom>
+                  <a:blipFill>
+                    <a:blip r:embed="rId10"/>
+                    <a:stretch>
+                      <a:fillRect/>
+                    </a:stretch>
+                  </a:blipFill>
+                  <a:ln w="12700">
+                    <a:noFill/>
+                  </a:ln>
+                </p:spPr>
+                <p:txBody>
+                  <a:bodyPr/>
+                  <a:lstStyle/>
+                  <a:p>
+                    <a:r>
+                      <a:rPr lang="de-DE">
+                        <a:noFill/>
+                      </a:rPr>
+                      <a:t> </a:t>
+                    </a:r>
+                  </a:p>
+                </p:txBody>
+              </p:sp>
+            </mc:Fallback>
+          </mc:AlternateContent>
+          <mc:AlternateContent xmlns:mc="http://schemas.openxmlformats.org/markup-compatibility/2006" xmlns:a14="http://schemas.microsoft.com/office/drawing/2010/main">
+            <mc:Choice Requires="a14">
+              <p:sp>
+                <p:nvSpPr>
+                  <p:cNvPr id="25" name="Textfeld 24">
+                    <a:extLst>
+                      <a:ext uri="{FF2B5EF4-FFF2-40B4-BE49-F238E27FC236}">
+                        <a16:creationId xmlns:a16="http://schemas.microsoft.com/office/drawing/2014/main" id="{272FB962-8D3C-D738-E57D-0EBF3136CD21}"/>
+                      </a:ext>
+                    </a:extLst>
+                  </p:cNvPr>
+                  <p:cNvSpPr txBox="1"/>
+                  <p:nvPr/>
+                </p:nvSpPr>
+                <p:spPr>
+                  <a:xfrm>
+                    <a:off x="1798821" y="5029318"/>
+                    <a:ext cx="2336699" cy="276999"/>
+                  </a:xfrm>
+                  <a:prstGeom prst="rect">
+                    <a:avLst/>
+                  </a:prstGeom>
+                  <a:noFill/>
+                  <a:ln w="12700">
+                    <a:noFill/>
+                  </a:ln>
+                </p:spPr>
+                <p:txBody>
+                  <a:bodyPr wrap="square">
+                    <a:spAutoFit/>
+                  </a:bodyPr>
+                  <a:lstStyle/>
+                  <a:p>
+                    <a:pPr algn="ctr"/>
+                    <a14:m>
+                      <m:oMathPara xmlns:m="http://schemas.openxmlformats.org/officeDocument/2006/math">
+                        <m:oMath>
+                          <m:r>
+                            <a:rPr lang="en-US" sz="1200" b="0" i="1" smtClean="0">
+                              <a:latin typeface="Cambria Math" panose="02040503050406030204" pitchFamily="18" charset="0"/>
+                              <a:ea typeface="Cambria Math" panose="02040503050406030204" pitchFamily="18" charset="0"/>
+                            </a:rPr>
+                            <m:t>𝑘</m:t>
+                          </m:r>
+                          <m:r>
+                            <a:rPr lang="en-US" sz="1200" b="0" i="1" smtClean="0">
+                              <a:latin typeface="Cambria Math" panose="02040503050406030204" pitchFamily="18" charset="0"/>
+                              <a:ea typeface="Cambria Math" panose="02040503050406030204" pitchFamily="18" charset="0"/>
+                            </a:rPr>
+                            <m:t> &gt;2</m:t>
+                          </m:r>
+                        </m:oMath>
+                      </m:oMathPara>
+                    </a14:m>
+                    <a:endParaRPr lang="en-GB" sz="1200" noProof="0" dirty="0">
+                      <a:latin typeface="Calibri" panose="020F0502020204030204" pitchFamily="34" charset="0"/>
+                      <a:ea typeface="Cambria Math" panose="02040503050406030204" pitchFamily="18" charset="0"/>
+                      <a:cs typeface="Calibri" panose="020F0502020204030204" pitchFamily="34" charset="0"/>
+                    </a:endParaRPr>
+                  </a:p>
+                </p:txBody>
+              </p:sp>
+            </mc:Choice>
+            <mc:Fallback xmlns="">
+              <p:sp>
+                <p:nvSpPr>
+                  <p:cNvPr id="25" name="Textfeld 24">
+                    <a:extLst>
+                      <a:ext uri="{FF2B5EF4-FFF2-40B4-BE49-F238E27FC236}">
+                        <a16:creationId xmlns:a16="http://schemas.microsoft.com/office/drawing/2014/main" id="{0EA1C71A-304F-C75E-AF4E-0A6C9B95F4FB}"/>
+                      </a:ext>
+                    </a:extLst>
+                  </p:cNvPr>
+                  <p:cNvSpPr txBox="1">
+                    <a:spLocks noRot="1" noChangeAspect="1" noMove="1" noResize="1" noEditPoints="1" noAdjustHandles="1" noChangeArrowheads="1" noChangeShapeType="1" noTextEdit="1"/>
+                  </p:cNvSpPr>
+                  <p:nvPr/>
+                </p:nvSpPr>
+                <p:spPr>
+                  <a:xfrm>
+                    <a:off x="1798821" y="5029318"/>
+                    <a:ext cx="2336699" cy="276999"/>
+                  </a:xfrm>
+                  <a:prstGeom prst="rect">
+                    <a:avLst/>
+                  </a:prstGeom>
+                  <a:blipFill>
+                    <a:blip r:embed="rId11"/>
+                    <a:stretch>
+                      <a:fillRect b="-4167"/>
+                    </a:stretch>
+                  </a:blipFill>
+                  <a:ln w="12700">
+                    <a:noFill/>
+                  </a:ln>
+                </p:spPr>
+                <p:txBody>
+                  <a:bodyPr/>
+                  <a:lstStyle/>
+                  <a:p>
+                    <a:r>
+                      <a:rPr lang="de-DE">
+                        <a:noFill/>
+                      </a:rPr>
+                      <a:t> </a:t>
+                    </a:r>
+                  </a:p>
+                </p:txBody>
+              </p:sp>
+            </mc:Fallback>
+          </mc:AlternateContent>
+          <p:grpSp>
+            <p:nvGrpSpPr>
+              <p:cNvPr id="38" name="Gruppieren 37">
+                <a:extLst>
+                  <a:ext uri="{FF2B5EF4-FFF2-40B4-BE49-F238E27FC236}">
+                    <a16:creationId xmlns:a16="http://schemas.microsoft.com/office/drawing/2014/main" id="{592218C2-53D5-DE90-AFB4-26C16008CEA5}"/>
+                  </a:ext>
+                </a:extLst>
+              </p:cNvPr>
+              <p:cNvGrpSpPr/>
+              <p:nvPr/>
+            </p:nvGrpSpPr>
+            <p:grpSpPr>
+              <a:xfrm>
+                <a:off x="4591203" y="4716325"/>
+                <a:ext cx="1687838" cy="346131"/>
+                <a:chOff x="2697748" y="1511731"/>
+                <a:chExt cx="1289074" cy="305403"/>
+              </a:xfrm>
+            </p:grpSpPr>
+            <p:cxnSp>
+              <p:nvCxnSpPr>
+                <p:cNvPr id="41" name="Gerade Verbindung mit Pfeil 40">
+                  <a:extLst>
+                    <a:ext uri="{FF2B5EF4-FFF2-40B4-BE49-F238E27FC236}">
+                      <a16:creationId xmlns:a16="http://schemas.microsoft.com/office/drawing/2014/main" id="{58AB4AAA-6EAD-72BA-D8B2-A088DE924A87}"/>
+                    </a:ext>
+                  </a:extLst>
+                </p:cNvPr>
+                <p:cNvCxnSpPr>
+                  <a:cxnSpLocks/>
+                </p:cNvCxnSpPr>
+                <p:nvPr/>
+              </p:nvCxnSpPr>
+              <p:spPr>
+                <a:xfrm flipH="1">
+                  <a:off x="2697748" y="1511731"/>
+                  <a:ext cx="639486" cy="305400"/>
+                </a:xfrm>
+                <a:prstGeom prst="straightConnector1">
+                  <a:avLst/>
+                </a:prstGeom>
+                <a:ln>
+                  <a:tailEnd type="triangle"/>
+                </a:ln>
+              </p:spPr>
+              <p:style>
+                <a:lnRef idx="1">
+                  <a:schemeClr val="accent1"/>
+                </a:lnRef>
+                <a:fillRef idx="0">
+                  <a:schemeClr val="accent1"/>
+                </a:fillRef>
+                <a:effectRef idx="0">
+                  <a:schemeClr val="accent1"/>
+                </a:effectRef>
+                <a:fontRef idx="minor">
+                  <a:schemeClr val="tx1"/>
+                </a:fontRef>
+              </p:style>
+            </p:cxnSp>
+            <p:cxnSp>
+              <p:nvCxnSpPr>
+                <p:cNvPr id="42" name="Gerade Verbindung mit Pfeil 41">
+                  <a:extLst>
+                    <a:ext uri="{FF2B5EF4-FFF2-40B4-BE49-F238E27FC236}">
+                      <a16:creationId xmlns:a16="http://schemas.microsoft.com/office/drawing/2014/main" id="{05335EE5-D5BD-7D18-1625-F5B7F427F081}"/>
+                    </a:ext>
+                  </a:extLst>
+                </p:cNvPr>
+                <p:cNvCxnSpPr>
+                  <a:cxnSpLocks/>
+                </p:cNvCxnSpPr>
+                <p:nvPr/>
+              </p:nvCxnSpPr>
+              <p:spPr>
+                <a:xfrm>
+                  <a:off x="3337232" y="1511734"/>
+                  <a:ext cx="649590" cy="305400"/>
+                </a:xfrm>
+                <a:prstGeom prst="straightConnector1">
+                  <a:avLst/>
+                </a:prstGeom>
+                <a:ln>
+                  <a:tailEnd type="triangle"/>
+                </a:ln>
+              </p:spPr>
+              <p:style>
+                <a:lnRef idx="1">
+                  <a:schemeClr val="accent1"/>
+                </a:lnRef>
+                <a:fillRef idx="0">
+                  <a:schemeClr val="accent1"/>
+                </a:fillRef>
+                <a:effectRef idx="0">
+                  <a:schemeClr val="accent1"/>
+                </a:effectRef>
+                <a:fontRef idx="minor">
+                  <a:schemeClr val="tx1"/>
+                </a:fontRef>
+              </p:style>
+            </p:cxnSp>
+          </p:grpSp>
+          <mc:AlternateContent xmlns:mc="http://schemas.openxmlformats.org/markup-compatibility/2006" xmlns:a14="http://schemas.microsoft.com/office/drawing/2010/main">
+            <mc:Choice Requires="a14">
+              <p:sp>
+                <p:nvSpPr>
+                  <p:cNvPr id="55" name="Textfeld 54">
+                    <a:extLst>
+                      <a:ext uri="{FF2B5EF4-FFF2-40B4-BE49-F238E27FC236}">
+                        <a16:creationId xmlns:a16="http://schemas.microsoft.com/office/drawing/2014/main" id="{947BE4D4-6EB5-4A04-CB5C-910422C885C6}"/>
+                      </a:ext>
+                    </a:extLst>
+                  </p:cNvPr>
+                  <p:cNvSpPr txBox="1"/>
+                  <p:nvPr/>
+                </p:nvSpPr>
+                <p:spPr>
+                  <a:xfrm>
+                    <a:off x="4194821" y="5033603"/>
+                    <a:ext cx="890372" cy="276999"/>
+                  </a:xfrm>
+                  <a:prstGeom prst="rect">
+                    <a:avLst/>
+                  </a:prstGeom>
+                  <a:noFill/>
+                  <a:ln w="12700">
+                    <a:noFill/>
+                  </a:ln>
+                </p:spPr>
+                <p:txBody>
+                  <a:bodyPr wrap="square">
+                    <a:spAutoFit/>
+                  </a:bodyPr>
+                  <a:lstStyle/>
+                  <a:p>
+                    <a:pPr algn="ctr"/>
+                    <a14:m>
+                      <m:oMathPara xmlns:m="http://schemas.openxmlformats.org/officeDocument/2006/math">
+                        <m:oMath>
+                          <m:r>
+                            <a:rPr lang="en-US" sz="1200" b="0" i="1" smtClean="0">
+                              <a:latin typeface="Cambria Math" panose="02040503050406030204" pitchFamily="18" charset="0"/>
+                              <a:ea typeface="Cambria Math" panose="02040503050406030204" pitchFamily="18" charset="0"/>
+                            </a:rPr>
+                            <m:t>𝑘</m:t>
+                          </m:r>
+                          <m:r>
+                            <a:rPr lang="en-US" sz="1200" b="0" i="1" smtClean="0">
+                              <a:latin typeface="Cambria Math" panose="02040503050406030204" pitchFamily="18" charset="0"/>
+                              <a:ea typeface="Cambria Math" panose="02040503050406030204" pitchFamily="18" charset="0"/>
+                            </a:rPr>
+                            <m:t> =2</m:t>
+                          </m:r>
+                        </m:oMath>
+                      </m:oMathPara>
+                    </a14:m>
+                    <a:endParaRPr lang="en-GB" sz="1200" noProof="0" dirty="0">
+                      <a:latin typeface="Calibri" panose="020F0502020204030204" pitchFamily="34" charset="0"/>
+                      <a:ea typeface="Cambria Math" panose="02040503050406030204" pitchFamily="18" charset="0"/>
+                      <a:cs typeface="Calibri" panose="020F0502020204030204" pitchFamily="34" charset="0"/>
+                    </a:endParaRPr>
+                  </a:p>
+                </p:txBody>
+              </p:sp>
+            </mc:Choice>
+            <mc:Fallback xmlns="">
+              <p:sp>
+                <p:nvSpPr>
+                  <p:cNvPr id="55" name="Textfeld 54">
+                    <a:extLst>
+                      <a:ext uri="{FF2B5EF4-FFF2-40B4-BE49-F238E27FC236}">
+                        <a16:creationId xmlns:a16="http://schemas.microsoft.com/office/drawing/2014/main" id="{32F34D86-DE31-25CE-057E-D851B9BC0D4C}"/>
+                      </a:ext>
+                    </a:extLst>
+                  </p:cNvPr>
+                  <p:cNvSpPr txBox="1">
+                    <a:spLocks noRot="1" noChangeAspect="1" noMove="1" noResize="1" noEditPoints="1" noAdjustHandles="1" noChangeArrowheads="1" noChangeShapeType="1" noTextEdit="1"/>
+                  </p:cNvSpPr>
+                  <p:nvPr/>
+                </p:nvSpPr>
+                <p:spPr>
+                  <a:xfrm>
+                    <a:off x="4194821" y="5033603"/>
+                    <a:ext cx="890372" cy="276999"/>
+                  </a:xfrm>
+                  <a:prstGeom prst="rect">
+                    <a:avLst/>
+                  </a:prstGeom>
+                  <a:blipFill>
+                    <a:blip r:embed="rId12"/>
+                    <a:stretch>
+                      <a:fillRect b="-4348"/>
+                    </a:stretch>
+                  </a:blipFill>
+                  <a:ln w="12700">
+                    <a:noFill/>
+                  </a:ln>
+                </p:spPr>
+                <p:txBody>
+                  <a:bodyPr/>
+                  <a:lstStyle/>
+                  <a:p>
+                    <a:r>
+                      <a:rPr lang="de-DE">
+                        <a:noFill/>
+                      </a:rPr>
+                      <a:t> </a:t>
+                    </a:r>
+                  </a:p>
+                </p:txBody>
+              </p:sp>
+            </mc:Fallback>
+          </mc:AlternateContent>
+          <mc:AlternateContent xmlns:mc="http://schemas.openxmlformats.org/markup-compatibility/2006" xmlns:a14="http://schemas.microsoft.com/office/drawing/2010/main">
+            <mc:Choice Requires="a14">
+              <p:sp>
+                <p:nvSpPr>
+                  <p:cNvPr id="56" name="Textfeld 55">
+                    <a:extLst>
+                      <a:ext uri="{FF2B5EF4-FFF2-40B4-BE49-F238E27FC236}">
+                        <a16:creationId xmlns:a16="http://schemas.microsoft.com/office/drawing/2014/main" id="{ADA3C46C-18A3-5962-93BB-665EF2E925E7}"/>
+                      </a:ext>
+                    </a:extLst>
+                  </p:cNvPr>
+                  <p:cNvSpPr txBox="1"/>
+                  <p:nvPr/>
+                </p:nvSpPr>
+                <p:spPr>
+                  <a:xfrm>
+                    <a:off x="5825084" y="5018698"/>
+                    <a:ext cx="846119" cy="276999"/>
+                  </a:xfrm>
+                  <a:prstGeom prst="rect">
+                    <a:avLst/>
+                  </a:prstGeom>
+                  <a:noFill/>
+                  <a:ln w="12700">
+                    <a:noFill/>
+                  </a:ln>
+                </p:spPr>
+                <p:txBody>
+                  <a:bodyPr wrap="square">
+                    <a:spAutoFit/>
+                  </a:bodyPr>
+                  <a:lstStyle/>
+                  <a:p>
+                    <a:pPr algn="ctr"/>
+                    <a14:m>
+                      <m:oMathPara xmlns:m="http://schemas.openxmlformats.org/officeDocument/2006/math">
+                        <m:oMath>
+                          <m:r>
+                            <a:rPr lang="en-US" sz="1200" b="0" i="1" smtClean="0">
+                              <a:latin typeface="Cambria Math" panose="02040503050406030204" pitchFamily="18" charset="0"/>
+                              <a:ea typeface="Cambria Math" panose="02040503050406030204" pitchFamily="18" charset="0"/>
+                            </a:rPr>
+                            <m:t>𝑘</m:t>
+                          </m:r>
+                          <m:r>
+                            <a:rPr lang="en-US" sz="1200" b="0" i="1" smtClean="0">
+                              <a:latin typeface="Cambria Math" panose="02040503050406030204" pitchFamily="18" charset="0"/>
+                              <a:ea typeface="Cambria Math" panose="02040503050406030204" pitchFamily="18" charset="0"/>
+                            </a:rPr>
+                            <m:t> &gt; 2</m:t>
+                          </m:r>
+                        </m:oMath>
+                      </m:oMathPara>
+                    </a14:m>
+                    <a:endParaRPr lang="en-GB" sz="1200" noProof="0" dirty="0">
+                      <a:latin typeface="Calibri" panose="020F0502020204030204" pitchFamily="34" charset="0"/>
+                      <a:ea typeface="Cambria Math" panose="02040503050406030204" pitchFamily="18" charset="0"/>
+                      <a:cs typeface="Calibri" panose="020F0502020204030204" pitchFamily="34" charset="0"/>
+                    </a:endParaRPr>
+                  </a:p>
+                </p:txBody>
+              </p:sp>
+            </mc:Choice>
+            <mc:Fallback xmlns="">
+              <p:sp>
+                <p:nvSpPr>
+                  <p:cNvPr id="56" name="Textfeld 55">
+                    <a:extLst>
+                      <a:ext uri="{FF2B5EF4-FFF2-40B4-BE49-F238E27FC236}">
+                        <a16:creationId xmlns:a16="http://schemas.microsoft.com/office/drawing/2014/main" id="{3E0D5529-B228-DD80-E287-2980B02418B3}"/>
+                      </a:ext>
+                    </a:extLst>
+                  </p:cNvPr>
+                  <p:cNvSpPr txBox="1">
+                    <a:spLocks noRot="1" noChangeAspect="1" noMove="1" noResize="1" noEditPoints="1" noAdjustHandles="1" noChangeArrowheads="1" noChangeShapeType="1" noTextEdit="1"/>
+                  </p:cNvSpPr>
+                  <p:nvPr/>
+                </p:nvSpPr>
+                <p:spPr>
+                  <a:xfrm>
+                    <a:off x="5825084" y="5018698"/>
+                    <a:ext cx="846119" cy="276999"/>
+                  </a:xfrm>
+                  <a:prstGeom prst="rect">
+                    <a:avLst/>
+                  </a:prstGeom>
+                  <a:blipFill>
+                    <a:blip r:embed="rId13"/>
+                    <a:stretch>
+                      <a:fillRect b="-4348"/>
+                    </a:stretch>
+                  </a:blipFill>
+                  <a:ln w="12700">
+                    <a:noFill/>
+                  </a:ln>
+                </p:spPr>
+                <p:txBody>
+                  <a:bodyPr/>
+                  <a:lstStyle/>
+                  <a:p>
+                    <a:r>
+                      <a:rPr lang="de-DE">
+                        <a:noFill/>
+                      </a:rPr>
+                      <a:t> </a:t>
+                    </a:r>
+                  </a:p>
+                </p:txBody>
+              </p:sp>
+            </mc:Fallback>
+          </mc:AlternateContent>
+          <p:grpSp>
+            <p:nvGrpSpPr>
+              <p:cNvPr id="57" name="Gruppieren 56">
+                <a:extLst>
+                  <a:ext uri="{FF2B5EF4-FFF2-40B4-BE49-F238E27FC236}">
+                    <a16:creationId xmlns:a16="http://schemas.microsoft.com/office/drawing/2014/main" id="{D0C449D1-27C8-EB85-BF13-93B7D90F8663}"/>
+                  </a:ext>
+                </a:extLst>
+              </p:cNvPr>
+              <p:cNvGrpSpPr/>
+              <p:nvPr/>
+            </p:nvGrpSpPr>
+            <p:grpSpPr>
+              <a:xfrm>
+                <a:off x="7894225" y="4716325"/>
+                <a:ext cx="1687838" cy="346131"/>
+                <a:chOff x="2785044" y="1511731"/>
+                <a:chExt cx="1289074" cy="305403"/>
+              </a:xfrm>
+            </p:grpSpPr>
+            <p:cxnSp>
+              <p:nvCxnSpPr>
+                <p:cNvPr id="58" name="Gerade Verbindung mit Pfeil 57">
+                  <a:extLst>
+                    <a:ext uri="{FF2B5EF4-FFF2-40B4-BE49-F238E27FC236}">
+                      <a16:creationId xmlns:a16="http://schemas.microsoft.com/office/drawing/2014/main" id="{AD74BBAF-E668-080C-2D00-CB913599C818}"/>
+                    </a:ext>
+                  </a:extLst>
+                </p:cNvPr>
+                <p:cNvCxnSpPr>
+                  <a:cxnSpLocks/>
+                </p:cNvCxnSpPr>
+                <p:nvPr/>
+              </p:nvCxnSpPr>
+              <p:spPr>
+                <a:xfrm flipH="1">
+                  <a:off x="2785044" y="1511731"/>
+                  <a:ext cx="639486" cy="305400"/>
+                </a:xfrm>
+                <a:prstGeom prst="straightConnector1">
+                  <a:avLst/>
+                </a:prstGeom>
+                <a:ln>
+                  <a:tailEnd type="triangle"/>
+                </a:ln>
+              </p:spPr>
+              <p:style>
+                <a:lnRef idx="1">
+                  <a:schemeClr val="accent1"/>
+                </a:lnRef>
+                <a:fillRef idx="0">
+                  <a:schemeClr val="accent1"/>
+                </a:fillRef>
+                <a:effectRef idx="0">
+                  <a:schemeClr val="accent1"/>
+                </a:effectRef>
+                <a:fontRef idx="minor">
+                  <a:schemeClr val="tx1"/>
+                </a:fontRef>
+              </p:style>
+            </p:cxnSp>
+            <p:cxnSp>
+              <p:nvCxnSpPr>
+                <p:cNvPr id="59" name="Gerade Verbindung mit Pfeil 58">
+                  <a:extLst>
+                    <a:ext uri="{FF2B5EF4-FFF2-40B4-BE49-F238E27FC236}">
+                      <a16:creationId xmlns:a16="http://schemas.microsoft.com/office/drawing/2014/main" id="{CEBF20F7-BBEC-726E-58ED-AF22CE707EBC}"/>
+                    </a:ext>
+                  </a:extLst>
+                </p:cNvPr>
+                <p:cNvCxnSpPr>
+                  <a:cxnSpLocks/>
+                </p:cNvCxnSpPr>
+                <p:nvPr/>
+              </p:nvCxnSpPr>
+              <p:spPr>
+                <a:xfrm>
+                  <a:off x="3424528" y="1511734"/>
+                  <a:ext cx="649590" cy="305400"/>
+                </a:xfrm>
+                <a:prstGeom prst="straightConnector1">
+                  <a:avLst/>
+                </a:prstGeom>
+                <a:ln>
+                  <a:tailEnd type="triangle"/>
+                </a:ln>
+              </p:spPr>
+              <p:style>
+                <a:lnRef idx="1">
+                  <a:schemeClr val="accent1"/>
+                </a:lnRef>
+                <a:fillRef idx="0">
+                  <a:schemeClr val="accent1"/>
+                </a:fillRef>
+                <a:effectRef idx="0">
+                  <a:schemeClr val="accent1"/>
+                </a:effectRef>
+                <a:fontRef idx="minor">
+                  <a:schemeClr val="tx1"/>
+                </a:fontRef>
+              </p:style>
+            </p:cxnSp>
+          </p:grpSp>
+          <mc:AlternateContent xmlns:mc="http://schemas.openxmlformats.org/markup-compatibility/2006" xmlns:a14="http://schemas.microsoft.com/office/drawing/2010/main">
+            <mc:Choice Requires="a14">
+              <p:sp>
+                <p:nvSpPr>
+                  <p:cNvPr id="60" name="Textfeld 59">
+                    <a:extLst>
+                      <a:ext uri="{FF2B5EF4-FFF2-40B4-BE49-F238E27FC236}">
+                        <a16:creationId xmlns:a16="http://schemas.microsoft.com/office/drawing/2014/main" id="{84DF7205-949F-23A3-AD8A-9501B2790ADE}"/>
+                      </a:ext>
+                    </a:extLst>
+                  </p:cNvPr>
+                  <p:cNvSpPr txBox="1"/>
+                  <p:nvPr/>
+                </p:nvSpPr>
+                <p:spPr>
+                  <a:xfrm>
+                    <a:off x="7396370" y="5018698"/>
+                    <a:ext cx="890372" cy="276999"/>
+                  </a:xfrm>
+                  <a:prstGeom prst="rect">
+                    <a:avLst/>
+                  </a:prstGeom>
+                  <a:noFill/>
+                  <a:ln w="12700">
+                    <a:noFill/>
+                  </a:ln>
+                </p:spPr>
+                <p:txBody>
+                  <a:bodyPr wrap="square">
+                    <a:spAutoFit/>
+                  </a:bodyPr>
+                  <a:lstStyle/>
+                  <a:p>
+                    <a:pPr algn="ctr"/>
+                    <a14:m>
+                      <m:oMathPara xmlns:m="http://schemas.openxmlformats.org/officeDocument/2006/math">
+                        <m:oMath>
+                          <m:r>
+                            <a:rPr lang="en-US" sz="1200" b="0" i="1" smtClean="0">
+                              <a:latin typeface="Cambria Math" panose="02040503050406030204" pitchFamily="18" charset="0"/>
+                              <a:ea typeface="Cambria Math" panose="02040503050406030204" pitchFamily="18" charset="0"/>
+                            </a:rPr>
+                            <m:t>𝑘</m:t>
+                          </m:r>
+                          <m:r>
+                            <a:rPr lang="en-US" sz="1200" b="0" i="1" smtClean="0">
+                              <a:latin typeface="Cambria Math" panose="02040503050406030204" pitchFamily="18" charset="0"/>
+                              <a:ea typeface="Cambria Math" panose="02040503050406030204" pitchFamily="18" charset="0"/>
+                            </a:rPr>
+                            <m:t> =2</m:t>
+                          </m:r>
+                        </m:oMath>
+                      </m:oMathPara>
+                    </a14:m>
+                    <a:endParaRPr lang="en-GB" sz="1200" noProof="0" dirty="0">
+                      <a:latin typeface="Calibri" panose="020F0502020204030204" pitchFamily="34" charset="0"/>
+                      <a:ea typeface="Cambria Math" panose="02040503050406030204" pitchFamily="18" charset="0"/>
+                      <a:cs typeface="Calibri" panose="020F0502020204030204" pitchFamily="34" charset="0"/>
+                    </a:endParaRPr>
+                  </a:p>
+                </p:txBody>
+              </p:sp>
+            </mc:Choice>
+            <mc:Fallback xmlns="">
+              <p:sp>
+                <p:nvSpPr>
+                  <p:cNvPr id="60" name="Textfeld 59">
+                    <a:extLst>
+                      <a:ext uri="{FF2B5EF4-FFF2-40B4-BE49-F238E27FC236}">
+                        <a16:creationId xmlns:a16="http://schemas.microsoft.com/office/drawing/2014/main" id="{77C6E6CC-42F5-BE06-70A0-D9AD39033837}"/>
+                      </a:ext>
+                    </a:extLst>
+                  </p:cNvPr>
+                  <p:cNvSpPr txBox="1">
+                    <a:spLocks noRot="1" noChangeAspect="1" noMove="1" noResize="1" noEditPoints="1" noAdjustHandles="1" noChangeArrowheads="1" noChangeShapeType="1" noTextEdit="1"/>
+                  </p:cNvSpPr>
+                  <p:nvPr/>
+                </p:nvSpPr>
+                <p:spPr>
+                  <a:xfrm>
+                    <a:off x="7396370" y="5018698"/>
+                    <a:ext cx="890372" cy="276999"/>
+                  </a:xfrm>
+                  <a:prstGeom prst="rect">
+                    <a:avLst/>
+                  </a:prstGeom>
+                  <a:blipFill>
+                    <a:blip r:embed="rId14"/>
+                    <a:stretch>
+                      <a:fillRect b="-4348"/>
+                    </a:stretch>
+                  </a:blipFill>
+                  <a:ln w="12700">
+                    <a:noFill/>
+                  </a:ln>
+                </p:spPr>
+                <p:txBody>
+                  <a:bodyPr/>
+                  <a:lstStyle/>
+                  <a:p>
+                    <a:r>
+                      <a:rPr lang="de-DE">
+                        <a:noFill/>
+                      </a:rPr>
+                      <a:t> </a:t>
+                    </a:r>
+                  </a:p>
+                </p:txBody>
+              </p:sp>
+            </mc:Fallback>
+          </mc:AlternateContent>
+          <mc:AlternateContent xmlns:mc="http://schemas.openxmlformats.org/markup-compatibility/2006" xmlns:a14="http://schemas.microsoft.com/office/drawing/2010/main">
+            <mc:Choice Requires="a14">
+              <p:sp>
+                <p:nvSpPr>
+                  <p:cNvPr id="61" name="Textfeld 60">
+                    <a:extLst>
+                      <a:ext uri="{FF2B5EF4-FFF2-40B4-BE49-F238E27FC236}">
+                        <a16:creationId xmlns:a16="http://schemas.microsoft.com/office/drawing/2014/main" id="{71CCCB3A-8795-E509-CCA8-3B82AFBA71C6}"/>
+                      </a:ext>
+                    </a:extLst>
+                  </p:cNvPr>
+                  <p:cNvSpPr txBox="1"/>
+                  <p:nvPr/>
+                </p:nvSpPr>
+                <p:spPr>
+                  <a:xfrm>
+                    <a:off x="9158922" y="5018698"/>
+                    <a:ext cx="846119" cy="276999"/>
+                  </a:xfrm>
+                  <a:prstGeom prst="rect">
+                    <a:avLst/>
+                  </a:prstGeom>
+                  <a:noFill/>
+                  <a:ln w="12700">
+                    <a:noFill/>
+                  </a:ln>
+                </p:spPr>
+                <p:txBody>
+                  <a:bodyPr wrap="square">
+                    <a:spAutoFit/>
+                  </a:bodyPr>
+                  <a:lstStyle/>
+                  <a:p>
+                    <a:pPr algn="ctr"/>
+                    <a14:m>
+                      <m:oMathPara xmlns:m="http://schemas.openxmlformats.org/officeDocument/2006/math">
+                        <m:oMath>
+                          <m:r>
+                            <a:rPr lang="en-US" sz="1200" b="0" i="1" smtClean="0">
+                              <a:latin typeface="Cambria Math" panose="02040503050406030204" pitchFamily="18" charset="0"/>
+                              <a:ea typeface="Cambria Math" panose="02040503050406030204" pitchFamily="18" charset="0"/>
+                            </a:rPr>
+                            <m:t> </m:t>
+                          </m:r>
+                          <m:r>
+                            <a:rPr lang="en-US" sz="1200" b="0" i="1" smtClean="0">
+                              <a:latin typeface="Cambria Math" panose="02040503050406030204" pitchFamily="18" charset="0"/>
+                              <a:ea typeface="Cambria Math" panose="02040503050406030204" pitchFamily="18" charset="0"/>
+                            </a:rPr>
+                            <m:t>𝑘</m:t>
+                          </m:r>
+                          <m:r>
+                            <a:rPr lang="en-US" sz="1200" b="0" i="1" smtClean="0">
+                              <a:latin typeface="Cambria Math" panose="02040503050406030204" pitchFamily="18" charset="0"/>
+                              <a:ea typeface="Cambria Math" panose="02040503050406030204" pitchFamily="18" charset="0"/>
+                            </a:rPr>
+                            <m:t>&gt; 2</m:t>
+                          </m:r>
+                        </m:oMath>
+                      </m:oMathPara>
+                    </a14:m>
+                    <a:endParaRPr lang="en-GB" sz="1200" noProof="0" dirty="0">
+                      <a:latin typeface="Calibri" panose="020F0502020204030204" pitchFamily="34" charset="0"/>
+                      <a:ea typeface="Cambria Math" panose="02040503050406030204" pitchFamily="18" charset="0"/>
+                      <a:cs typeface="Calibri" panose="020F0502020204030204" pitchFamily="34" charset="0"/>
+                    </a:endParaRPr>
+                  </a:p>
+                </p:txBody>
+              </p:sp>
+            </mc:Choice>
+            <mc:Fallback xmlns="">
+              <p:sp>
+                <p:nvSpPr>
+                  <p:cNvPr id="61" name="Textfeld 60">
+                    <a:extLst>
+                      <a:ext uri="{FF2B5EF4-FFF2-40B4-BE49-F238E27FC236}">
+                        <a16:creationId xmlns:a16="http://schemas.microsoft.com/office/drawing/2014/main" id="{98C4BAEE-E59A-9693-1E67-65291EDBDE33}"/>
+                      </a:ext>
+                    </a:extLst>
+                  </p:cNvPr>
+                  <p:cNvSpPr txBox="1">
+                    <a:spLocks noRot="1" noChangeAspect="1" noMove="1" noResize="1" noEditPoints="1" noAdjustHandles="1" noChangeArrowheads="1" noChangeShapeType="1" noTextEdit="1"/>
+                  </p:cNvSpPr>
+                  <p:nvPr/>
+                </p:nvSpPr>
+                <p:spPr>
+                  <a:xfrm>
+                    <a:off x="9158922" y="5018698"/>
+                    <a:ext cx="846119" cy="276999"/>
+                  </a:xfrm>
+                  <a:prstGeom prst="rect">
+                    <a:avLst/>
+                  </a:prstGeom>
+                  <a:blipFill>
+                    <a:blip r:embed="rId15"/>
+                    <a:stretch>
+                      <a:fillRect b="-4348"/>
+                    </a:stretch>
+                  </a:blipFill>
+                  <a:ln w="12700">
+                    <a:noFill/>
+                  </a:ln>
+                </p:spPr>
+                <p:txBody>
+                  <a:bodyPr/>
+                  <a:lstStyle/>
+                  <a:p>
+                    <a:r>
+                      <a:rPr lang="de-DE">
+                        <a:noFill/>
+                      </a:rPr>
+                      <a:t> </a:t>
+                    </a:r>
+                  </a:p>
+                </p:txBody>
+              </p:sp>
+            </mc:Fallback>
+          </mc:AlternateContent>
+          <p:sp>
+            <p:nvSpPr>
+              <p:cNvPr id="62" name="Textfeld 61">
+                <a:extLst>
+                  <a:ext uri="{FF2B5EF4-FFF2-40B4-BE49-F238E27FC236}">
+                    <a16:creationId xmlns:a16="http://schemas.microsoft.com/office/drawing/2014/main" id="{05A7FCC7-AAA1-25DE-F5ED-DD8C82FBB3EA}"/>
+                  </a:ext>
+                </a:extLst>
+              </p:cNvPr>
+              <p:cNvSpPr txBox="1"/>
+              <p:nvPr/>
+            </p:nvSpPr>
+            <p:spPr>
+              <a:xfrm>
+                <a:off x="4237616" y="5367256"/>
+                <a:ext cx="991434" cy="276999"/>
+              </a:xfrm>
+              <a:prstGeom prst="rect">
+                <a:avLst/>
+              </a:prstGeom>
+              <a:solidFill>
+                <a:schemeClr val="accent4">
+                  <a:alpha val="19758"/>
+                </a:schemeClr>
+              </a:solidFill>
+              <a:ln w="12700">
+                <a:solidFill>
+                  <a:schemeClr val="tx1"/>
+                </a:solidFill>
+              </a:ln>
+            </p:spPr>
+            <p:txBody>
+              <a:bodyPr wrap="square">
+                <a:spAutoFit/>
+              </a:bodyPr>
+              <a:lstStyle>
+                <a:defPPr>
+                  <a:defRPr lang="de-DE"/>
+                </a:defPPr>
+                <a:lvl1pPr algn="ctr">
+                  <a:defRPr sz="1200"/>
+                </a:lvl1pPr>
+              </a:lstStyle>
+              <a:p>
+                <a:r>
+                  <a:rPr lang="en-GB" noProof="0" dirty="0" err="1">
+                    <a:latin typeface="Courier New" panose="02070309020205020404" pitchFamily="49" charset="0"/>
+                    <a:ea typeface="Cambria Math" panose="02040503050406030204" pitchFamily="18" charset="0"/>
+                    <a:cs typeface="Courier New" panose="02070309020205020404" pitchFamily="49" charset="0"/>
+                  </a:rPr>
+                  <a:t>t.test</a:t>
+                </a:r>
+                <a:r>
+                  <a:rPr lang="en-GB" noProof="0" dirty="0">
+                    <a:latin typeface="Courier New" panose="02070309020205020404" pitchFamily="49" charset="0"/>
+                    <a:ea typeface="Cambria Math" panose="02040503050406030204" pitchFamily="18" charset="0"/>
+                    <a:cs typeface="Courier New" panose="02070309020205020404" pitchFamily="49" charset="0"/>
+                  </a:rPr>
+                  <a:t>()</a:t>
+                </a:r>
+              </a:p>
+            </p:txBody>
+          </p:sp>
+          <p:cxnSp>
+            <p:nvCxnSpPr>
+              <p:cNvPr id="448" name="Gerade Verbindung mit Pfeil 447">
+                <a:extLst>
+                  <a:ext uri="{FF2B5EF4-FFF2-40B4-BE49-F238E27FC236}">
+                    <a16:creationId xmlns:a16="http://schemas.microsoft.com/office/drawing/2014/main" id="{D3C5FC0F-2527-7814-47E7-6E47A58C5B4B}"/>
+                  </a:ext>
+                </a:extLst>
+              </p:cNvPr>
+              <p:cNvCxnSpPr>
+                <a:cxnSpLocks/>
+              </p:cNvCxnSpPr>
+              <p:nvPr/>
+            </p:nvCxnSpPr>
+            <p:spPr>
+              <a:xfrm>
+                <a:off x="6054863" y="5667436"/>
+                <a:ext cx="0" cy="188882"/>
+              </a:xfrm>
+              <a:prstGeom prst="straightConnector1">
+                <a:avLst/>
+              </a:prstGeom>
+              <a:ln>
+                <a:solidFill>
+                  <a:schemeClr val="accent1"/>
+                </a:solidFill>
+                <a:tailEnd type="triangle"/>
+              </a:ln>
+            </p:spPr>
+            <p:style>
+              <a:lnRef idx="1">
+                <a:schemeClr val="accent1"/>
+              </a:lnRef>
+              <a:fillRef idx="0">
+                <a:schemeClr val="accent1"/>
+              </a:fillRef>
+              <a:effectRef idx="0">
+                <a:schemeClr val="accent1"/>
+              </a:effectRef>
+              <a:fontRef idx="minor">
+                <a:schemeClr val="tx1"/>
+              </a:fontRef>
+            </p:style>
+          </p:cxnSp>
+          <p:sp>
+            <p:nvSpPr>
+              <p:cNvPr id="453" name="Textfeld 452">
+                <a:extLst>
+                  <a:ext uri="{FF2B5EF4-FFF2-40B4-BE49-F238E27FC236}">
+                    <a16:creationId xmlns:a16="http://schemas.microsoft.com/office/drawing/2014/main" id="{0B0B7A0F-63E6-A192-B45E-34D5AD94AE63}"/>
+                  </a:ext>
+                </a:extLst>
+              </p:cNvPr>
+              <p:cNvSpPr txBox="1"/>
+              <p:nvPr/>
+            </p:nvSpPr>
+            <p:spPr>
+              <a:xfrm>
+                <a:off x="371932" y="1518116"/>
+                <a:ext cx="1579377" cy="281831"/>
+              </a:xfrm>
+              <a:prstGeom prst="rect">
+                <a:avLst/>
+              </a:prstGeom>
+              <a:solidFill>
+                <a:schemeClr val="accent4">
+                  <a:alpha val="19758"/>
+                </a:schemeClr>
+              </a:solidFill>
+              <a:ln w="12700">
+                <a:noFill/>
+              </a:ln>
+            </p:spPr>
+            <p:txBody>
+              <a:bodyPr wrap="square">
+                <a:spAutoFit/>
+              </a:bodyPr>
+              <a:lstStyle/>
+              <a:p>
+                <a:pPr algn="ctr"/>
+                <a:r>
+                  <a:rPr lang="en-GB" sz="1200" noProof="0" dirty="0">
+                    <a:latin typeface="Calibri" panose="020F0502020204030204" pitchFamily="34" charset="0"/>
+                    <a:ea typeface="Cambria Math" panose="02040503050406030204" pitchFamily="18" charset="0"/>
+                    <a:cs typeface="Calibri" panose="020F0502020204030204" pitchFamily="34" charset="0"/>
+                  </a:rPr>
+                  <a:t>parametric tests</a:t>
+                </a:r>
+              </a:p>
+            </p:txBody>
+          </p:sp>
+          <p:sp>
+            <p:nvSpPr>
+              <p:cNvPr id="454" name="Textfeld 453">
+                <a:extLst>
+                  <a:ext uri="{FF2B5EF4-FFF2-40B4-BE49-F238E27FC236}">
+                    <a16:creationId xmlns:a16="http://schemas.microsoft.com/office/drawing/2014/main" id="{725DE9B5-C5E7-C073-D21F-4E06D90D6A8B}"/>
+                  </a:ext>
+                </a:extLst>
+              </p:cNvPr>
+              <p:cNvSpPr txBox="1"/>
+              <p:nvPr/>
+            </p:nvSpPr>
+            <p:spPr>
+              <a:xfrm>
+                <a:off x="306876" y="1315788"/>
+                <a:ext cx="1097743" cy="281831"/>
+              </a:xfrm>
+              <a:prstGeom prst="rect">
+                <a:avLst/>
+              </a:prstGeom>
+              <a:noFill/>
+              <a:ln w="12700">
+                <a:noFill/>
+              </a:ln>
+            </p:spPr>
+            <p:txBody>
+              <a:bodyPr wrap="square">
+                <a:spAutoFit/>
+              </a:bodyPr>
+              <a:lstStyle>
+                <a:defPPr>
+                  <a:defRPr lang="de-DE"/>
+                </a:defPPr>
+                <a:lvl1pPr algn="ctr">
+                  <a:defRPr sz="1200"/>
+                </a:lvl1pPr>
+              </a:lstStyle>
+              <a:p>
+                <a:pPr algn="l"/>
+                <a:r>
+                  <a:rPr lang="en-GB" noProof="0" dirty="0">
+                    <a:latin typeface="Calibri" panose="020F0502020204030204" pitchFamily="34" charset="0"/>
+                    <a:ea typeface="Cambria Math" panose="02040503050406030204" pitchFamily="18" charset="0"/>
+                    <a:cs typeface="Calibri" panose="020F0502020204030204" pitchFamily="34" charset="0"/>
+                  </a:rPr>
+                  <a:t>Colour code: </a:t>
+                </a:r>
+              </a:p>
+            </p:txBody>
+          </p:sp>
+          <p:sp>
+            <p:nvSpPr>
+              <p:cNvPr id="455" name="Rechteck 454">
+                <a:extLst>
+                  <a:ext uri="{FF2B5EF4-FFF2-40B4-BE49-F238E27FC236}">
+                    <a16:creationId xmlns:a16="http://schemas.microsoft.com/office/drawing/2014/main" id="{39E1AB60-10D1-5CF6-890C-AC00B41C7513}"/>
+                  </a:ext>
+                </a:extLst>
+              </p:cNvPr>
+              <p:cNvSpPr/>
+              <p:nvPr/>
+            </p:nvSpPr>
+            <p:spPr>
+              <a:xfrm>
+                <a:off x="264845" y="1290852"/>
+                <a:ext cx="2562767" cy="1410048"/>
+              </a:xfrm>
+              <a:prstGeom prst="rect">
+                <a:avLst/>
+              </a:prstGeom>
+              <a:noFill/>
+              <a:ln>
+                <a:solidFill>
+                  <a:schemeClr val="bg1">
+                    <a:lumMod val="85000"/>
+                  </a:schemeClr>
+                </a:solidFill>
+              </a:ln>
+            </p:spPr>
+            <p:style>
+              <a:lnRef idx="2">
+                <a:schemeClr val="accent1">
+                  <a:shade val="15000"/>
+                </a:schemeClr>
+              </a:lnRef>
+              <a:fillRef idx="1">
+                <a:schemeClr val="accent1"/>
+              </a:fillRef>
+              <a:effectRef idx="0">
+                <a:schemeClr val="accent1"/>
+              </a:effectRef>
+              <a:fontRef idx="minor">
+                <a:schemeClr val="lt1"/>
+              </a:fontRef>
+            </p:style>
+            <p:txBody>
+              <a:bodyPr rtlCol="0" anchor="ctr"/>
+              <a:lstStyle/>
+              <a:p>
+                <a:pPr algn="ctr"/>
+                <a:endParaRPr lang="de-DE"/>
+              </a:p>
+            </p:txBody>
+          </p:sp>
+          <mc:AlternateContent xmlns:mc="http://schemas.openxmlformats.org/markup-compatibility/2006" xmlns:a14="http://schemas.microsoft.com/office/drawing/2010/main">
+            <mc:Choice Requires="a14">
+              <p:sp>
+                <p:nvSpPr>
+                  <p:cNvPr id="457" name="Textfeld 456">
+                    <a:extLst>
+                      <a:ext uri="{FF2B5EF4-FFF2-40B4-BE49-F238E27FC236}">
+                        <a16:creationId xmlns:a16="http://schemas.microsoft.com/office/drawing/2014/main" id="{9398502E-FD25-47E8-FD78-787ABF1693E4}"/>
+                      </a:ext>
+                    </a:extLst>
+                  </p:cNvPr>
+                  <p:cNvSpPr txBox="1"/>
+                  <p:nvPr/>
+                </p:nvSpPr>
+                <p:spPr>
+                  <a:xfrm>
+                    <a:off x="331795" y="2194101"/>
+                    <a:ext cx="2326236" cy="461665"/>
+                  </a:xfrm>
+                  <a:prstGeom prst="rect">
+                    <a:avLst/>
+                  </a:prstGeom>
+                  <a:noFill/>
+                  <a:ln>
+                    <a:noFill/>
+                  </a:ln>
+                </p:spPr>
+                <p:txBody>
+                  <a:bodyPr wrap="square">
+                    <a:spAutoFit/>
+                  </a:bodyPr>
+                  <a:lstStyle/>
+                  <a:p>
+                    <a14:m>
+                      <m:oMath xmlns:m="http://schemas.openxmlformats.org/officeDocument/2006/math">
+                        <m:r>
+                          <a:rPr lang="en-GB" sz="1200" i="1" noProof="0" smtClean="0">
+                            <a:latin typeface="Cambria Math" panose="02040503050406030204" pitchFamily="18" charset="0"/>
+                            <a:ea typeface="Cambria Math" panose="02040503050406030204" pitchFamily="18" charset="0"/>
+                          </a:rPr>
+                          <m:t>𝛼</m:t>
+                        </m:r>
+                        <m:r>
+                          <a:rPr lang="en-US" sz="1200" b="0" i="1" noProof="0" smtClean="0">
+                            <a:latin typeface="Cambria Math" panose="02040503050406030204" pitchFamily="18" charset="0"/>
+                            <a:ea typeface="Cambria Math" panose="02040503050406030204" pitchFamily="18" charset="0"/>
+                          </a:rPr>
+                          <m:t>  </m:t>
+                        </m:r>
+                        <m:r>
+                          <a:rPr lang="en-GB" sz="1200" b="0" i="1" noProof="0" smtClean="0">
+                            <a:latin typeface="Cambria Math" panose="02040503050406030204" pitchFamily="18" charset="0"/>
+                            <a:ea typeface="Cambria Math" panose="02040503050406030204" pitchFamily="18" charset="0"/>
+                          </a:rPr>
+                          <m:t>=</m:t>
+                        </m:r>
+                        <m:r>
+                          <a:rPr lang="en-US" sz="1200" b="0" i="1" noProof="0" smtClean="0">
+                            <a:latin typeface="Cambria Math" panose="02040503050406030204" pitchFamily="18" charset="0"/>
+                            <a:ea typeface="Cambria Math" panose="02040503050406030204" pitchFamily="18" charset="0"/>
+                          </a:rPr>
+                          <m:t> </m:t>
+                        </m:r>
+                        <m:r>
+                          <a:rPr lang="en-GB" sz="1200" b="0" i="1" noProof="0" smtClean="0">
+                            <a:latin typeface="Cambria Math" panose="02040503050406030204" pitchFamily="18" charset="0"/>
+                            <a:ea typeface="Cambria Math" panose="02040503050406030204" pitchFamily="18" charset="0"/>
+                          </a:rPr>
+                          <m:t>1−</m:t>
+                        </m:r>
+                      </m:oMath>
+                    </a14:m>
+                    <a:r>
+                      <a:rPr lang="en-GB" sz="1200" noProof="0" dirty="0">
+                        <a:latin typeface="Calibri" panose="020F0502020204030204" pitchFamily="34" charset="0"/>
+                        <a:ea typeface="Cambria Math" panose="02040503050406030204" pitchFamily="18" charset="0"/>
+                        <a:cs typeface="Calibri" panose="020F0502020204030204" pitchFamily="34" charset="0"/>
+                      </a:rPr>
+                      <a:t> </a:t>
+                    </a:r>
+                    <a:r>
+                      <a:rPr lang="en-GB" sz="1200" noProof="0" dirty="0" err="1">
+                        <a:latin typeface="Courier New" panose="02070309020205020404" pitchFamily="49" charset="0"/>
+                        <a:ea typeface="CMU Bright Roman" panose="02000603000000000000" pitchFamily="2" charset="0"/>
+                        <a:cs typeface="Courier New" panose="02070309020205020404" pitchFamily="49" charset="0"/>
+                      </a:rPr>
+                      <a:t>conf.level</a:t>
+                    </a:r>
+                    <a:endParaRPr lang="en-GB" sz="1200" noProof="0" dirty="0">
+                      <a:latin typeface="Courier New" panose="02070309020205020404" pitchFamily="49" charset="0"/>
+                      <a:ea typeface="CMU Bright Roman" panose="02000603000000000000" pitchFamily="2" charset="0"/>
+                      <a:cs typeface="Courier New" panose="02070309020205020404" pitchFamily="49" charset="0"/>
+                    </a:endParaRPr>
+                  </a:p>
+                  <a:p>
+                    <a14:m>
+                      <m:oMath xmlns:m="http://schemas.openxmlformats.org/officeDocument/2006/math">
+                        <m:sSub>
+                          <m:sSubPr>
+                            <m:ctrlPr>
+                              <a:rPr lang="en-GB" sz="1200" i="1" noProof="0" dirty="0" smtClean="0">
+                                <a:latin typeface="Cambria Math" panose="02040503050406030204" pitchFamily="18" charset="0"/>
+                                <a:ea typeface="CMU Bright Roman" panose="02000603000000000000" pitchFamily="2" charset="0"/>
+                                <a:cs typeface="Courier New" panose="02070309020205020404" pitchFamily="49" charset="0"/>
+                              </a:rPr>
+                            </m:ctrlPr>
+                          </m:sSubPr>
+                          <m:e>
+                            <m:r>
+                              <a:rPr lang="en-GB" sz="1200" i="1" noProof="0" dirty="0" smtClean="0">
+                                <a:latin typeface="Cambria Math" panose="02040503050406030204" pitchFamily="18" charset="0"/>
+                                <a:ea typeface="CMU Bright Roman" panose="02000603000000000000" pitchFamily="2" charset="0"/>
+                                <a:cs typeface="Courier New" panose="02070309020205020404" pitchFamily="49" charset="0"/>
+                              </a:rPr>
+                              <m:t>𝑛</m:t>
+                            </m:r>
+                          </m:e>
+                          <m:sub>
+                            <m:r>
+                              <a:rPr lang="en-GB" sz="1200" i="1" noProof="0" dirty="0" smtClean="0">
+                                <a:latin typeface="Cambria Math" panose="02040503050406030204" pitchFamily="18" charset="0"/>
+                                <a:ea typeface="CMU Bright Roman" panose="02000603000000000000" pitchFamily="2" charset="0"/>
+                                <a:cs typeface="Courier New" panose="02070309020205020404" pitchFamily="49" charset="0"/>
+                              </a:rPr>
+                              <m:t>𝑖</m:t>
+                            </m:r>
+                          </m:sub>
+                        </m:sSub>
+                        <m:r>
+                          <a:rPr lang="en-GB" sz="1200" i="1" dirty="0" smtClean="0">
+                            <a:latin typeface="Cambria Math" panose="02040503050406030204" pitchFamily="18" charset="0"/>
+                            <a:ea typeface="CMU Bright Roman" panose="02000603000000000000" pitchFamily="2" charset="0"/>
+                            <a:cs typeface="Courier New" panose="02070309020205020404" pitchFamily="49" charset="0"/>
+                          </a:rPr>
+                          <m:t>:</m:t>
+                        </m:r>
+                        <m:r>
+                          <a:rPr lang="en-GB" sz="1200" i="1" dirty="0">
+                            <a:latin typeface="Cambria Math" panose="02040503050406030204" pitchFamily="18" charset="0"/>
+                            <a:ea typeface="CMU Bright Roman" panose="02000603000000000000" pitchFamily="2" charset="0"/>
+                            <a:cs typeface="Courier New" panose="02070309020205020404" pitchFamily="49" charset="0"/>
+                          </a:rPr>
+                          <m:t> </m:t>
+                        </m:r>
+                      </m:oMath>
+                    </a14:m>
+                    <a:r>
+                      <a:rPr lang="en-GB" sz="1200" dirty="0">
+                        <a:ea typeface="CMU Bright Roman" panose="02000603000000000000" pitchFamily="2" charset="0"/>
+                        <a:cs typeface="Courier New" panose="02070309020205020404" pitchFamily="49" charset="0"/>
+                      </a:rPr>
+                      <a:t>sample size of group/level</a:t>
+                    </a:r>
+                    <a14:m>
+                      <m:oMath xmlns:m="http://schemas.openxmlformats.org/officeDocument/2006/math">
+                        <m:r>
+                          <a:rPr lang="en-US" sz="1200" b="0" i="0" dirty="0" smtClean="0">
+                            <a:latin typeface="Cambria Math" panose="02040503050406030204" pitchFamily="18" charset="0"/>
+                            <a:ea typeface="CMU Bright Roman" panose="02000603000000000000" pitchFamily="2" charset="0"/>
+                            <a:cs typeface="Courier New" panose="02070309020205020404" pitchFamily="49" charset="0"/>
+                          </a:rPr>
+                          <m:t> </m:t>
+                        </m:r>
+                        <m:r>
+                          <a:rPr lang="en-GB" sz="1200" i="1" dirty="0" smtClean="0">
+                            <a:latin typeface="Cambria Math" panose="02040503050406030204" pitchFamily="18" charset="0"/>
+                            <a:ea typeface="CMU Bright Roman" panose="02000603000000000000" pitchFamily="2" charset="0"/>
+                            <a:cs typeface="Courier New" panose="02070309020205020404" pitchFamily="49" charset="0"/>
+                          </a:rPr>
+                          <m:t>𝑖</m:t>
+                        </m:r>
+                      </m:oMath>
+                    </a14:m>
+                    <a:endParaRPr lang="en-GB" sz="800" noProof="0" dirty="0">
+                      <a:ea typeface="CMU Bright Roman" panose="02000603000000000000" pitchFamily="2" charset="0"/>
+                      <a:cs typeface="CMU Bright Roman" panose="02000603000000000000" pitchFamily="2" charset="0"/>
+                    </a:endParaRPr>
+                  </a:p>
+                </p:txBody>
+              </p:sp>
+            </mc:Choice>
+            <mc:Fallback xmlns="">
+              <p:sp>
+                <p:nvSpPr>
+                  <p:cNvPr id="457" name="Textfeld 456">
+                    <a:extLst>
+                      <a:ext uri="{FF2B5EF4-FFF2-40B4-BE49-F238E27FC236}">
+                        <a16:creationId xmlns:a16="http://schemas.microsoft.com/office/drawing/2014/main" id="{AE241776-F0C5-523F-4D7D-472302D0E677}"/>
+                      </a:ext>
+                    </a:extLst>
+                  </p:cNvPr>
+                  <p:cNvSpPr txBox="1">
+                    <a:spLocks noRot="1" noChangeAspect="1" noMove="1" noResize="1" noEditPoints="1" noAdjustHandles="1" noChangeArrowheads="1" noChangeShapeType="1" noTextEdit="1"/>
+                  </p:cNvSpPr>
+                  <p:nvPr/>
+                </p:nvSpPr>
+                <p:spPr>
+                  <a:xfrm>
+                    <a:off x="331795" y="2194101"/>
+                    <a:ext cx="2326236" cy="461665"/>
+                  </a:xfrm>
+                  <a:prstGeom prst="rect">
+                    <a:avLst/>
+                  </a:prstGeom>
+                  <a:blipFill>
+                    <a:blip r:embed="rId16"/>
+                    <a:stretch>
+                      <a:fillRect b="-8108"/>
+                    </a:stretch>
+                  </a:blipFill>
+                  <a:ln>
+                    <a:noFill/>
+                  </a:ln>
+                </p:spPr>
+                <p:txBody>
+                  <a:bodyPr/>
+                  <a:lstStyle/>
+                  <a:p>
+                    <a:r>
+                      <a:rPr lang="de-DE">
+                        <a:noFill/>
+                      </a:rPr>
+                      <a:t> </a:t>
+                    </a:r>
+                  </a:p>
+                </p:txBody>
+              </p:sp>
+            </mc:Fallback>
+          </mc:AlternateContent>
+          <p:cxnSp>
+            <p:nvCxnSpPr>
+              <p:cNvPr id="458" name="Gerade Verbindung mit Pfeil 457">
+                <a:extLst>
+                  <a:ext uri="{FF2B5EF4-FFF2-40B4-BE49-F238E27FC236}">
+                    <a16:creationId xmlns:a16="http://schemas.microsoft.com/office/drawing/2014/main" id="{48DC8FF4-B38A-3AAA-9F2C-F5CBF1326EC3}"/>
+                  </a:ext>
+                </a:extLst>
+              </p:cNvPr>
+              <p:cNvCxnSpPr>
+                <a:cxnSpLocks/>
+              </p:cNvCxnSpPr>
+              <p:nvPr/>
+            </p:nvCxnSpPr>
+            <p:spPr>
+              <a:xfrm>
+                <a:off x="7573975" y="3310805"/>
+                <a:ext cx="0" cy="493567"/>
+              </a:xfrm>
+              <a:prstGeom prst="straightConnector1">
+                <a:avLst/>
+              </a:prstGeom>
+              <a:ln>
+                <a:solidFill>
+                  <a:schemeClr val="accent1"/>
+                </a:solidFill>
+                <a:tailEnd type="triangle"/>
+              </a:ln>
+            </p:spPr>
+            <p:style>
+              <a:lnRef idx="1">
+                <a:schemeClr val="accent1"/>
+              </a:lnRef>
+              <a:fillRef idx="0">
+                <a:schemeClr val="accent1"/>
+              </a:fillRef>
+              <a:effectRef idx="0">
+                <a:schemeClr val="accent1"/>
+              </a:effectRef>
+              <a:fontRef idx="minor">
+                <a:schemeClr val="tx1"/>
+              </a:fontRef>
+            </p:style>
+          </p:cxnSp>
+          <p:sp>
+            <p:nvSpPr>
+              <p:cNvPr id="508" name="Textfeld 507">
+                <a:extLst>
+                  <a:ext uri="{FF2B5EF4-FFF2-40B4-BE49-F238E27FC236}">
+                    <a16:creationId xmlns:a16="http://schemas.microsoft.com/office/drawing/2014/main" id="{7739C404-B97A-4DF2-FF08-5CD1425219B0}"/>
+                  </a:ext>
+                </a:extLst>
+              </p:cNvPr>
+              <p:cNvSpPr txBox="1"/>
+              <p:nvPr/>
+            </p:nvSpPr>
+            <p:spPr>
+              <a:xfrm>
+                <a:off x="306876" y="3784066"/>
+                <a:ext cx="3307799" cy="276999"/>
+              </a:xfrm>
+              <a:prstGeom prst="rect">
+                <a:avLst/>
+              </a:prstGeom>
+              <a:solidFill>
+                <a:schemeClr val="accent1">
+                  <a:lumMod val="40000"/>
+                  <a:lumOff val="60000"/>
+                </a:schemeClr>
+              </a:solidFill>
+              <a:ln w="12700">
+                <a:noFill/>
+              </a:ln>
+            </p:spPr>
+            <p:txBody>
+              <a:bodyPr wrap="square">
+                <a:spAutoFit/>
+              </a:bodyPr>
+              <a:lstStyle>
+                <a:defPPr>
+                  <a:defRPr lang="de-DE"/>
+                </a:defPPr>
+                <a:lvl1pPr algn="ctr">
+                  <a:defRPr sz="1200"/>
+                </a:lvl1pPr>
+              </a:lstStyle>
+              <a:p>
+                <a:r>
+                  <a:rPr lang="en-GB" noProof="0" dirty="0">
+                    <a:latin typeface="Calibri" panose="020F0502020204030204" pitchFamily="34" charset="0"/>
+                    <a:ea typeface="Cambria Math" panose="02040503050406030204" pitchFamily="18" charset="0"/>
+                    <a:cs typeface="Calibri" panose="020F0502020204030204" pitchFamily="34" charset="0"/>
+                  </a:rPr>
+                  <a:t>non-parametric tests </a:t>
+                </a:r>
+              </a:p>
+            </p:txBody>
+          </p:sp>
+          <p:sp>
+            <p:nvSpPr>
+              <p:cNvPr id="2" name="Textfeld 1">
+                <a:extLst>
+                  <a:ext uri="{FF2B5EF4-FFF2-40B4-BE49-F238E27FC236}">
+                    <a16:creationId xmlns:a16="http://schemas.microsoft.com/office/drawing/2014/main" id="{6285C5ED-B7D7-2B67-2F5E-385146328EA9}"/>
+                  </a:ext>
+                </a:extLst>
+              </p:cNvPr>
+              <p:cNvSpPr txBox="1"/>
+              <p:nvPr/>
+            </p:nvSpPr>
+            <p:spPr>
+              <a:xfrm>
+                <a:off x="393079" y="1855690"/>
+                <a:ext cx="1579378" cy="276999"/>
+              </a:xfrm>
+              <a:prstGeom prst="rect">
+                <a:avLst/>
+              </a:prstGeom>
+              <a:solidFill>
+                <a:schemeClr val="accent1">
+                  <a:lumMod val="40000"/>
+                  <a:lumOff val="60000"/>
+                </a:schemeClr>
+              </a:solidFill>
+              <a:ln w="12700">
+                <a:noFill/>
+              </a:ln>
+            </p:spPr>
+            <p:txBody>
+              <a:bodyPr wrap="square">
+                <a:spAutoFit/>
+              </a:bodyPr>
+              <a:lstStyle>
+                <a:defPPr>
+                  <a:defRPr lang="de-DE"/>
+                </a:defPPr>
+                <a:lvl1pPr algn="ctr">
+                  <a:defRPr sz="1200"/>
+                </a:lvl1pPr>
+              </a:lstStyle>
+              <a:p>
+                <a:r>
+                  <a:rPr lang="en-GB" noProof="0" dirty="0">
+                    <a:latin typeface="Calibri" panose="020F0502020204030204" pitchFamily="34" charset="0"/>
+                    <a:ea typeface="Cambria Math" panose="02040503050406030204" pitchFamily="18" charset="0"/>
+                    <a:cs typeface="Calibri" panose="020F0502020204030204" pitchFamily="34" charset="0"/>
+                  </a:rPr>
+                  <a:t>non-parametric tests </a:t>
+                </a:r>
+              </a:p>
+            </p:txBody>
+          </p:sp>
+          <p:grpSp>
+            <p:nvGrpSpPr>
+              <p:cNvPr id="17" name="Gruppieren 16">
+                <a:extLst>
+                  <a:ext uri="{FF2B5EF4-FFF2-40B4-BE49-F238E27FC236}">
+                    <a16:creationId xmlns:a16="http://schemas.microsoft.com/office/drawing/2014/main" id="{49E3860B-75F4-C4C4-AE3F-0A16B448FAFA}"/>
+                  </a:ext>
+                </a:extLst>
+              </p:cNvPr>
+              <p:cNvGrpSpPr/>
+              <p:nvPr/>
+            </p:nvGrpSpPr>
+            <p:grpSpPr>
+              <a:xfrm>
+                <a:off x="1022643" y="4084526"/>
+                <a:ext cx="1795871" cy="944792"/>
+                <a:chOff x="3378041" y="2876116"/>
+                <a:chExt cx="1795871" cy="542165"/>
+              </a:xfrm>
+            </p:grpSpPr>
+            <p:cxnSp>
+              <p:nvCxnSpPr>
+                <p:cNvPr id="19" name="Gerade Verbindung mit Pfeil 18">
+                  <a:extLst>
+                    <a:ext uri="{FF2B5EF4-FFF2-40B4-BE49-F238E27FC236}">
+                      <a16:creationId xmlns:a16="http://schemas.microsoft.com/office/drawing/2014/main" id="{60F08B0A-977D-7CB0-17A2-D4CD2DBF5777}"/>
+                    </a:ext>
+                  </a:extLst>
+                </p:cNvPr>
+                <p:cNvCxnSpPr>
+                  <a:cxnSpLocks/>
+                </p:cNvCxnSpPr>
+                <p:nvPr/>
+              </p:nvCxnSpPr>
+              <p:spPr>
+                <a:xfrm flipH="1">
+                  <a:off x="3378041" y="2876116"/>
+                  <a:ext cx="890897" cy="542165"/>
+                </a:xfrm>
+                <a:prstGeom prst="straightConnector1">
+                  <a:avLst/>
+                </a:prstGeom>
+                <a:ln>
+                  <a:solidFill>
+                    <a:schemeClr val="accent1"/>
+                  </a:solidFill>
+                  <a:tailEnd type="triangle"/>
+                </a:ln>
+              </p:spPr>
+              <p:style>
+                <a:lnRef idx="1">
+                  <a:schemeClr val="accent1"/>
+                </a:lnRef>
+                <a:fillRef idx="0">
+                  <a:schemeClr val="accent1"/>
+                </a:fillRef>
+                <a:effectRef idx="0">
+                  <a:schemeClr val="accent1"/>
+                </a:effectRef>
+                <a:fontRef idx="minor">
+                  <a:schemeClr val="tx1"/>
+                </a:fontRef>
+              </p:style>
+            </p:cxnSp>
+            <p:cxnSp>
+              <p:nvCxnSpPr>
+                <p:cNvPr id="20" name="Gerade Verbindung mit Pfeil 19">
+                  <a:extLst>
+                    <a:ext uri="{FF2B5EF4-FFF2-40B4-BE49-F238E27FC236}">
+                      <a16:creationId xmlns:a16="http://schemas.microsoft.com/office/drawing/2014/main" id="{F087514A-1F40-95F2-0C1F-FF7F386CA727}"/>
+                    </a:ext>
+                  </a:extLst>
+                </p:cNvPr>
+                <p:cNvCxnSpPr>
+                  <a:cxnSpLocks/>
+                </p:cNvCxnSpPr>
+                <p:nvPr/>
+              </p:nvCxnSpPr>
+              <p:spPr>
+                <a:xfrm>
+                  <a:off x="4268938" y="2876116"/>
+                  <a:ext cx="904974" cy="542165"/>
+                </a:xfrm>
+                <a:prstGeom prst="straightConnector1">
+                  <a:avLst/>
+                </a:prstGeom>
+                <a:ln>
+                  <a:solidFill>
+                    <a:schemeClr val="accent1"/>
+                  </a:solidFill>
+                  <a:tailEnd type="triangle"/>
+                </a:ln>
+              </p:spPr>
+              <p:style>
+                <a:lnRef idx="1">
+                  <a:schemeClr val="accent1"/>
+                </a:lnRef>
+                <a:fillRef idx="0">
+                  <a:schemeClr val="accent1"/>
+                </a:fillRef>
+                <a:effectRef idx="0">
+                  <a:schemeClr val="accent1"/>
+                </a:effectRef>
+                <a:fontRef idx="minor">
+                  <a:schemeClr val="tx1"/>
+                </a:fontRef>
+              </p:style>
+            </p:cxnSp>
+          </p:grpSp>
+        </p:grpSp>
+        <p:cxnSp>
+          <p:nvCxnSpPr>
+            <p:cNvPr id="11" name="Gerade Verbindung mit Pfeil 10">
+              <a:extLst>
+                <a:ext uri="{FF2B5EF4-FFF2-40B4-BE49-F238E27FC236}">
+                  <a16:creationId xmlns:a16="http://schemas.microsoft.com/office/drawing/2014/main" id="{3E3D73A8-70F2-3F30-8F8E-59464648DBD0}"/>
+                </a:ext>
+              </a:extLst>
+            </p:cNvPr>
+            <p:cNvCxnSpPr>
+              <a:cxnSpLocks/>
+              <a:stCxn id="18" idx="2"/>
+            </p:cNvCxnSpPr>
+            <p:nvPr/>
+          </p:nvCxnSpPr>
+          <p:spPr>
+            <a:xfrm flipH="1">
+              <a:off x="3442874" y="3610011"/>
+              <a:ext cx="3996032" cy="524364"/>
+            </a:xfrm>
+            <a:prstGeom prst="straightConnector1">
+              <a:avLst/>
+            </a:prstGeom>
+            <a:ln>
+              <a:tailEnd type="triangle"/>
+            </a:ln>
+          </p:spPr>
+          <p:style>
+            <a:lnRef idx="1">
+              <a:schemeClr val="accent1"/>
+            </a:lnRef>
+            <a:fillRef idx="0">
+              <a:schemeClr val="accent1"/>
+            </a:fillRef>
+            <a:effectRef idx="0">
+              <a:schemeClr val="accent1"/>
+            </a:effectRef>
+            <a:fontRef idx="minor">
+              <a:schemeClr val="tx1"/>
+            </a:fontRef>
+          </p:style>
+        </p:cxnSp>
+        <p:cxnSp>
+          <p:nvCxnSpPr>
+            <p:cNvPr id="13" name="Gerade Verbindung mit Pfeil 12">
+              <a:extLst>
+                <a:ext uri="{FF2B5EF4-FFF2-40B4-BE49-F238E27FC236}">
+                  <a16:creationId xmlns:a16="http://schemas.microsoft.com/office/drawing/2014/main" id="{421B2C4E-E553-C4F1-DB70-85D57C5FAA01}"/>
+                </a:ext>
+              </a:extLst>
+            </p:cNvPr>
+            <p:cNvCxnSpPr>
+              <a:cxnSpLocks/>
+              <a:endCxn id="88" idx="0"/>
+            </p:cNvCxnSpPr>
+            <p:nvPr/>
+          </p:nvCxnSpPr>
+          <p:spPr>
+            <a:xfrm>
+              <a:off x="6271256" y="2486905"/>
+              <a:ext cx="1167650" cy="431412"/>
+            </a:xfrm>
+            <a:prstGeom prst="straightConnector1">
+              <a:avLst/>
+            </a:prstGeom>
+            <a:ln>
+              <a:tailEnd type="triangle"/>
+            </a:ln>
+          </p:spPr>
+          <p:style>
+            <a:lnRef idx="1">
+              <a:schemeClr val="accent1"/>
+            </a:lnRef>
+            <a:fillRef idx="0">
+              <a:schemeClr val="accent1"/>
+            </a:fillRef>
+            <a:effectRef idx="0">
+              <a:schemeClr val="accent1"/>
+            </a:effectRef>
+            <a:fontRef idx="minor">
+              <a:schemeClr val="tx1"/>
+            </a:fontRef>
+          </p:style>
+        </p:cxnSp>
+      </p:grpSp>
+      <p:cxnSp>
+        <p:nvCxnSpPr>
+          <p:cNvPr id="499" name="Gerade Verbindung mit Pfeil 498">
+            <a:extLst>
+              <a:ext uri="{FF2B5EF4-FFF2-40B4-BE49-F238E27FC236}">
+                <a16:creationId xmlns:a16="http://schemas.microsoft.com/office/drawing/2014/main" id="{445627F6-EB0A-B9FB-1E9C-3533B733C304}"/>
+              </a:ext>
+            </a:extLst>
+          </p:cNvPr>
+          <p:cNvCxnSpPr>
+            <a:cxnSpLocks/>
+          </p:cNvCxnSpPr>
+          <p:nvPr/>
+        </p:nvCxnSpPr>
+        <p:spPr>
+          <a:xfrm>
+            <a:off x="1672857" y="3698487"/>
+            <a:ext cx="0" cy="493567"/>
+          </a:xfrm>
+          <a:prstGeom prst="straightConnector1">
+            <a:avLst/>
+          </a:prstGeom>
+          <a:ln>
+            <a:solidFill>
+              <a:schemeClr val="accent1"/>
+            </a:solidFill>
+            <a:tailEnd type="triangle"/>
+          </a:ln>
+        </p:spPr>
+        <p:style>
+          <a:lnRef idx="1">
+            <a:schemeClr val="accent1"/>
+          </a:lnRef>
+          <a:fillRef idx="0">
+            <a:schemeClr val="accent1"/>
+          </a:fillRef>
+          <a:effectRef idx="0">
+            <a:schemeClr val="accent1"/>
+          </a:effectRef>
+          <a:fontRef idx="minor">
+            <a:schemeClr val="tx1"/>
+          </a:fontRef>
+        </p:style>
+      </p:cxnSp>
+    </p:spTree>
+    <p:extLst>
+      <p:ext uri="{BB962C8B-B14F-4D97-AF65-F5344CB8AC3E}">
+        <p14:creationId xmlns:p14="http://schemas.microsoft.com/office/powerpoint/2010/main" val="3004504650"/>
+      </p:ext>
+    </p:extLst>
+  </p:cSld>
+  <p:clrMapOvr>
+    <a:masterClrMapping/>
+  </p:clrMapOvr>
+</p:sld>
+</file>
+
+<file path=ppt/slides/slide3.xml><?xml version="1.0" encoding="utf-8"?>
 <p:sld xmlns:a="http://schemas.openxmlformats.org/drawingml/2006/main" xmlns:r="http://schemas.openxmlformats.org/officeDocument/2006/relationships" xmlns:p="http://schemas.openxmlformats.org/presentationml/2006/main">
   <p:cSld>
     <p:spTree>
@@ -12741,7 +16572,7 @@
 </p:sld>
 </file>
 
-<file path=ppt/slides/slide3.xml><?xml version="1.0" encoding="utf-8"?>
+<file path=ppt/slides/slide4.xml><?xml version="1.0" encoding="utf-8"?>
 <p:sld xmlns:a="http://schemas.openxmlformats.org/drawingml/2006/main" xmlns:r="http://schemas.openxmlformats.org/officeDocument/2006/relationships" xmlns:p="http://schemas.openxmlformats.org/presentationml/2006/main">
   <p:cSld>
     <p:spTree>
@@ -16834,7 +20665,7 @@
 </p:sld>
 </file>
 
-<file path=ppt/slides/slide4.xml><?xml version="1.0" encoding="utf-8"?>
+<file path=ppt/slides/slide5.xml><?xml version="1.0" encoding="utf-8"?>
 <p:sld xmlns:a="http://schemas.openxmlformats.org/drawingml/2006/main" xmlns:r="http://schemas.openxmlformats.org/officeDocument/2006/relationships" xmlns:p="http://schemas.openxmlformats.org/presentationml/2006/main">
   <p:cSld>
     <p:spTree>
@@ -21029,7 +24860,7 @@
 </p:sld>
 </file>
 
-<file path=ppt/slides/slide5.xml><?xml version="1.0" encoding="utf-8"?>
+<file path=ppt/slides/slide6.xml><?xml version="1.0" encoding="utf-8"?>
 <p:sld xmlns:a="http://schemas.openxmlformats.org/drawingml/2006/main" xmlns:r="http://schemas.openxmlformats.org/officeDocument/2006/relationships" xmlns:p="http://schemas.openxmlformats.org/presentationml/2006/main">
   <p:cSld>
     <p:spTree>
@@ -25549,7 +29380,7 @@
 </p:sld>
 </file>
 
-<file path=ppt/slides/slide6.xml><?xml version="1.0" encoding="utf-8"?>
+<file path=ppt/slides/slide7.xml><?xml version="1.0" encoding="utf-8"?>
 <p:sld xmlns:a="http://schemas.openxmlformats.org/drawingml/2006/main" xmlns:r="http://schemas.openxmlformats.org/officeDocument/2006/relationships" xmlns:p="http://schemas.openxmlformats.org/presentationml/2006/main">
   <p:cSld>
     <p:spTree>
@@ -29831,7 +33662,7 @@
 </p:sld>
 </file>
 
-<file path=ppt/slides/slide7.xml><?xml version="1.0" encoding="utf-8"?>
+<file path=ppt/slides/slide8.xml><?xml version="1.0" encoding="utf-8"?>
 <p:sld xmlns:a="http://schemas.openxmlformats.org/drawingml/2006/main" xmlns:r="http://schemas.openxmlformats.org/officeDocument/2006/relationships" xmlns:p="http://schemas.openxmlformats.org/presentationml/2006/main">
   <p:cSld>
     <p:spTree>

</xml_diff>